<commit_message>
Inclui o link do quadro no README e na apresentação
Co-Authored-By: Claude Opus 5.5 <noreply@anthropic.com>
Claude-Session: https://claude.ai/code/session_01AxsLnikbU4P6aghAswDkjm
</commit_message>
<xml_diff>
--- a/docs/apresentacao-checkpoint-4-6.pptx
+++ b/docs/apresentacao-checkpoint-4-6.pptx
@@ -3118,7 +3118,7 @@
                 <a:ea typeface="Calibri" pitchFamily="34" charset="-122"/>
                 <a:cs typeface="Calibri" pitchFamily="34" charset="-120"/>
               </a:rPr>
-              <a:t>Issues #1 a #14 e Projects do repositório (aba Projects)</a:t>
+              <a:t>Issues #1 a #14 · quadro em github.com/users/davi-cassiano/projects/1</a:t>
             </a:r>
             <a:endParaRPr lang="en-US" sz="1200" dirty="0"/>
           </a:p>
@@ -20559,7 +20559,24 @@
                 <a:ea typeface="Calibri" pitchFamily="34" charset="-122"/>
                 <a:cs typeface="Calibri" pitchFamily="34" charset="-120"/>
               </a:rPr>
-              <a:t>Issues #1 a #14 e quadro na aba Projects</a:t>
+              <a:t>Issues #1 a #14 · quadro em</a:t>
+            </a:r>
+            <a:endParaRPr lang="en-US" sz="1100" dirty="0"/>
+          </a:p>
+          <a:p>
+            <a:pPr indent="0" marL="0">
+              <a:buNone/>
+            </a:pPr>
+            <a:r>
+              <a:rPr lang="en-US" sz="1100" dirty="0">
+                <a:solidFill>
+                  <a:srgbClr val="CFE0EC"/>
+                </a:solidFill>
+                <a:latin typeface="Calibri" pitchFamily="34" charset="0"/>
+                <a:ea typeface="Calibri" pitchFamily="34" charset="-122"/>
+                <a:cs typeface="Calibri" pitchFamily="34" charset="-120"/>
+              </a:rPr>
+              <a:t>github.com/users/davi-cassiano/projects/1</a:t>
             </a:r>
             <a:endParaRPr lang="en-US" sz="1100" dirty="0"/>
           </a:p>

</xml_diff>

<commit_message>
Registra o Planning Poker e atualiza estimativas
US09 revista de 3 para 5 pontos; backlog com 58 pontos.

Co-Authored-By: Claude Opus 5.5 <noreply@anthropic.com>
Claude-Session: https://claude.ai/code/session_01AxsLnikbU4P6aghAswDkjm
</commit_message>
<xml_diff>
--- a/docs/apresentacao-checkpoint-4-6.pptx
+++ b/docs/apresentacao-checkpoint-4-6.pptx
@@ -265,7 +265,7 @@
                   <c:v>3</c:v>
                 </c:pt>
                 <c:pt idx="8">
-                  <c:v>3</c:v>
+                  <c:v>5</c:v>
                 </c:pt>
                 <c:pt idx="9">
                   <c:v>5</c:v>
@@ -1432,7 +1432,7 @@
           <a:p>
             <a:r>
               <a:rPr lang="en-US" dirty="0"/>
-              <a:t>Contar como foi o Planning Poker: onde houve divergência e por quê. Os pontos do gráfico são os que o grupo fechou.</a:t>
+              <a:t>US04: o 3 via só ordenar; o 8 lembrou de quebrar em dias com teto e janela → 5. US09: reabrir planejamento antigo com base alterada → 5, com aviso em vez de reconciliar. US11: 13 pela incerteza; baseline já medido fechou em 8. US12: empate 8/13; escopo limitado a vizinho mais próximo + 2-opt para caber em 8.</a:t>
             </a:r>
             <a:endParaRPr lang="en-US" dirty="0"/>
           </a:p>
@@ -13125,7 +13125,7 @@
                 <a:ea typeface="Cambria" pitchFamily="34" charset="-122"/>
                 <a:cs typeface="Cambria" pitchFamily="34" charset="-120"/>
               </a:rPr>
-              <a:t>56 pontos</a:t>
+              <a:t>58 pontos</a:t>
             </a:r>
             <a:endParaRPr lang="en-US" sz="2200" dirty="0"/>
           </a:p>
@@ -13230,7 +13230,7 @@
                 <a:ea typeface="Calibri" pitchFamily="34" charset="-122"/>
                 <a:cs typeface="Calibri" pitchFamily="34" charset="-120"/>
               </a:rPr>
-              <a:t>A velocidade da Sprint 1 é hipótese: o grupo concilia o projeto com outras disciplinas. Ela é recalibrada no fim da sprint.</a:t>
+              <a:t>Divergências revotadas: US04 (3 a 8) · US09 (3 a 8, subiu para 5) · US11 (5 a 13) · US12 (8 e 13, escopo reduzido). Velocidade recalibrada ao fim da sprint.</a:t>
             </a:r>
             <a:endParaRPr lang="en-US" sz="1200" dirty="0"/>
           </a:p>
@@ -26844,7 +26844,7 @@
                           <a:ea typeface="Calibri" pitchFamily="34" charset="-122"/>
                           <a:cs typeface="Calibri" pitchFamily="34" charset="-120"/>
                         </a:rPr>
-                        <a:t>3</a:t>
+                        <a:t>5</a:t>
                       </a:r>
                       <a:endParaRPr lang="en-US" sz="1050" dirty="0">
                         <a:latin typeface="Calibri" charset="0"/>
@@ -28643,7 +28643,7 @@
                 <a:ea typeface="Calibri" pitchFamily="34" charset="-122"/>
                 <a:cs typeface="Calibri" pitchFamily="34" charset="-120"/>
               </a:rPr>
-              <a:t>Pontos: proposta de partida, revisada no Planning Poker do grupo. Onda 1: 40 pontos · Onda 2: 16 pontos.</a:t>
+              <a:t>Pontos fechados no Planning Poker. Onda 1: 42 pontos · Onda 2: 16 pontos · total 58.</a:t>
             </a:r>
             <a:endParaRPr lang="en-US" sz="1050" dirty="0"/>
           </a:p>

</xml_diff>

<commit_message>
Atualiza a apresentação com o resultado da revisão do PR
Co-Authored-By: Claude Opus 5.5 <noreply@anthropic.com>
Claude-Session: https://claude.ai/code/session_01AxsLnikbU4P6aghAswDkjm
</commit_message>
<xml_diff>
--- a/docs/apresentacao-checkpoint-4-6.pptx
+++ b/docs/apresentacao-checkpoint-4-6.pptx
@@ -8537,7 +8537,7 @@
                 <a:ea typeface="Cambria" pitchFamily="34" charset="-122"/>
                 <a:cs typeface="Cambria" pitchFamily="34" charset="-120"/>
               </a:rPr>
-              <a:t>22</a:t>
+              <a:t>23</a:t>
             </a:r>
             <a:endParaRPr lang="en-US" sz="3000" dirty="0"/>
           </a:p>
@@ -10174,7 +10174,7 @@
                 <a:ea typeface="Calibri" pitchFamily="34" charset="-122"/>
                 <a:cs typeface="Calibri" pitchFamily="34" charset="-120"/>
               </a:rPr>
-              <a:t>Revisão do PR feita por integrante do grupo, com os comentários respondidos e resolvidos antes do merge.</a:t>
+              <a:t>Revisão do Davi, 3 comentários: preço fixo no código (corrigido) · corte temporal (testado) · regra dos 30 km (virou a Issue #16).</a:t>
             </a:r>
             <a:endParaRPr lang="en-US" sz="1200" dirty="0"/>
           </a:p>
@@ -19025,13 +19025,13 @@
                       <a:r>
                         <a:rPr lang="en-US" sz="1150" b="1" dirty="0">
                           <a:solidFill>
-                            <a:srgbClr val="9A5B12"/>
+                            <a:srgbClr val="0E7C66"/>
                           </a:solidFill>
                           <a:latin typeface="Calibri" pitchFamily="34" charset="0"/>
                           <a:ea typeface="Calibri" pitchFamily="34" charset="-122"/>
                           <a:cs typeface="Calibri" pitchFamily="34" charset="-120"/>
                         </a:rPr>
-                        <a:t>Em revisão</a:t>
+                        <a:t>Entregue</a:t>
                       </a:r>
                       <a:endParaRPr lang="en-US" sz="1150" dirty="0">
                         <a:latin typeface="Calibri" charset="0"/>
@@ -21324,7 +21324,7 @@
                 <a:ea typeface="Calibri" pitchFamily="34" charset="-122"/>
                 <a:cs typeface="Calibri" pitchFamily="34" charset="-120"/>
               </a:rPr>
-              <a:t>ingest, features, train e serve, SOLID, 22 testes, pull request #15</a:t>
+              <a:t>ingest, features, train e serve, SOLID, 23 testes, pull request #15</a:t>
             </a:r>
             <a:endParaRPr lang="en-US" sz="1200" dirty="0"/>
           </a:p>

</xml_diff>

<commit_message>
Define os responsáveis pelos riscos e pela Sprint 1
Co-Authored-By: Claude Opus 5.5 <noreply@anthropic.com>
Claude-Session: https://claude.ai/code/session_01AxsLnikbU4P6aghAswDkjm
</commit_message>
<xml_diff>
--- a/docs/apresentacao-checkpoint-4-6.pptx
+++ b/docs/apresentacao-checkpoint-4-6.pptx
@@ -13440,19 +13440,20 @@
         </p:nvGraphicFramePr>
         <p:xfrm>
           <a:off x="548640" y="1554480"/>
-          <a:ext cx="7406640" cy="914400"/>
+          <a:ext cx="7772400" cy="914400"/>
         </p:xfrm>
         <a:graphic>
           <a:graphicData uri="http://schemas.openxmlformats.org/drawingml/2006/table">
             <a:tbl>
               <a:tblPr/>
               <a:tblGrid>
-                <a:gridCol w="525633"/>
-                <a:gridCol w="3344934"/>
-                <a:gridCol w="860126"/>
-                <a:gridCol w="812341"/>
-                <a:gridCol w="812341"/>
-                <a:gridCol w="1051265"/>
+                <a:gridCol w="476834"/>
+                <a:gridCol w="3147107"/>
+                <a:gridCol w="810618"/>
+                <a:gridCol w="762935"/>
+                <a:gridCol w="810618"/>
+                <a:gridCol w="905985"/>
+                <a:gridCol w="858302"/>
               </a:tblGrid>
               <a:tr h="475488">
                 <a:tc>
@@ -13813,6 +13814,74 @@
                           <a:cs typeface="Calibri" pitchFamily="34" charset="-120"/>
                         </a:rPr>
                         <a:t>Resposta</a:t>
+                      </a:r>
+                      <a:endParaRPr lang="en-US" sz="1050" dirty="0">
+                        <a:latin typeface="Calibri" charset="0"/>
+                        <a:ea typeface="Calibri" charset="0"/>
+                        <a:cs typeface="Calibri" charset="0"/>
+                      </a:endParaRPr>
+                    </a:p>
+                  </a:txBody>
+                  <a:tcPr marL="91440" marR="91440" marT="45720" marB="45720" anchor="ctr">
+                    <a:lnL w="9525" cap="flat" cmpd="sng" algn="ctr">
+                      <a:solidFill>
+                        <a:srgbClr val="D9E0E8"/>
+                      </a:solidFill>
+                      <a:prstDash val="solid"/>
+                      <a:round/>
+                      <a:headEnd type="none" w="med" len="med"/>
+                      <a:tailEnd type="none" w="med" len="med"/>
+                    </a:lnL>
+                    <a:lnR w="9525" cap="flat" cmpd="sng" algn="ctr">
+                      <a:solidFill>
+                        <a:srgbClr val="D9E0E8"/>
+                      </a:solidFill>
+                      <a:prstDash val="solid"/>
+                      <a:round/>
+                      <a:headEnd type="none" w="med" len="med"/>
+                      <a:tailEnd type="none" w="med" len="med"/>
+                    </a:lnR>
+                    <a:lnT w="9525" cap="flat" cmpd="sng" algn="ctr">
+                      <a:solidFill>
+                        <a:srgbClr val="D9E0E8"/>
+                      </a:solidFill>
+                      <a:prstDash val="solid"/>
+                      <a:round/>
+                      <a:headEnd type="none" w="med" len="med"/>
+                      <a:tailEnd type="none" w="med" len="med"/>
+                    </a:lnT>
+                    <a:lnB w="9525" cap="flat" cmpd="sng" algn="ctr">
+                      <a:solidFill>
+                        <a:srgbClr val="D9E0E8"/>
+                      </a:solidFill>
+                      <a:prstDash val="solid"/>
+                      <a:round/>
+                      <a:headEnd type="none" w="med" len="med"/>
+                      <a:tailEnd type="none" w="med" len="med"/>
+                    </a:lnB>
+                    <a:solidFill>
+                      <a:srgbClr val="12263A"/>
+                    </a:solidFill>
+                  </a:tcPr>
+                </a:tc>
+                <a:tc>
+                  <a:txBody>
+                    <a:bodyPr/>
+                    <a:lstStyle/>
+                    <a:p>
+                      <a:pPr indent="0" marL="0">
+                        <a:buNone/>
+                      </a:pPr>
+                      <a:r>
+                        <a:rPr lang="en-US" sz="1050" b="1" dirty="0">
+                          <a:solidFill>
+                            <a:srgbClr val="FFFFFF"/>
+                          </a:solidFill>
+                          <a:latin typeface="Calibri" pitchFamily="34" charset="0"/>
+                          <a:ea typeface="Calibri" pitchFamily="34" charset="-122"/>
+                          <a:cs typeface="Calibri" pitchFamily="34" charset="-120"/>
+                        </a:rPr>
+                        <a:t>Dono</a:t>
                       </a:r>
                       <a:endParaRPr lang="en-US" sz="1050" dirty="0">
                         <a:latin typeface="Calibri" charset="0"/>
@@ -14273,6 +14342,74 @@
                     </a:solidFill>
                   </a:tcPr>
                 </a:tc>
+                <a:tc>
+                  <a:txBody>
+                    <a:bodyPr/>
+                    <a:lstStyle/>
+                    <a:p>
+                      <a:pPr indent="0" marL="0">
+                        <a:buNone/>
+                      </a:pPr>
+                      <a:r>
+                        <a:rPr lang="en-US" sz="1050" dirty="0">
+                          <a:solidFill>
+                            <a:srgbClr val="5A7185"/>
+                          </a:solidFill>
+                          <a:latin typeface="Calibri" pitchFamily="34" charset="0"/>
+                          <a:ea typeface="Calibri" pitchFamily="34" charset="-122"/>
+                          <a:cs typeface="Calibri" pitchFamily="34" charset="-120"/>
+                        </a:rPr>
+                        <a:t>Gabriel</a:t>
+                      </a:r>
+                      <a:endParaRPr lang="en-US" sz="1050" dirty="0">
+                        <a:latin typeface="Calibri" charset="0"/>
+                        <a:ea typeface="Calibri" charset="0"/>
+                        <a:cs typeface="Calibri" charset="0"/>
+                      </a:endParaRPr>
+                    </a:p>
+                  </a:txBody>
+                  <a:tcPr marL="91440" marR="91440" marT="45720" marB="45720" anchor="ctr">
+                    <a:lnL w="9525" cap="flat" cmpd="sng" algn="ctr">
+                      <a:solidFill>
+                        <a:srgbClr val="D9E0E8"/>
+                      </a:solidFill>
+                      <a:prstDash val="solid"/>
+                      <a:round/>
+                      <a:headEnd type="none" w="med" len="med"/>
+                      <a:tailEnd type="none" w="med" len="med"/>
+                    </a:lnL>
+                    <a:lnR w="9525" cap="flat" cmpd="sng" algn="ctr">
+                      <a:solidFill>
+                        <a:srgbClr val="D9E0E8"/>
+                      </a:solidFill>
+                      <a:prstDash val="solid"/>
+                      <a:round/>
+                      <a:headEnd type="none" w="med" len="med"/>
+                      <a:tailEnd type="none" w="med" len="med"/>
+                    </a:lnR>
+                    <a:lnT w="9525" cap="flat" cmpd="sng" algn="ctr">
+                      <a:solidFill>
+                        <a:srgbClr val="D9E0E8"/>
+                      </a:solidFill>
+                      <a:prstDash val="solid"/>
+                      <a:round/>
+                      <a:headEnd type="none" w="med" len="med"/>
+                      <a:tailEnd type="none" w="med" len="med"/>
+                    </a:lnT>
+                    <a:lnB w="9525" cap="flat" cmpd="sng" algn="ctr">
+                      <a:solidFill>
+                        <a:srgbClr val="D9E0E8"/>
+                      </a:solidFill>
+                      <a:prstDash val="solid"/>
+                      <a:round/>
+                      <a:headEnd type="none" w="med" len="med"/>
+                      <a:tailEnd type="none" w="med" len="med"/>
+                    </a:lnB>
+                    <a:solidFill>
+                      <a:srgbClr val="F4F7FA"/>
+                    </a:solidFill>
+                  </a:tcPr>
+                </a:tc>
               </a:tr>
               <a:tr h="475488">
                 <a:tc>
@@ -14633,6 +14770,74 @@
                           <a:cs typeface="Calibri" pitchFamily="34" charset="-120"/>
                         </a:rPr>
                         <a:t>Mitigar</a:t>
+                      </a:r>
+                      <a:endParaRPr lang="en-US" sz="1050" dirty="0">
+                        <a:latin typeface="Calibri" charset="0"/>
+                        <a:ea typeface="Calibri" charset="0"/>
+                        <a:cs typeface="Calibri" charset="0"/>
+                      </a:endParaRPr>
+                    </a:p>
+                  </a:txBody>
+                  <a:tcPr marL="91440" marR="91440" marT="45720" marB="45720" anchor="ctr">
+                    <a:lnL w="9525" cap="flat" cmpd="sng" algn="ctr">
+                      <a:solidFill>
+                        <a:srgbClr val="D9E0E8"/>
+                      </a:solidFill>
+                      <a:prstDash val="solid"/>
+                      <a:round/>
+                      <a:headEnd type="none" w="med" len="med"/>
+                      <a:tailEnd type="none" w="med" len="med"/>
+                    </a:lnL>
+                    <a:lnR w="9525" cap="flat" cmpd="sng" algn="ctr">
+                      <a:solidFill>
+                        <a:srgbClr val="D9E0E8"/>
+                      </a:solidFill>
+                      <a:prstDash val="solid"/>
+                      <a:round/>
+                      <a:headEnd type="none" w="med" len="med"/>
+                      <a:tailEnd type="none" w="med" len="med"/>
+                    </a:lnR>
+                    <a:lnT w="9525" cap="flat" cmpd="sng" algn="ctr">
+                      <a:solidFill>
+                        <a:srgbClr val="D9E0E8"/>
+                      </a:solidFill>
+                      <a:prstDash val="solid"/>
+                      <a:round/>
+                      <a:headEnd type="none" w="med" len="med"/>
+                      <a:tailEnd type="none" w="med" len="med"/>
+                    </a:lnT>
+                    <a:lnB w="9525" cap="flat" cmpd="sng" algn="ctr">
+                      <a:solidFill>
+                        <a:srgbClr val="D9E0E8"/>
+                      </a:solidFill>
+                      <a:prstDash val="solid"/>
+                      <a:round/>
+                      <a:headEnd type="none" w="med" len="med"/>
+                      <a:tailEnd type="none" w="med" len="med"/>
+                    </a:lnB>
+                    <a:solidFill>
+                      <a:srgbClr val="FFFFFF"/>
+                    </a:solidFill>
+                  </a:tcPr>
+                </a:tc>
+                <a:tc>
+                  <a:txBody>
+                    <a:bodyPr/>
+                    <a:lstStyle/>
+                    <a:p>
+                      <a:pPr indent="0" marL="0">
+                        <a:buNone/>
+                      </a:pPr>
+                      <a:r>
+                        <a:rPr lang="en-US" sz="1050" dirty="0">
+                          <a:solidFill>
+                            <a:srgbClr val="5A7185"/>
+                          </a:solidFill>
+                          <a:latin typeface="Calibri" pitchFamily="34" charset="0"/>
+                          <a:ea typeface="Calibri" pitchFamily="34" charset="-122"/>
+                          <a:cs typeface="Calibri" pitchFamily="34" charset="-120"/>
+                        </a:rPr>
+                        <a:t>Luca</a:t>
                       </a:r>
                       <a:endParaRPr lang="en-US" sz="1050" dirty="0">
                         <a:latin typeface="Calibri" charset="0"/>
@@ -15093,6 +15298,74 @@
                     </a:solidFill>
                   </a:tcPr>
                 </a:tc>
+                <a:tc>
+                  <a:txBody>
+                    <a:bodyPr/>
+                    <a:lstStyle/>
+                    <a:p>
+                      <a:pPr indent="0" marL="0">
+                        <a:buNone/>
+                      </a:pPr>
+                      <a:r>
+                        <a:rPr lang="en-US" sz="1050" dirty="0">
+                          <a:solidFill>
+                            <a:srgbClr val="5A7185"/>
+                          </a:solidFill>
+                          <a:latin typeface="Calibri" pitchFamily="34" charset="0"/>
+                          <a:ea typeface="Calibri" pitchFamily="34" charset="-122"/>
+                          <a:cs typeface="Calibri" pitchFamily="34" charset="-120"/>
+                        </a:rPr>
+                        <a:t>Victor</a:t>
+                      </a:r>
+                      <a:endParaRPr lang="en-US" sz="1050" dirty="0">
+                        <a:latin typeface="Calibri" charset="0"/>
+                        <a:ea typeface="Calibri" charset="0"/>
+                        <a:cs typeface="Calibri" charset="0"/>
+                      </a:endParaRPr>
+                    </a:p>
+                  </a:txBody>
+                  <a:tcPr marL="91440" marR="91440" marT="45720" marB="45720" anchor="ctr">
+                    <a:lnL w="9525" cap="flat" cmpd="sng" algn="ctr">
+                      <a:solidFill>
+                        <a:srgbClr val="D9E0E8"/>
+                      </a:solidFill>
+                      <a:prstDash val="solid"/>
+                      <a:round/>
+                      <a:headEnd type="none" w="med" len="med"/>
+                      <a:tailEnd type="none" w="med" len="med"/>
+                    </a:lnL>
+                    <a:lnR w="9525" cap="flat" cmpd="sng" algn="ctr">
+                      <a:solidFill>
+                        <a:srgbClr val="D9E0E8"/>
+                      </a:solidFill>
+                      <a:prstDash val="solid"/>
+                      <a:round/>
+                      <a:headEnd type="none" w="med" len="med"/>
+                      <a:tailEnd type="none" w="med" len="med"/>
+                    </a:lnR>
+                    <a:lnT w="9525" cap="flat" cmpd="sng" algn="ctr">
+                      <a:solidFill>
+                        <a:srgbClr val="D9E0E8"/>
+                      </a:solidFill>
+                      <a:prstDash val="solid"/>
+                      <a:round/>
+                      <a:headEnd type="none" w="med" len="med"/>
+                      <a:tailEnd type="none" w="med" len="med"/>
+                    </a:lnT>
+                    <a:lnB w="9525" cap="flat" cmpd="sng" algn="ctr">
+                      <a:solidFill>
+                        <a:srgbClr val="D9E0E8"/>
+                      </a:solidFill>
+                      <a:prstDash val="solid"/>
+                      <a:round/>
+                      <a:headEnd type="none" w="med" len="med"/>
+                      <a:tailEnd type="none" w="med" len="med"/>
+                    </a:lnB>
+                    <a:solidFill>
+                      <a:srgbClr val="F4F7FA"/>
+                    </a:solidFill>
+                  </a:tcPr>
+                </a:tc>
               </a:tr>
               <a:tr h="475488">
                 <a:tc>
@@ -15453,6 +15726,74 @@
                           <a:cs typeface="Calibri" pitchFamily="34" charset="-120"/>
                         </a:rPr>
                         <a:t>Mitigar</a:t>
+                      </a:r>
+                      <a:endParaRPr lang="en-US" sz="1050" dirty="0">
+                        <a:latin typeface="Calibri" charset="0"/>
+                        <a:ea typeface="Calibri" charset="0"/>
+                        <a:cs typeface="Calibri" charset="0"/>
+                      </a:endParaRPr>
+                    </a:p>
+                  </a:txBody>
+                  <a:tcPr marL="91440" marR="91440" marT="45720" marB="45720" anchor="ctr">
+                    <a:lnL w="9525" cap="flat" cmpd="sng" algn="ctr">
+                      <a:solidFill>
+                        <a:srgbClr val="D9E0E8"/>
+                      </a:solidFill>
+                      <a:prstDash val="solid"/>
+                      <a:round/>
+                      <a:headEnd type="none" w="med" len="med"/>
+                      <a:tailEnd type="none" w="med" len="med"/>
+                    </a:lnL>
+                    <a:lnR w="9525" cap="flat" cmpd="sng" algn="ctr">
+                      <a:solidFill>
+                        <a:srgbClr val="D9E0E8"/>
+                      </a:solidFill>
+                      <a:prstDash val="solid"/>
+                      <a:round/>
+                      <a:headEnd type="none" w="med" len="med"/>
+                      <a:tailEnd type="none" w="med" len="med"/>
+                    </a:lnR>
+                    <a:lnT w="9525" cap="flat" cmpd="sng" algn="ctr">
+                      <a:solidFill>
+                        <a:srgbClr val="D9E0E8"/>
+                      </a:solidFill>
+                      <a:prstDash val="solid"/>
+                      <a:round/>
+                      <a:headEnd type="none" w="med" len="med"/>
+                      <a:tailEnd type="none" w="med" len="med"/>
+                    </a:lnT>
+                    <a:lnB w="9525" cap="flat" cmpd="sng" algn="ctr">
+                      <a:solidFill>
+                        <a:srgbClr val="D9E0E8"/>
+                      </a:solidFill>
+                      <a:prstDash val="solid"/>
+                      <a:round/>
+                      <a:headEnd type="none" w="med" len="med"/>
+                      <a:tailEnd type="none" w="med" len="med"/>
+                    </a:lnB>
+                    <a:solidFill>
+                      <a:srgbClr val="FFFFFF"/>
+                    </a:solidFill>
+                  </a:tcPr>
+                </a:tc>
+                <a:tc>
+                  <a:txBody>
+                    <a:bodyPr/>
+                    <a:lstStyle/>
+                    <a:p>
+                      <a:pPr indent="0" marL="0">
+                        <a:buNone/>
+                      </a:pPr>
+                      <a:r>
+                        <a:rPr lang="en-US" sz="1050" dirty="0">
+                          <a:solidFill>
+                            <a:srgbClr val="5A7185"/>
+                          </a:solidFill>
+                          <a:latin typeface="Calibri" pitchFamily="34" charset="0"/>
+                          <a:ea typeface="Calibri" pitchFamily="34" charset="-122"/>
+                          <a:cs typeface="Calibri" pitchFamily="34" charset="-120"/>
+                        </a:rPr>
+                        <a:t>Luca</a:t>
                       </a:r>
                       <a:endParaRPr lang="en-US" sz="1050" dirty="0">
                         <a:latin typeface="Calibri" charset="0"/>
@@ -15913,6 +16254,74 @@
                     </a:solidFill>
                   </a:tcPr>
                 </a:tc>
+                <a:tc>
+                  <a:txBody>
+                    <a:bodyPr/>
+                    <a:lstStyle/>
+                    <a:p>
+                      <a:pPr indent="0" marL="0">
+                        <a:buNone/>
+                      </a:pPr>
+                      <a:r>
+                        <a:rPr lang="en-US" sz="1050" dirty="0">
+                          <a:solidFill>
+                            <a:srgbClr val="5A7185"/>
+                          </a:solidFill>
+                          <a:latin typeface="Calibri" pitchFamily="34" charset="0"/>
+                          <a:ea typeface="Calibri" pitchFamily="34" charset="-122"/>
+                          <a:cs typeface="Calibri" pitchFamily="34" charset="-120"/>
+                        </a:rPr>
+                        <a:t>Victor</a:t>
+                      </a:r>
+                      <a:endParaRPr lang="en-US" sz="1050" dirty="0">
+                        <a:latin typeface="Calibri" charset="0"/>
+                        <a:ea typeface="Calibri" charset="0"/>
+                        <a:cs typeface="Calibri" charset="0"/>
+                      </a:endParaRPr>
+                    </a:p>
+                  </a:txBody>
+                  <a:tcPr marL="91440" marR="91440" marT="45720" marB="45720" anchor="ctr">
+                    <a:lnL w="9525" cap="flat" cmpd="sng" algn="ctr">
+                      <a:solidFill>
+                        <a:srgbClr val="D9E0E8"/>
+                      </a:solidFill>
+                      <a:prstDash val="solid"/>
+                      <a:round/>
+                      <a:headEnd type="none" w="med" len="med"/>
+                      <a:tailEnd type="none" w="med" len="med"/>
+                    </a:lnL>
+                    <a:lnR w="9525" cap="flat" cmpd="sng" algn="ctr">
+                      <a:solidFill>
+                        <a:srgbClr val="D9E0E8"/>
+                      </a:solidFill>
+                      <a:prstDash val="solid"/>
+                      <a:round/>
+                      <a:headEnd type="none" w="med" len="med"/>
+                      <a:tailEnd type="none" w="med" len="med"/>
+                    </a:lnR>
+                    <a:lnT w="9525" cap="flat" cmpd="sng" algn="ctr">
+                      <a:solidFill>
+                        <a:srgbClr val="D9E0E8"/>
+                      </a:solidFill>
+                      <a:prstDash val="solid"/>
+                      <a:round/>
+                      <a:headEnd type="none" w="med" len="med"/>
+                      <a:tailEnd type="none" w="med" len="med"/>
+                    </a:lnT>
+                    <a:lnB w="9525" cap="flat" cmpd="sng" algn="ctr">
+                      <a:solidFill>
+                        <a:srgbClr val="D9E0E8"/>
+                      </a:solidFill>
+                      <a:prstDash val="solid"/>
+                      <a:round/>
+                      <a:headEnd type="none" w="med" len="med"/>
+                      <a:tailEnd type="none" w="med" len="med"/>
+                    </a:lnB>
+                    <a:solidFill>
+                      <a:srgbClr val="F4F7FA"/>
+                    </a:solidFill>
+                  </a:tcPr>
+                </a:tc>
               </a:tr>
               <a:tr h="475488">
                 <a:tc>
@@ -16273,6 +16682,74 @@
                           <a:cs typeface="Calibri" pitchFamily="34" charset="-120"/>
                         </a:rPr>
                         <a:t>Mitigar</a:t>
+                      </a:r>
+                      <a:endParaRPr lang="en-US" sz="1050" dirty="0">
+                        <a:latin typeface="Calibri" charset="0"/>
+                        <a:ea typeface="Calibri" charset="0"/>
+                        <a:cs typeface="Calibri" charset="0"/>
+                      </a:endParaRPr>
+                    </a:p>
+                  </a:txBody>
+                  <a:tcPr marL="91440" marR="91440" marT="45720" marB="45720" anchor="ctr">
+                    <a:lnL w="9525" cap="flat" cmpd="sng" algn="ctr">
+                      <a:solidFill>
+                        <a:srgbClr val="D9E0E8"/>
+                      </a:solidFill>
+                      <a:prstDash val="solid"/>
+                      <a:round/>
+                      <a:headEnd type="none" w="med" len="med"/>
+                      <a:tailEnd type="none" w="med" len="med"/>
+                    </a:lnL>
+                    <a:lnR w="9525" cap="flat" cmpd="sng" algn="ctr">
+                      <a:solidFill>
+                        <a:srgbClr val="D9E0E8"/>
+                      </a:solidFill>
+                      <a:prstDash val="solid"/>
+                      <a:round/>
+                      <a:headEnd type="none" w="med" len="med"/>
+                      <a:tailEnd type="none" w="med" len="med"/>
+                    </a:lnR>
+                    <a:lnT w="9525" cap="flat" cmpd="sng" algn="ctr">
+                      <a:solidFill>
+                        <a:srgbClr val="D9E0E8"/>
+                      </a:solidFill>
+                      <a:prstDash val="solid"/>
+                      <a:round/>
+                      <a:headEnd type="none" w="med" len="med"/>
+                      <a:tailEnd type="none" w="med" len="med"/>
+                    </a:lnT>
+                    <a:lnB w="9525" cap="flat" cmpd="sng" algn="ctr">
+                      <a:solidFill>
+                        <a:srgbClr val="D9E0E8"/>
+                      </a:solidFill>
+                      <a:prstDash val="solid"/>
+                      <a:round/>
+                      <a:headEnd type="none" w="med" len="med"/>
+                      <a:tailEnd type="none" w="med" len="med"/>
+                    </a:lnB>
+                    <a:solidFill>
+                      <a:srgbClr val="FFFFFF"/>
+                    </a:solidFill>
+                  </a:tcPr>
+                </a:tc>
+                <a:tc>
+                  <a:txBody>
+                    <a:bodyPr/>
+                    <a:lstStyle/>
+                    <a:p>
+                      <a:pPr indent="0" marL="0">
+                        <a:buNone/>
+                      </a:pPr>
+                      <a:r>
+                        <a:rPr lang="en-US" sz="1050" dirty="0">
+                          <a:solidFill>
+                            <a:srgbClr val="5A7185"/>
+                          </a:solidFill>
+                          <a:latin typeface="Calibri" pitchFamily="34" charset="0"/>
+                          <a:ea typeface="Calibri" pitchFamily="34" charset="-122"/>
+                          <a:cs typeface="Calibri" pitchFamily="34" charset="-120"/>
+                        </a:rPr>
+                        <a:t>Davi</a:t>
                       </a:r>
                       <a:endParaRPr lang="en-US" sz="1050" dirty="0">
                         <a:latin typeface="Calibri" charset="0"/>
@@ -16733,6 +17210,74 @@
                     </a:solidFill>
                   </a:tcPr>
                 </a:tc>
+                <a:tc>
+                  <a:txBody>
+                    <a:bodyPr/>
+                    <a:lstStyle/>
+                    <a:p>
+                      <a:pPr indent="0" marL="0">
+                        <a:buNone/>
+                      </a:pPr>
+                      <a:r>
+                        <a:rPr lang="en-US" sz="1050" dirty="0">
+                          <a:solidFill>
+                            <a:srgbClr val="5A7185"/>
+                          </a:solidFill>
+                          <a:latin typeface="Calibri" pitchFamily="34" charset="0"/>
+                          <a:ea typeface="Calibri" pitchFamily="34" charset="-122"/>
+                          <a:cs typeface="Calibri" pitchFamily="34" charset="-120"/>
+                        </a:rPr>
+                        <a:t>Gabriel</a:t>
+                      </a:r>
+                      <a:endParaRPr lang="en-US" sz="1050" dirty="0">
+                        <a:latin typeface="Calibri" charset="0"/>
+                        <a:ea typeface="Calibri" charset="0"/>
+                        <a:cs typeface="Calibri" charset="0"/>
+                      </a:endParaRPr>
+                    </a:p>
+                  </a:txBody>
+                  <a:tcPr marL="91440" marR="91440" marT="45720" marB="45720" anchor="ctr">
+                    <a:lnL w="9525" cap="flat" cmpd="sng" algn="ctr">
+                      <a:solidFill>
+                        <a:srgbClr val="D9E0E8"/>
+                      </a:solidFill>
+                      <a:prstDash val="solid"/>
+                      <a:round/>
+                      <a:headEnd type="none" w="med" len="med"/>
+                      <a:tailEnd type="none" w="med" len="med"/>
+                    </a:lnL>
+                    <a:lnR w="9525" cap="flat" cmpd="sng" algn="ctr">
+                      <a:solidFill>
+                        <a:srgbClr val="D9E0E8"/>
+                      </a:solidFill>
+                      <a:prstDash val="solid"/>
+                      <a:round/>
+                      <a:headEnd type="none" w="med" len="med"/>
+                      <a:tailEnd type="none" w="med" len="med"/>
+                    </a:lnR>
+                    <a:lnT w="9525" cap="flat" cmpd="sng" algn="ctr">
+                      <a:solidFill>
+                        <a:srgbClr val="D9E0E8"/>
+                      </a:solidFill>
+                      <a:prstDash val="solid"/>
+                      <a:round/>
+                      <a:headEnd type="none" w="med" len="med"/>
+                      <a:tailEnd type="none" w="med" len="med"/>
+                    </a:lnT>
+                    <a:lnB w="9525" cap="flat" cmpd="sng" algn="ctr">
+                      <a:solidFill>
+                        <a:srgbClr val="D9E0E8"/>
+                      </a:solidFill>
+                      <a:prstDash val="solid"/>
+                      <a:round/>
+                      <a:headEnd type="none" w="med" len="med"/>
+                      <a:tailEnd type="none" w="med" len="med"/>
+                    </a:lnB>
+                    <a:solidFill>
+                      <a:srgbClr val="F4F7FA"/>
+                    </a:solidFill>
+                  </a:tcPr>
+                </a:tc>
               </a:tr>
             </a:tbl>
           </a:graphicData>
@@ -16746,7 +17291,7 @@
         </p:nvSpPr>
         <p:spPr>
           <a:xfrm>
-            <a:off x="9006840" y="1965960"/>
+            <a:off x="9144000" y="1965960"/>
             <a:ext cx="822960" cy="822960"/>
           </a:xfrm>
           <a:prstGeom prst="rect">
@@ -16771,7 +17316,7 @@
         </p:nvSpPr>
         <p:spPr>
           <a:xfrm>
-            <a:off x="9875520" y="1965960"/>
+            <a:off x="10012680" y="1965960"/>
             <a:ext cx="822960" cy="822960"/>
           </a:xfrm>
           <a:prstGeom prst="rect">
@@ -16796,7 +17341,7 @@
         </p:nvSpPr>
         <p:spPr>
           <a:xfrm>
-            <a:off x="9875520" y="2240280"/>
+            <a:off x="10012680" y="2240280"/>
             <a:ext cx="822960" cy="274320"/>
           </a:xfrm>
           <a:prstGeom prst="rect">
@@ -16835,7 +17380,7 @@
         </p:nvSpPr>
         <p:spPr>
           <a:xfrm>
-            <a:off x="10744200" y="1965960"/>
+            <a:off x="10881360" y="1965960"/>
             <a:ext cx="822960" cy="822960"/>
           </a:xfrm>
           <a:prstGeom prst="rect">
@@ -16860,7 +17405,7 @@
         </p:nvSpPr>
         <p:spPr>
           <a:xfrm>
-            <a:off x="10744200" y="2240280"/>
+            <a:off x="10881360" y="2240280"/>
             <a:ext cx="822960" cy="274320"/>
           </a:xfrm>
           <a:prstGeom prst="rect">
@@ -16899,7 +17444,7 @@
         </p:nvSpPr>
         <p:spPr>
           <a:xfrm>
-            <a:off x="9006840" y="2834640"/>
+            <a:off x="9144000" y="2834640"/>
             <a:ext cx="822960" cy="822960"/>
           </a:xfrm>
           <a:prstGeom prst="rect">
@@ -16924,7 +17469,7 @@
         </p:nvSpPr>
         <p:spPr>
           <a:xfrm>
-            <a:off x="9875520" y="2834640"/>
+            <a:off x="10012680" y="2834640"/>
             <a:ext cx="822960" cy="822960"/>
           </a:xfrm>
           <a:prstGeom prst="rect">
@@ -16949,7 +17494,7 @@
         </p:nvSpPr>
         <p:spPr>
           <a:xfrm>
-            <a:off x="9875520" y="3108960"/>
+            <a:off x="10012680" y="3108960"/>
             <a:ext cx="822960" cy="274320"/>
           </a:xfrm>
           <a:prstGeom prst="rect">
@@ -16988,7 +17533,7 @@
         </p:nvSpPr>
         <p:spPr>
           <a:xfrm>
-            <a:off x="10744200" y="2834640"/>
+            <a:off x="10881360" y="2834640"/>
             <a:ext cx="822960" cy="822960"/>
           </a:xfrm>
           <a:prstGeom prst="rect">
@@ -17013,7 +17558,7 @@
         </p:nvSpPr>
         <p:spPr>
           <a:xfrm>
-            <a:off x="10744200" y="3108960"/>
+            <a:off x="10881360" y="3108960"/>
             <a:ext cx="822960" cy="274320"/>
           </a:xfrm>
           <a:prstGeom prst="rect">
@@ -17052,7 +17597,7 @@
         </p:nvSpPr>
         <p:spPr>
           <a:xfrm>
-            <a:off x="9006840" y="3703320"/>
+            <a:off x="9144000" y="3703320"/>
             <a:ext cx="822960" cy="822960"/>
           </a:xfrm>
           <a:prstGeom prst="rect">
@@ -17077,7 +17622,7 @@
         </p:nvSpPr>
         <p:spPr>
           <a:xfrm>
-            <a:off x="9875520" y="3703320"/>
+            <a:off x="10012680" y="3703320"/>
             <a:ext cx="822960" cy="822960"/>
           </a:xfrm>
           <a:prstGeom prst="rect">
@@ -17102,7 +17647,7 @@
         </p:nvSpPr>
         <p:spPr>
           <a:xfrm>
-            <a:off x="10744200" y="3703320"/>
+            <a:off x="10881360" y="3703320"/>
             <a:ext cx="822960" cy="822960"/>
           </a:xfrm>
           <a:prstGeom prst="rect">
@@ -17127,7 +17672,7 @@
         </p:nvSpPr>
         <p:spPr>
           <a:xfrm>
-            <a:off x="10744200" y="3977640"/>
+            <a:off x="10881360" y="3977640"/>
             <a:ext cx="822960" cy="274320"/>
           </a:xfrm>
           <a:prstGeom prst="rect">
@@ -17166,7 +17711,7 @@
         </p:nvSpPr>
         <p:spPr>
           <a:xfrm>
-            <a:off x="8321040" y="2267712"/>
+            <a:off x="8458200" y="2267712"/>
             <a:ext cx="640080" cy="228600"/>
           </a:xfrm>
           <a:prstGeom prst="rect">
@@ -17205,7 +17750,7 @@
         </p:nvSpPr>
         <p:spPr>
           <a:xfrm>
-            <a:off x="8321040" y="3136392"/>
+            <a:off x="8458200" y="3136392"/>
             <a:ext cx="640080" cy="228600"/>
           </a:xfrm>
           <a:prstGeom prst="rect">
@@ -17244,7 +17789,7 @@
         </p:nvSpPr>
         <p:spPr>
           <a:xfrm>
-            <a:off x="8321040" y="4005072"/>
+            <a:off x="8458200" y="4005072"/>
             <a:ext cx="640080" cy="228600"/>
           </a:xfrm>
           <a:prstGeom prst="rect">
@@ -17283,7 +17828,7 @@
         </p:nvSpPr>
         <p:spPr>
           <a:xfrm>
-            <a:off x="9006840" y="4599432"/>
+            <a:off x="9144000" y="4599432"/>
             <a:ext cx="822960" cy="228600"/>
           </a:xfrm>
           <a:prstGeom prst="rect">
@@ -17322,7 +17867,7 @@
         </p:nvSpPr>
         <p:spPr>
           <a:xfrm>
-            <a:off x="9875520" y="4599432"/>
+            <a:off x="10012680" y="4599432"/>
             <a:ext cx="822960" cy="228600"/>
           </a:xfrm>
           <a:prstGeom prst="rect">
@@ -17361,7 +17906,7 @@
         </p:nvSpPr>
         <p:spPr>
           <a:xfrm>
-            <a:off x="10744200" y="4599432"/>
+            <a:off x="10881360" y="4599432"/>
             <a:ext cx="822960" cy="228600"/>
           </a:xfrm>
           <a:prstGeom prst="rect">
@@ -17400,7 +17945,7 @@
         </p:nvSpPr>
         <p:spPr>
           <a:xfrm>
-            <a:off x="9006840" y="1645920"/>
+            <a:off x="9144000" y="1645920"/>
             <a:ext cx="2651760" cy="228600"/>
           </a:xfrm>
           <a:prstGeom prst="rect">
@@ -17491,7 +18036,7 @@
                 <a:ea typeface="Calibri" pitchFamily="34" charset="-122"/>
                 <a:cs typeface="Calibri" pitchFamily="34" charset="-120"/>
               </a:rPr>
-              <a:t>Responsáveis: R1 a R7 com um dono cada no docs/planejamento.md. Matriz revisada a cada sprint (pacote 7.3).</a:t>
+              <a:t>Cada um é dono dos riscos da sua frente: Gabriel (agências), Luca (modelo), Victor (negócio e rota), Davi (prazo). Revisão a cada sprint.</a:t>
             </a:r>
             <a:endParaRPr lang="en-US" sz="1200" dirty="0"/>
           </a:p>
@@ -17708,10 +18253,11 @@
             <a:tbl>
               <a:tblPr/>
               <a:tblGrid>
-                <a:gridCol w="3291840"/>
-                <a:gridCol w="822960"/>
-                <a:gridCol w="1554480"/>
-                <a:gridCol w="1280160"/>
+                <a:gridCol w="2902931"/>
+                <a:gridCol w="791708"/>
+                <a:gridCol w="1319514"/>
+                <a:gridCol w="879676"/>
+                <a:gridCol w="1055611"/>
               </a:tblGrid>
               <a:tr h="475488">
                 <a:tc>
@@ -17868,6 +18414,74 @@
                           <a:cs typeface="Calibri" pitchFamily="34" charset="-120"/>
                         </a:rPr>
                         <a:t>Pacotes da WBS</a:t>
+                      </a:r>
+                      <a:endParaRPr lang="en-US" sz="1150" dirty="0">
+                        <a:latin typeface="Calibri" charset="0"/>
+                        <a:ea typeface="Calibri" charset="0"/>
+                        <a:cs typeface="Calibri" charset="0"/>
+                      </a:endParaRPr>
+                    </a:p>
+                  </a:txBody>
+                  <a:tcPr marL="91440" marR="91440" marT="45720" marB="45720" anchor="ctr">
+                    <a:lnL w="9525" cap="flat" cmpd="sng" algn="ctr">
+                      <a:solidFill>
+                        <a:srgbClr val="D9E0E8"/>
+                      </a:solidFill>
+                      <a:prstDash val="solid"/>
+                      <a:round/>
+                      <a:headEnd type="none" w="med" len="med"/>
+                      <a:tailEnd type="none" w="med" len="med"/>
+                    </a:lnL>
+                    <a:lnR w="9525" cap="flat" cmpd="sng" algn="ctr">
+                      <a:solidFill>
+                        <a:srgbClr val="D9E0E8"/>
+                      </a:solidFill>
+                      <a:prstDash val="solid"/>
+                      <a:round/>
+                      <a:headEnd type="none" w="med" len="med"/>
+                      <a:tailEnd type="none" w="med" len="med"/>
+                    </a:lnR>
+                    <a:lnT w="9525" cap="flat" cmpd="sng" algn="ctr">
+                      <a:solidFill>
+                        <a:srgbClr val="D9E0E8"/>
+                      </a:solidFill>
+                      <a:prstDash val="solid"/>
+                      <a:round/>
+                      <a:headEnd type="none" w="med" len="med"/>
+                      <a:tailEnd type="none" w="med" len="med"/>
+                    </a:lnT>
+                    <a:lnB w="9525" cap="flat" cmpd="sng" algn="ctr">
+                      <a:solidFill>
+                        <a:srgbClr val="D9E0E8"/>
+                      </a:solidFill>
+                      <a:prstDash val="solid"/>
+                      <a:round/>
+                      <a:headEnd type="none" w="med" len="med"/>
+                      <a:tailEnd type="none" w="med" len="med"/>
+                    </a:lnB>
+                    <a:solidFill>
+                      <a:srgbClr val="12263A"/>
+                    </a:solidFill>
+                  </a:tcPr>
+                </a:tc>
+                <a:tc>
+                  <a:txBody>
+                    <a:bodyPr/>
+                    <a:lstStyle/>
+                    <a:p>
+                      <a:pPr indent="0" marL="0">
+                        <a:buNone/>
+                      </a:pPr>
+                      <a:r>
+                        <a:rPr lang="en-US" sz="1150" b="1" dirty="0">
+                          <a:solidFill>
+                            <a:srgbClr val="FFFFFF"/>
+                          </a:solidFill>
+                          <a:latin typeface="Calibri" pitchFamily="34" charset="0"/>
+                          <a:ea typeface="Calibri" pitchFamily="34" charset="-122"/>
+                          <a:cs typeface="Calibri" pitchFamily="34" charset="-120"/>
+                        </a:rPr>
+                        <a:t>Dono</a:t>
                       </a:r>
                       <a:endParaRPr lang="en-US" sz="1150" dirty="0">
                         <a:latin typeface="Calibri" charset="0"/>
@@ -18201,6 +18815,74 @@
                         <a:buNone/>
                       </a:pPr>
                       <a:r>
+                        <a:rPr lang="en-US" sz="1150" dirty="0">
+                          <a:solidFill>
+                            <a:srgbClr val="5A7185"/>
+                          </a:solidFill>
+                          <a:latin typeface="Calibri" pitchFamily="34" charset="0"/>
+                          <a:ea typeface="Calibri" pitchFamily="34" charset="-122"/>
+                          <a:cs typeface="Calibri" pitchFamily="34" charset="-120"/>
+                        </a:rPr>
+                        <a:t>Gabriel</a:t>
+                      </a:r>
+                      <a:endParaRPr lang="en-US" sz="1150" dirty="0">
+                        <a:latin typeface="Calibri" charset="0"/>
+                        <a:ea typeface="Calibri" charset="0"/>
+                        <a:cs typeface="Calibri" charset="0"/>
+                      </a:endParaRPr>
+                    </a:p>
+                  </a:txBody>
+                  <a:tcPr marL="91440" marR="91440" marT="45720" marB="45720" anchor="ctr">
+                    <a:lnL w="9525" cap="flat" cmpd="sng" algn="ctr">
+                      <a:solidFill>
+                        <a:srgbClr val="D9E0E8"/>
+                      </a:solidFill>
+                      <a:prstDash val="solid"/>
+                      <a:round/>
+                      <a:headEnd type="none" w="med" len="med"/>
+                      <a:tailEnd type="none" w="med" len="med"/>
+                    </a:lnL>
+                    <a:lnR w="9525" cap="flat" cmpd="sng" algn="ctr">
+                      <a:solidFill>
+                        <a:srgbClr val="D9E0E8"/>
+                      </a:solidFill>
+                      <a:prstDash val="solid"/>
+                      <a:round/>
+                      <a:headEnd type="none" w="med" len="med"/>
+                      <a:tailEnd type="none" w="med" len="med"/>
+                    </a:lnR>
+                    <a:lnT w="9525" cap="flat" cmpd="sng" algn="ctr">
+                      <a:solidFill>
+                        <a:srgbClr val="D9E0E8"/>
+                      </a:solidFill>
+                      <a:prstDash val="solid"/>
+                      <a:round/>
+                      <a:headEnd type="none" w="med" len="med"/>
+                      <a:tailEnd type="none" w="med" len="med"/>
+                    </a:lnT>
+                    <a:lnB w="9525" cap="flat" cmpd="sng" algn="ctr">
+                      <a:solidFill>
+                        <a:srgbClr val="D9E0E8"/>
+                      </a:solidFill>
+                      <a:prstDash val="solid"/>
+                      <a:round/>
+                      <a:headEnd type="none" w="med" len="med"/>
+                      <a:tailEnd type="none" w="med" len="med"/>
+                    </a:lnB>
+                    <a:solidFill>
+                      <a:srgbClr val="F4F7FA"/>
+                    </a:solidFill>
+                  </a:tcPr>
+                </a:tc>
+                <a:tc>
+                  <a:txBody>
+                    <a:bodyPr/>
+                    <a:lstStyle/>
+                    <a:p>
+                      <a:pPr indent="0" marL="0">
+                        <a:buNone/>
+                      </a:pPr>
+                      <a:r>
                         <a:rPr lang="en-US" sz="1150" b="1" dirty="0">
                           <a:solidFill>
                             <a:srgbClr val="0E7C66"/>
@@ -18475,6 +19157,74 @@
                         <a:buNone/>
                       </a:pPr>
                       <a:r>
+                        <a:rPr lang="en-US" sz="1150" dirty="0">
+                          <a:solidFill>
+                            <a:srgbClr val="5A7185"/>
+                          </a:solidFill>
+                          <a:latin typeface="Calibri" pitchFamily="34" charset="0"/>
+                          <a:ea typeface="Calibri" pitchFamily="34" charset="-122"/>
+                          <a:cs typeface="Calibri" pitchFamily="34" charset="-120"/>
+                        </a:rPr>
+                        <a:t>Luca</a:t>
+                      </a:r>
+                      <a:endParaRPr lang="en-US" sz="1150" dirty="0">
+                        <a:latin typeface="Calibri" charset="0"/>
+                        <a:ea typeface="Calibri" charset="0"/>
+                        <a:cs typeface="Calibri" charset="0"/>
+                      </a:endParaRPr>
+                    </a:p>
+                  </a:txBody>
+                  <a:tcPr marL="91440" marR="91440" marT="45720" marB="45720" anchor="ctr">
+                    <a:lnL w="9525" cap="flat" cmpd="sng" algn="ctr">
+                      <a:solidFill>
+                        <a:srgbClr val="D9E0E8"/>
+                      </a:solidFill>
+                      <a:prstDash val="solid"/>
+                      <a:round/>
+                      <a:headEnd type="none" w="med" len="med"/>
+                      <a:tailEnd type="none" w="med" len="med"/>
+                    </a:lnL>
+                    <a:lnR w="9525" cap="flat" cmpd="sng" algn="ctr">
+                      <a:solidFill>
+                        <a:srgbClr val="D9E0E8"/>
+                      </a:solidFill>
+                      <a:prstDash val="solid"/>
+                      <a:round/>
+                      <a:headEnd type="none" w="med" len="med"/>
+                      <a:tailEnd type="none" w="med" len="med"/>
+                    </a:lnR>
+                    <a:lnT w="9525" cap="flat" cmpd="sng" algn="ctr">
+                      <a:solidFill>
+                        <a:srgbClr val="D9E0E8"/>
+                      </a:solidFill>
+                      <a:prstDash val="solid"/>
+                      <a:round/>
+                      <a:headEnd type="none" w="med" len="med"/>
+                      <a:tailEnd type="none" w="med" len="med"/>
+                    </a:lnT>
+                    <a:lnB w="9525" cap="flat" cmpd="sng" algn="ctr">
+                      <a:solidFill>
+                        <a:srgbClr val="D9E0E8"/>
+                      </a:solidFill>
+                      <a:prstDash val="solid"/>
+                      <a:round/>
+                      <a:headEnd type="none" w="med" len="med"/>
+                      <a:tailEnd type="none" w="med" len="med"/>
+                    </a:lnB>
+                    <a:solidFill>
+                      <a:srgbClr val="FFFFFF"/>
+                    </a:solidFill>
+                  </a:tcPr>
+                </a:tc>
+                <a:tc>
+                  <a:txBody>
+                    <a:bodyPr/>
+                    <a:lstStyle/>
+                    <a:p>
+                      <a:pPr indent="0" marL="0">
+                        <a:buNone/>
+                      </a:pPr>
+                      <a:r>
                         <a:rPr lang="en-US" sz="1150" b="1" dirty="0">
                           <a:solidFill>
                             <a:srgbClr val="0E7C66"/>
@@ -18749,6 +19499,74 @@
                         <a:buNone/>
                       </a:pPr>
                       <a:r>
+                        <a:rPr lang="en-US" sz="1150" dirty="0">
+                          <a:solidFill>
+                            <a:srgbClr val="5A7185"/>
+                          </a:solidFill>
+                          <a:latin typeface="Calibri" pitchFamily="34" charset="0"/>
+                          <a:ea typeface="Calibri" pitchFamily="34" charset="-122"/>
+                          <a:cs typeface="Calibri" pitchFamily="34" charset="-120"/>
+                        </a:rPr>
+                        <a:t>Victor</a:t>
+                      </a:r>
+                      <a:endParaRPr lang="en-US" sz="1150" dirty="0">
+                        <a:latin typeface="Calibri" charset="0"/>
+                        <a:ea typeface="Calibri" charset="0"/>
+                        <a:cs typeface="Calibri" charset="0"/>
+                      </a:endParaRPr>
+                    </a:p>
+                  </a:txBody>
+                  <a:tcPr marL="91440" marR="91440" marT="45720" marB="45720" anchor="ctr">
+                    <a:lnL w="9525" cap="flat" cmpd="sng" algn="ctr">
+                      <a:solidFill>
+                        <a:srgbClr val="D9E0E8"/>
+                      </a:solidFill>
+                      <a:prstDash val="solid"/>
+                      <a:round/>
+                      <a:headEnd type="none" w="med" len="med"/>
+                      <a:tailEnd type="none" w="med" len="med"/>
+                    </a:lnL>
+                    <a:lnR w="9525" cap="flat" cmpd="sng" algn="ctr">
+                      <a:solidFill>
+                        <a:srgbClr val="D9E0E8"/>
+                      </a:solidFill>
+                      <a:prstDash val="solid"/>
+                      <a:round/>
+                      <a:headEnd type="none" w="med" len="med"/>
+                      <a:tailEnd type="none" w="med" len="med"/>
+                    </a:lnR>
+                    <a:lnT w="9525" cap="flat" cmpd="sng" algn="ctr">
+                      <a:solidFill>
+                        <a:srgbClr val="D9E0E8"/>
+                      </a:solidFill>
+                      <a:prstDash val="solid"/>
+                      <a:round/>
+                      <a:headEnd type="none" w="med" len="med"/>
+                      <a:tailEnd type="none" w="med" len="med"/>
+                    </a:lnT>
+                    <a:lnB w="9525" cap="flat" cmpd="sng" algn="ctr">
+                      <a:solidFill>
+                        <a:srgbClr val="D9E0E8"/>
+                      </a:solidFill>
+                      <a:prstDash val="solid"/>
+                      <a:round/>
+                      <a:headEnd type="none" w="med" len="med"/>
+                      <a:tailEnd type="none" w="med" len="med"/>
+                    </a:lnB>
+                    <a:solidFill>
+                      <a:srgbClr val="F4F7FA"/>
+                    </a:solidFill>
+                  </a:tcPr>
+                </a:tc>
+                <a:tc>
+                  <a:txBody>
+                    <a:bodyPr/>
+                    <a:lstStyle/>
+                    <a:p>
+                      <a:pPr indent="0" marL="0">
+                        <a:buNone/>
+                      </a:pPr>
+                      <a:r>
                         <a:rPr lang="en-US" sz="1150" b="1" dirty="0">
                           <a:solidFill>
                             <a:srgbClr val="0E7C66"/>
@@ -19023,6 +19841,74 @@
                         <a:buNone/>
                       </a:pPr>
                       <a:r>
+                        <a:rPr lang="en-US" sz="1150" dirty="0">
+                          <a:solidFill>
+                            <a:srgbClr val="5A7185"/>
+                          </a:solidFill>
+                          <a:latin typeface="Calibri" pitchFamily="34" charset="0"/>
+                          <a:ea typeface="Calibri" pitchFamily="34" charset="-122"/>
+                          <a:cs typeface="Calibri" pitchFamily="34" charset="-120"/>
+                        </a:rPr>
+                        <a:t>Davi</a:t>
+                      </a:r>
+                      <a:endParaRPr lang="en-US" sz="1150" dirty="0">
+                        <a:latin typeface="Calibri" charset="0"/>
+                        <a:ea typeface="Calibri" charset="0"/>
+                        <a:cs typeface="Calibri" charset="0"/>
+                      </a:endParaRPr>
+                    </a:p>
+                  </a:txBody>
+                  <a:tcPr marL="91440" marR="91440" marT="45720" marB="45720" anchor="ctr">
+                    <a:lnL w="9525" cap="flat" cmpd="sng" algn="ctr">
+                      <a:solidFill>
+                        <a:srgbClr val="D9E0E8"/>
+                      </a:solidFill>
+                      <a:prstDash val="solid"/>
+                      <a:round/>
+                      <a:headEnd type="none" w="med" len="med"/>
+                      <a:tailEnd type="none" w="med" len="med"/>
+                    </a:lnL>
+                    <a:lnR w="9525" cap="flat" cmpd="sng" algn="ctr">
+                      <a:solidFill>
+                        <a:srgbClr val="D9E0E8"/>
+                      </a:solidFill>
+                      <a:prstDash val="solid"/>
+                      <a:round/>
+                      <a:headEnd type="none" w="med" len="med"/>
+                      <a:tailEnd type="none" w="med" len="med"/>
+                    </a:lnR>
+                    <a:lnT w="9525" cap="flat" cmpd="sng" algn="ctr">
+                      <a:solidFill>
+                        <a:srgbClr val="D9E0E8"/>
+                      </a:solidFill>
+                      <a:prstDash val="solid"/>
+                      <a:round/>
+                      <a:headEnd type="none" w="med" len="med"/>
+                      <a:tailEnd type="none" w="med" len="med"/>
+                    </a:lnT>
+                    <a:lnB w="9525" cap="flat" cmpd="sng" algn="ctr">
+                      <a:solidFill>
+                        <a:srgbClr val="D9E0E8"/>
+                      </a:solidFill>
+                      <a:prstDash val="solid"/>
+                      <a:round/>
+                      <a:headEnd type="none" w="med" len="med"/>
+                      <a:tailEnd type="none" w="med" len="med"/>
+                    </a:lnB>
+                    <a:solidFill>
+                      <a:srgbClr val="FFFFFF"/>
+                    </a:solidFill>
+                  </a:tcPr>
+                </a:tc>
+                <a:tc>
+                  <a:txBody>
+                    <a:bodyPr/>
+                    <a:lstStyle/>
+                    <a:p>
+                      <a:pPr indent="0" marL="0">
+                        <a:buNone/>
+                      </a:pPr>
+                      <a:r>
                         <a:rPr lang="en-US" sz="1150" b="1" dirty="0">
                           <a:solidFill>
                             <a:srgbClr val="0E7C66"/>
@@ -19171,6 +20057,63 @@
                         </a:rPr>
                         <a:t>19 de 20</a:t>
                       </a:r>
+                      <a:endParaRPr lang="en-US" sz="1150" dirty="0">
+                        <a:latin typeface="Calibri" charset="0"/>
+                        <a:ea typeface="Calibri" charset="0"/>
+                        <a:cs typeface="Calibri" charset="0"/>
+                      </a:endParaRPr>
+                    </a:p>
+                  </a:txBody>
+                  <a:tcPr marL="91440" marR="91440" marT="45720" marB="45720" anchor="ctr">
+                    <a:lnL w="9525" cap="flat" cmpd="sng" algn="ctr">
+                      <a:solidFill>
+                        <a:srgbClr val="D9E0E8"/>
+                      </a:solidFill>
+                      <a:prstDash val="solid"/>
+                      <a:round/>
+                      <a:headEnd type="none" w="med" len="med"/>
+                      <a:tailEnd type="none" w="med" len="med"/>
+                    </a:lnL>
+                    <a:lnR w="9525" cap="flat" cmpd="sng" algn="ctr">
+                      <a:solidFill>
+                        <a:srgbClr val="D9E0E8"/>
+                      </a:solidFill>
+                      <a:prstDash val="solid"/>
+                      <a:round/>
+                      <a:headEnd type="none" w="med" len="med"/>
+                      <a:tailEnd type="none" w="med" len="med"/>
+                    </a:lnR>
+                    <a:lnT w="9525" cap="flat" cmpd="sng" algn="ctr">
+                      <a:solidFill>
+                        <a:srgbClr val="D9E0E8"/>
+                      </a:solidFill>
+                      <a:prstDash val="solid"/>
+                      <a:round/>
+                      <a:headEnd type="none" w="med" len="med"/>
+                      <a:tailEnd type="none" w="med" len="med"/>
+                    </a:lnT>
+                    <a:lnB w="9525" cap="flat" cmpd="sng" algn="ctr">
+                      <a:solidFill>
+                        <a:srgbClr val="D9E0E8"/>
+                      </a:solidFill>
+                      <a:prstDash val="solid"/>
+                      <a:round/>
+                      <a:headEnd type="none" w="med" len="med"/>
+                      <a:tailEnd type="none" w="med" len="med"/>
+                    </a:lnB>
+                    <a:solidFill>
+                      <a:srgbClr val="F4F7FA"/>
+                    </a:solidFill>
+                  </a:tcPr>
+                </a:tc>
+                <a:tc>
+                  <a:txBody>
+                    <a:bodyPr/>
+                    <a:lstStyle/>
+                    <a:p>
+                      <a:pPr indent="0" marL="0">
+                        <a:buNone/>
+                      </a:pPr>
                       <a:endParaRPr lang="en-US" sz="1150" dirty="0">
                         <a:latin typeface="Calibri" charset="0"/>
                         <a:ea typeface="Calibri" charset="0"/>

</xml_diff>

<commit_message>
Define os responsáveis pelos riscos e pela Sprint 1 (#17)
Claude-Session: https://claude.ai/code/session_01AxsLnikbU4P6aghAswDkjm

Co-authored-by: Claude <noreply@anthropic.com>
</commit_message>
<xml_diff>
--- a/docs/apresentacao-checkpoint-4-6.pptx
+++ b/docs/apresentacao-checkpoint-4-6.pptx
@@ -13440,19 +13440,20 @@
         </p:nvGraphicFramePr>
         <p:xfrm>
           <a:off x="548640" y="1554480"/>
-          <a:ext cx="7406640" cy="914400"/>
+          <a:ext cx="7772400" cy="914400"/>
         </p:xfrm>
         <a:graphic>
           <a:graphicData uri="http://schemas.openxmlformats.org/drawingml/2006/table">
             <a:tbl>
               <a:tblPr/>
               <a:tblGrid>
-                <a:gridCol w="525633"/>
-                <a:gridCol w="3344934"/>
-                <a:gridCol w="860126"/>
-                <a:gridCol w="812341"/>
-                <a:gridCol w="812341"/>
-                <a:gridCol w="1051265"/>
+                <a:gridCol w="476834"/>
+                <a:gridCol w="3147107"/>
+                <a:gridCol w="810618"/>
+                <a:gridCol w="762935"/>
+                <a:gridCol w="810618"/>
+                <a:gridCol w="905985"/>
+                <a:gridCol w="858302"/>
               </a:tblGrid>
               <a:tr h="475488">
                 <a:tc>
@@ -13813,6 +13814,74 @@
                           <a:cs typeface="Calibri" pitchFamily="34" charset="-120"/>
                         </a:rPr>
                         <a:t>Resposta</a:t>
+                      </a:r>
+                      <a:endParaRPr lang="en-US" sz="1050" dirty="0">
+                        <a:latin typeface="Calibri" charset="0"/>
+                        <a:ea typeface="Calibri" charset="0"/>
+                        <a:cs typeface="Calibri" charset="0"/>
+                      </a:endParaRPr>
+                    </a:p>
+                  </a:txBody>
+                  <a:tcPr marL="91440" marR="91440" marT="45720" marB="45720" anchor="ctr">
+                    <a:lnL w="9525" cap="flat" cmpd="sng" algn="ctr">
+                      <a:solidFill>
+                        <a:srgbClr val="D9E0E8"/>
+                      </a:solidFill>
+                      <a:prstDash val="solid"/>
+                      <a:round/>
+                      <a:headEnd type="none" w="med" len="med"/>
+                      <a:tailEnd type="none" w="med" len="med"/>
+                    </a:lnL>
+                    <a:lnR w="9525" cap="flat" cmpd="sng" algn="ctr">
+                      <a:solidFill>
+                        <a:srgbClr val="D9E0E8"/>
+                      </a:solidFill>
+                      <a:prstDash val="solid"/>
+                      <a:round/>
+                      <a:headEnd type="none" w="med" len="med"/>
+                      <a:tailEnd type="none" w="med" len="med"/>
+                    </a:lnR>
+                    <a:lnT w="9525" cap="flat" cmpd="sng" algn="ctr">
+                      <a:solidFill>
+                        <a:srgbClr val="D9E0E8"/>
+                      </a:solidFill>
+                      <a:prstDash val="solid"/>
+                      <a:round/>
+                      <a:headEnd type="none" w="med" len="med"/>
+                      <a:tailEnd type="none" w="med" len="med"/>
+                    </a:lnT>
+                    <a:lnB w="9525" cap="flat" cmpd="sng" algn="ctr">
+                      <a:solidFill>
+                        <a:srgbClr val="D9E0E8"/>
+                      </a:solidFill>
+                      <a:prstDash val="solid"/>
+                      <a:round/>
+                      <a:headEnd type="none" w="med" len="med"/>
+                      <a:tailEnd type="none" w="med" len="med"/>
+                    </a:lnB>
+                    <a:solidFill>
+                      <a:srgbClr val="12263A"/>
+                    </a:solidFill>
+                  </a:tcPr>
+                </a:tc>
+                <a:tc>
+                  <a:txBody>
+                    <a:bodyPr/>
+                    <a:lstStyle/>
+                    <a:p>
+                      <a:pPr indent="0" marL="0">
+                        <a:buNone/>
+                      </a:pPr>
+                      <a:r>
+                        <a:rPr lang="en-US" sz="1050" b="1" dirty="0">
+                          <a:solidFill>
+                            <a:srgbClr val="FFFFFF"/>
+                          </a:solidFill>
+                          <a:latin typeface="Calibri" pitchFamily="34" charset="0"/>
+                          <a:ea typeface="Calibri" pitchFamily="34" charset="-122"/>
+                          <a:cs typeface="Calibri" pitchFamily="34" charset="-120"/>
+                        </a:rPr>
+                        <a:t>Dono</a:t>
                       </a:r>
                       <a:endParaRPr lang="en-US" sz="1050" dirty="0">
                         <a:latin typeface="Calibri" charset="0"/>
@@ -14273,6 +14342,74 @@
                     </a:solidFill>
                   </a:tcPr>
                 </a:tc>
+                <a:tc>
+                  <a:txBody>
+                    <a:bodyPr/>
+                    <a:lstStyle/>
+                    <a:p>
+                      <a:pPr indent="0" marL="0">
+                        <a:buNone/>
+                      </a:pPr>
+                      <a:r>
+                        <a:rPr lang="en-US" sz="1050" dirty="0">
+                          <a:solidFill>
+                            <a:srgbClr val="5A7185"/>
+                          </a:solidFill>
+                          <a:latin typeface="Calibri" pitchFamily="34" charset="0"/>
+                          <a:ea typeface="Calibri" pitchFamily="34" charset="-122"/>
+                          <a:cs typeface="Calibri" pitchFamily="34" charset="-120"/>
+                        </a:rPr>
+                        <a:t>Gabriel</a:t>
+                      </a:r>
+                      <a:endParaRPr lang="en-US" sz="1050" dirty="0">
+                        <a:latin typeface="Calibri" charset="0"/>
+                        <a:ea typeface="Calibri" charset="0"/>
+                        <a:cs typeface="Calibri" charset="0"/>
+                      </a:endParaRPr>
+                    </a:p>
+                  </a:txBody>
+                  <a:tcPr marL="91440" marR="91440" marT="45720" marB="45720" anchor="ctr">
+                    <a:lnL w="9525" cap="flat" cmpd="sng" algn="ctr">
+                      <a:solidFill>
+                        <a:srgbClr val="D9E0E8"/>
+                      </a:solidFill>
+                      <a:prstDash val="solid"/>
+                      <a:round/>
+                      <a:headEnd type="none" w="med" len="med"/>
+                      <a:tailEnd type="none" w="med" len="med"/>
+                    </a:lnL>
+                    <a:lnR w="9525" cap="flat" cmpd="sng" algn="ctr">
+                      <a:solidFill>
+                        <a:srgbClr val="D9E0E8"/>
+                      </a:solidFill>
+                      <a:prstDash val="solid"/>
+                      <a:round/>
+                      <a:headEnd type="none" w="med" len="med"/>
+                      <a:tailEnd type="none" w="med" len="med"/>
+                    </a:lnR>
+                    <a:lnT w="9525" cap="flat" cmpd="sng" algn="ctr">
+                      <a:solidFill>
+                        <a:srgbClr val="D9E0E8"/>
+                      </a:solidFill>
+                      <a:prstDash val="solid"/>
+                      <a:round/>
+                      <a:headEnd type="none" w="med" len="med"/>
+                      <a:tailEnd type="none" w="med" len="med"/>
+                    </a:lnT>
+                    <a:lnB w="9525" cap="flat" cmpd="sng" algn="ctr">
+                      <a:solidFill>
+                        <a:srgbClr val="D9E0E8"/>
+                      </a:solidFill>
+                      <a:prstDash val="solid"/>
+                      <a:round/>
+                      <a:headEnd type="none" w="med" len="med"/>
+                      <a:tailEnd type="none" w="med" len="med"/>
+                    </a:lnB>
+                    <a:solidFill>
+                      <a:srgbClr val="F4F7FA"/>
+                    </a:solidFill>
+                  </a:tcPr>
+                </a:tc>
               </a:tr>
               <a:tr h="475488">
                 <a:tc>
@@ -14633,6 +14770,74 @@
                           <a:cs typeface="Calibri" pitchFamily="34" charset="-120"/>
                         </a:rPr>
                         <a:t>Mitigar</a:t>
+                      </a:r>
+                      <a:endParaRPr lang="en-US" sz="1050" dirty="0">
+                        <a:latin typeface="Calibri" charset="0"/>
+                        <a:ea typeface="Calibri" charset="0"/>
+                        <a:cs typeface="Calibri" charset="0"/>
+                      </a:endParaRPr>
+                    </a:p>
+                  </a:txBody>
+                  <a:tcPr marL="91440" marR="91440" marT="45720" marB="45720" anchor="ctr">
+                    <a:lnL w="9525" cap="flat" cmpd="sng" algn="ctr">
+                      <a:solidFill>
+                        <a:srgbClr val="D9E0E8"/>
+                      </a:solidFill>
+                      <a:prstDash val="solid"/>
+                      <a:round/>
+                      <a:headEnd type="none" w="med" len="med"/>
+                      <a:tailEnd type="none" w="med" len="med"/>
+                    </a:lnL>
+                    <a:lnR w="9525" cap="flat" cmpd="sng" algn="ctr">
+                      <a:solidFill>
+                        <a:srgbClr val="D9E0E8"/>
+                      </a:solidFill>
+                      <a:prstDash val="solid"/>
+                      <a:round/>
+                      <a:headEnd type="none" w="med" len="med"/>
+                      <a:tailEnd type="none" w="med" len="med"/>
+                    </a:lnR>
+                    <a:lnT w="9525" cap="flat" cmpd="sng" algn="ctr">
+                      <a:solidFill>
+                        <a:srgbClr val="D9E0E8"/>
+                      </a:solidFill>
+                      <a:prstDash val="solid"/>
+                      <a:round/>
+                      <a:headEnd type="none" w="med" len="med"/>
+                      <a:tailEnd type="none" w="med" len="med"/>
+                    </a:lnT>
+                    <a:lnB w="9525" cap="flat" cmpd="sng" algn="ctr">
+                      <a:solidFill>
+                        <a:srgbClr val="D9E0E8"/>
+                      </a:solidFill>
+                      <a:prstDash val="solid"/>
+                      <a:round/>
+                      <a:headEnd type="none" w="med" len="med"/>
+                      <a:tailEnd type="none" w="med" len="med"/>
+                    </a:lnB>
+                    <a:solidFill>
+                      <a:srgbClr val="FFFFFF"/>
+                    </a:solidFill>
+                  </a:tcPr>
+                </a:tc>
+                <a:tc>
+                  <a:txBody>
+                    <a:bodyPr/>
+                    <a:lstStyle/>
+                    <a:p>
+                      <a:pPr indent="0" marL="0">
+                        <a:buNone/>
+                      </a:pPr>
+                      <a:r>
+                        <a:rPr lang="en-US" sz="1050" dirty="0">
+                          <a:solidFill>
+                            <a:srgbClr val="5A7185"/>
+                          </a:solidFill>
+                          <a:latin typeface="Calibri" pitchFamily="34" charset="0"/>
+                          <a:ea typeface="Calibri" pitchFamily="34" charset="-122"/>
+                          <a:cs typeface="Calibri" pitchFamily="34" charset="-120"/>
+                        </a:rPr>
+                        <a:t>Luca</a:t>
                       </a:r>
                       <a:endParaRPr lang="en-US" sz="1050" dirty="0">
                         <a:latin typeface="Calibri" charset="0"/>
@@ -15093,6 +15298,74 @@
                     </a:solidFill>
                   </a:tcPr>
                 </a:tc>
+                <a:tc>
+                  <a:txBody>
+                    <a:bodyPr/>
+                    <a:lstStyle/>
+                    <a:p>
+                      <a:pPr indent="0" marL="0">
+                        <a:buNone/>
+                      </a:pPr>
+                      <a:r>
+                        <a:rPr lang="en-US" sz="1050" dirty="0">
+                          <a:solidFill>
+                            <a:srgbClr val="5A7185"/>
+                          </a:solidFill>
+                          <a:latin typeface="Calibri" pitchFamily="34" charset="0"/>
+                          <a:ea typeface="Calibri" pitchFamily="34" charset="-122"/>
+                          <a:cs typeface="Calibri" pitchFamily="34" charset="-120"/>
+                        </a:rPr>
+                        <a:t>Victor</a:t>
+                      </a:r>
+                      <a:endParaRPr lang="en-US" sz="1050" dirty="0">
+                        <a:latin typeface="Calibri" charset="0"/>
+                        <a:ea typeface="Calibri" charset="0"/>
+                        <a:cs typeface="Calibri" charset="0"/>
+                      </a:endParaRPr>
+                    </a:p>
+                  </a:txBody>
+                  <a:tcPr marL="91440" marR="91440" marT="45720" marB="45720" anchor="ctr">
+                    <a:lnL w="9525" cap="flat" cmpd="sng" algn="ctr">
+                      <a:solidFill>
+                        <a:srgbClr val="D9E0E8"/>
+                      </a:solidFill>
+                      <a:prstDash val="solid"/>
+                      <a:round/>
+                      <a:headEnd type="none" w="med" len="med"/>
+                      <a:tailEnd type="none" w="med" len="med"/>
+                    </a:lnL>
+                    <a:lnR w="9525" cap="flat" cmpd="sng" algn="ctr">
+                      <a:solidFill>
+                        <a:srgbClr val="D9E0E8"/>
+                      </a:solidFill>
+                      <a:prstDash val="solid"/>
+                      <a:round/>
+                      <a:headEnd type="none" w="med" len="med"/>
+                      <a:tailEnd type="none" w="med" len="med"/>
+                    </a:lnR>
+                    <a:lnT w="9525" cap="flat" cmpd="sng" algn="ctr">
+                      <a:solidFill>
+                        <a:srgbClr val="D9E0E8"/>
+                      </a:solidFill>
+                      <a:prstDash val="solid"/>
+                      <a:round/>
+                      <a:headEnd type="none" w="med" len="med"/>
+                      <a:tailEnd type="none" w="med" len="med"/>
+                    </a:lnT>
+                    <a:lnB w="9525" cap="flat" cmpd="sng" algn="ctr">
+                      <a:solidFill>
+                        <a:srgbClr val="D9E0E8"/>
+                      </a:solidFill>
+                      <a:prstDash val="solid"/>
+                      <a:round/>
+                      <a:headEnd type="none" w="med" len="med"/>
+                      <a:tailEnd type="none" w="med" len="med"/>
+                    </a:lnB>
+                    <a:solidFill>
+                      <a:srgbClr val="F4F7FA"/>
+                    </a:solidFill>
+                  </a:tcPr>
+                </a:tc>
               </a:tr>
               <a:tr h="475488">
                 <a:tc>
@@ -15453,6 +15726,74 @@
                           <a:cs typeface="Calibri" pitchFamily="34" charset="-120"/>
                         </a:rPr>
                         <a:t>Mitigar</a:t>
+                      </a:r>
+                      <a:endParaRPr lang="en-US" sz="1050" dirty="0">
+                        <a:latin typeface="Calibri" charset="0"/>
+                        <a:ea typeface="Calibri" charset="0"/>
+                        <a:cs typeface="Calibri" charset="0"/>
+                      </a:endParaRPr>
+                    </a:p>
+                  </a:txBody>
+                  <a:tcPr marL="91440" marR="91440" marT="45720" marB="45720" anchor="ctr">
+                    <a:lnL w="9525" cap="flat" cmpd="sng" algn="ctr">
+                      <a:solidFill>
+                        <a:srgbClr val="D9E0E8"/>
+                      </a:solidFill>
+                      <a:prstDash val="solid"/>
+                      <a:round/>
+                      <a:headEnd type="none" w="med" len="med"/>
+                      <a:tailEnd type="none" w="med" len="med"/>
+                    </a:lnL>
+                    <a:lnR w="9525" cap="flat" cmpd="sng" algn="ctr">
+                      <a:solidFill>
+                        <a:srgbClr val="D9E0E8"/>
+                      </a:solidFill>
+                      <a:prstDash val="solid"/>
+                      <a:round/>
+                      <a:headEnd type="none" w="med" len="med"/>
+                      <a:tailEnd type="none" w="med" len="med"/>
+                    </a:lnR>
+                    <a:lnT w="9525" cap="flat" cmpd="sng" algn="ctr">
+                      <a:solidFill>
+                        <a:srgbClr val="D9E0E8"/>
+                      </a:solidFill>
+                      <a:prstDash val="solid"/>
+                      <a:round/>
+                      <a:headEnd type="none" w="med" len="med"/>
+                      <a:tailEnd type="none" w="med" len="med"/>
+                    </a:lnT>
+                    <a:lnB w="9525" cap="flat" cmpd="sng" algn="ctr">
+                      <a:solidFill>
+                        <a:srgbClr val="D9E0E8"/>
+                      </a:solidFill>
+                      <a:prstDash val="solid"/>
+                      <a:round/>
+                      <a:headEnd type="none" w="med" len="med"/>
+                      <a:tailEnd type="none" w="med" len="med"/>
+                    </a:lnB>
+                    <a:solidFill>
+                      <a:srgbClr val="FFFFFF"/>
+                    </a:solidFill>
+                  </a:tcPr>
+                </a:tc>
+                <a:tc>
+                  <a:txBody>
+                    <a:bodyPr/>
+                    <a:lstStyle/>
+                    <a:p>
+                      <a:pPr indent="0" marL="0">
+                        <a:buNone/>
+                      </a:pPr>
+                      <a:r>
+                        <a:rPr lang="en-US" sz="1050" dirty="0">
+                          <a:solidFill>
+                            <a:srgbClr val="5A7185"/>
+                          </a:solidFill>
+                          <a:latin typeface="Calibri" pitchFamily="34" charset="0"/>
+                          <a:ea typeface="Calibri" pitchFamily="34" charset="-122"/>
+                          <a:cs typeface="Calibri" pitchFamily="34" charset="-120"/>
+                        </a:rPr>
+                        <a:t>Luca</a:t>
                       </a:r>
                       <a:endParaRPr lang="en-US" sz="1050" dirty="0">
                         <a:latin typeface="Calibri" charset="0"/>
@@ -15913,6 +16254,74 @@
                     </a:solidFill>
                   </a:tcPr>
                 </a:tc>
+                <a:tc>
+                  <a:txBody>
+                    <a:bodyPr/>
+                    <a:lstStyle/>
+                    <a:p>
+                      <a:pPr indent="0" marL="0">
+                        <a:buNone/>
+                      </a:pPr>
+                      <a:r>
+                        <a:rPr lang="en-US" sz="1050" dirty="0">
+                          <a:solidFill>
+                            <a:srgbClr val="5A7185"/>
+                          </a:solidFill>
+                          <a:latin typeface="Calibri" pitchFamily="34" charset="0"/>
+                          <a:ea typeface="Calibri" pitchFamily="34" charset="-122"/>
+                          <a:cs typeface="Calibri" pitchFamily="34" charset="-120"/>
+                        </a:rPr>
+                        <a:t>Victor</a:t>
+                      </a:r>
+                      <a:endParaRPr lang="en-US" sz="1050" dirty="0">
+                        <a:latin typeface="Calibri" charset="0"/>
+                        <a:ea typeface="Calibri" charset="0"/>
+                        <a:cs typeface="Calibri" charset="0"/>
+                      </a:endParaRPr>
+                    </a:p>
+                  </a:txBody>
+                  <a:tcPr marL="91440" marR="91440" marT="45720" marB="45720" anchor="ctr">
+                    <a:lnL w="9525" cap="flat" cmpd="sng" algn="ctr">
+                      <a:solidFill>
+                        <a:srgbClr val="D9E0E8"/>
+                      </a:solidFill>
+                      <a:prstDash val="solid"/>
+                      <a:round/>
+                      <a:headEnd type="none" w="med" len="med"/>
+                      <a:tailEnd type="none" w="med" len="med"/>
+                    </a:lnL>
+                    <a:lnR w="9525" cap="flat" cmpd="sng" algn="ctr">
+                      <a:solidFill>
+                        <a:srgbClr val="D9E0E8"/>
+                      </a:solidFill>
+                      <a:prstDash val="solid"/>
+                      <a:round/>
+                      <a:headEnd type="none" w="med" len="med"/>
+                      <a:tailEnd type="none" w="med" len="med"/>
+                    </a:lnR>
+                    <a:lnT w="9525" cap="flat" cmpd="sng" algn="ctr">
+                      <a:solidFill>
+                        <a:srgbClr val="D9E0E8"/>
+                      </a:solidFill>
+                      <a:prstDash val="solid"/>
+                      <a:round/>
+                      <a:headEnd type="none" w="med" len="med"/>
+                      <a:tailEnd type="none" w="med" len="med"/>
+                    </a:lnT>
+                    <a:lnB w="9525" cap="flat" cmpd="sng" algn="ctr">
+                      <a:solidFill>
+                        <a:srgbClr val="D9E0E8"/>
+                      </a:solidFill>
+                      <a:prstDash val="solid"/>
+                      <a:round/>
+                      <a:headEnd type="none" w="med" len="med"/>
+                      <a:tailEnd type="none" w="med" len="med"/>
+                    </a:lnB>
+                    <a:solidFill>
+                      <a:srgbClr val="F4F7FA"/>
+                    </a:solidFill>
+                  </a:tcPr>
+                </a:tc>
               </a:tr>
               <a:tr h="475488">
                 <a:tc>
@@ -16273,6 +16682,74 @@
                           <a:cs typeface="Calibri" pitchFamily="34" charset="-120"/>
                         </a:rPr>
                         <a:t>Mitigar</a:t>
+                      </a:r>
+                      <a:endParaRPr lang="en-US" sz="1050" dirty="0">
+                        <a:latin typeface="Calibri" charset="0"/>
+                        <a:ea typeface="Calibri" charset="0"/>
+                        <a:cs typeface="Calibri" charset="0"/>
+                      </a:endParaRPr>
+                    </a:p>
+                  </a:txBody>
+                  <a:tcPr marL="91440" marR="91440" marT="45720" marB="45720" anchor="ctr">
+                    <a:lnL w="9525" cap="flat" cmpd="sng" algn="ctr">
+                      <a:solidFill>
+                        <a:srgbClr val="D9E0E8"/>
+                      </a:solidFill>
+                      <a:prstDash val="solid"/>
+                      <a:round/>
+                      <a:headEnd type="none" w="med" len="med"/>
+                      <a:tailEnd type="none" w="med" len="med"/>
+                    </a:lnL>
+                    <a:lnR w="9525" cap="flat" cmpd="sng" algn="ctr">
+                      <a:solidFill>
+                        <a:srgbClr val="D9E0E8"/>
+                      </a:solidFill>
+                      <a:prstDash val="solid"/>
+                      <a:round/>
+                      <a:headEnd type="none" w="med" len="med"/>
+                      <a:tailEnd type="none" w="med" len="med"/>
+                    </a:lnR>
+                    <a:lnT w="9525" cap="flat" cmpd="sng" algn="ctr">
+                      <a:solidFill>
+                        <a:srgbClr val="D9E0E8"/>
+                      </a:solidFill>
+                      <a:prstDash val="solid"/>
+                      <a:round/>
+                      <a:headEnd type="none" w="med" len="med"/>
+                      <a:tailEnd type="none" w="med" len="med"/>
+                    </a:lnT>
+                    <a:lnB w="9525" cap="flat" cmpd="sng" algn="ctr">
+                      <a:solidFill>
+                        <a:srgbClr val="D9E0E8"/>
+                      </a:solidFill>
+                      <a:prstDash val="solid"/>
+                      <a:round/>
+                      <a:headEnd type="none" w="med" len="med"/>
+                      <a:tailEnd type="none" w="med" len="med"/>
+                    </a:lnB>
+                    <a:solidFill>
+                      <a:srgbClr val="FFFFFF"/>
+                    </a:solidFill>
+                  </a:tcPr>
+                </a:tc>
+                <a:tc>
+                  <a:txBody>
+                    <a:bodyPr/>
+                    <a:lstStyle/>
+                    <a:p>
+                      <a:pPr indent="0" marL="0">
+                        <a:buNone/>
+                      </a:pPr>
+                      <a:r>
+                        <a:rPr lang="en-US" sz="1050" dirty="0">
+                          <a:solidFill>
+                            <a:srgbClr val="5A7185"/>
+                          </a:solidFill>
+                          <a:latin typeface="Calibri" pitchFamily="34" charset="0"/>
+                          <a:ea typeface="Calibri" pitchFamily="34" charset="-122"/>
+                          <a:cs typeface="Calibri" pitchFamily="34" charset="-120"/>
+                        </a:rPr>
+                        <a:t>Davi</a:t>
                       </a:r>
                       <a:endParaRPr lang="en-US" sz="1050" dirty="0">
                         <a:latin typeface="Calibri" charset="0"/>
@@ -16733,6 +17210,74 @@
                     </a:solidFill>
                   </a:tcPr>
                 </a:tc>
+                <a:tc>
+                  <a:txBody>
+                    <a:bodyPr/>
+                    <a:lstStyle/>
+                    <a:p>
+                      <a:pPr indent="0" marL="0">
+                        <a:buNone/>
+                      </a:pPr>
+                      <a:r>
+                        <a:rPr lang="en-US" sz="1050" dirty="0">
+                          <a:solidFill>
+                            <a:srgbClr val="5A7185"/>
+                          </a:solidFill>
+                          <a:latin typeface="Calibri" pitchFamily="34" charset="0"/>
+                          <a:ea typeface="Calibri" pitchFamily="34" charset="-122"/>
+                          <a:cs typeface="Calibri" pitchFamily="34" charset="-120"/>
+                        </a:rPr>
+                        <a:t>Gabriel</a:t>
+                      </a:r>
+                      <a:endParaRPr lang="en-US" sz="1050" dirty="0">
+                        <a:latin typeface="Calibri" charset="0"/>
+                        <a:ea typeface="Calibri" charset="0"/>
+                        <a:cs typeface="Calibri" charset="0"/>
+                      </a:endParaRPr>
+                    </a:p>
+                  </a:txBody>
+                  <a:tcPr marL="91440" marR="91440" marT="45720" marB="45720" anchor="ctr">
+                    <a:lnL w="9525" cap="flat" cmpd="sng" algn="ctr">
+                      <a:solidFill>
+                        <a:srgbClr val="D9E0E8"/>
+                      </a:solidFill>
+                      <a:prstDash val="solid"/>
+                      <a:round/>
+                      <a:headEnd type="none" w="med" len="med"/>
+                      <a:tailEnd type="none" w="med" len="med"/>
+                    </a:lnL>
+                    <a:lnR w="9525" cap="flat" cmpd="sng" algn="ctr">
+                      <a:solidFill>
+                        <a:srgbClr val="D9E0E8"/>
+                      </a:solidFill>
+                      <a:prstDash val="solid"/>
+                      <a:round/>
+                      <a:headEnd type="none" w="med" len="med"/>
+                      <a:tailEnd type="none" w="med" len="med"/>
+                    </a:lnR>
+                    <a:lnT w="9525" cap="flat" cmpd="sng" algn="ctr">
+                      <a:solidFill>
+                        <a:srgbClr val="D9E0E8"/>
+                      </a:solidFill>
+                      <a:prstDash val="solid"/>
+                      <a:round/>
+                      <a:headEnd type="none" w="med" len="med"/>
+                      <a:tailEnd type="none" w="med" len="med"/>
+                    </a:lnT>
+                    <a:lnB w="9525" cap="flat" cmpd="sng" algn="ctr">
+                      <a:solidFill>
+                        <a:srgbClr val="D9E0E8"/>
+                      </a:solidFill>
+                      <a:prstDash val="solid"/>
+                      <a:round/>
+                      <a:headEnd type="none" w="med" len="med"/>
+                      <a:tailEnd type="none" w="med" len="med"/>
+                    </a:lnB>
+                    <a:solidFill>
+                      <a:srgbClr val="F4F7FA"/>
+                    </a:solidFill>
+                  </a:tcPr>
+                </a:tc>
               </a:tr>
             </a:tbl>
           </a:graphicData>
@@ -16746,7 +17291,7 @@
         </p:nvSpPr>
         <p:spPr>
           <a:xfrm>
-            <a:off x="9006840" y="1965960"/>
+            <a:off x="9144000" y="1965960"/>
             <a:ext cx="822960" cy="822960"/>
           </a:xfrm>
           <a:prstGeom prst="rect">
@@ -16771,7 +17316,7 @@
         </p:nvSpPr>
         <p:spPr>
           <a:xfrm>
-            <a:off x="9875520" y="1965960"/>
+            <a:off x="10012680" y="1965960"/>
             <a:ext cx="822960" cy="822960"/>
           </a:xfrm>
           <a:prstGeom prst="rect">
@@ -16796,7 +17341,7 @@
         </p:nvSpPr>
         <p:spPr>
           <a:xfrm>
-            <a:off x="9875520" y="2240280"/>
+            <a:off x="10012680" y="2240280"/>
             <a:ext cx="822960" cy="274320"/>
           </a:xfrm>
           <a:prstGeom prst="rect">
@@ -16835,7 +17380,7 @@
         </p:nvSpPr>
         <p:spPr>
           <a:xfrm>
-            <a:off x="10744200" y="1965960"/>
+            <a:off x="10881360" y="1965960"/>
             <a:ext cx="822960" cy="822960"/>
           </a:xfrm>
           <a:prstGeom prst="rect">
@@ -16860,7 +17405,7 @@
         </p:nvSpPr>
         <p:spPr>
           <a:xfrm>
-            <a:off x="10744200" y="2240280"/>
+            <a:off x="10881360" y="2240280"/>
             <a:ext cx="822960" cy="274320"/>
           </a:xfrm>
           <a:prstGeom prst="rect">
@@ -16899,7 +17444,7 @@
         </p:nvSpPr>
         <p:spPr>
           <a:xfrm>
-            <a:off x="9006840" y="2834640"/>
+            <a:off x="9144000" y="2834640"/>
             <a:ext cx="822960" cy="822960"/>
           </a:xfrm>
           <a:prstGeom prst="rect">
@@ -16924,7 +17469,7 @@
         </p:nvSpPr>
         <p:spPr>
           <a:xfrm>
-            <a:off x="9875520" y="2834640"/>
+            <a:off x="10012680" y="2834640"/>
             <a:ext cx="822960" cy="822960"/>
           </a:xfrm>
           <a:prstGeom prst="rect">
@@ -16949,7 +17494,7 @@
         </p:nvSpPr>
         <p:spPr>
           <a:xfrm>
-            <a:off x="9875520" y="3108960"/>
+            <a:off x="10012680" y="3108960"/>
             <a:ext cx="822960" cy="274320"/>
           </a:xfrm>
           <a:prstGeom prst="rect">
@@ -16988,7 +17533,7 @@
         </p:nvSpPr>
         <p:spPr>
           <a:xfrm>
-            <a:off x="10744200" y="2834640"/>
+            <a:off x="10881360" y="2834640"/>
             <a:ext cx="822960" cy="822960"/>
           </a:xfrm>
           <a:prstGeom prst="rect">
@@ -17013,7 +17558,7 @@
         </p:nvSpPr>
         <p:spPr>
           <a:xfrm>
-            <a:off x="10744200" y="3108960"/>
+            <a:off x="10881360" y="3108960"/>
             <a:ext cx="822960" cy="274320"/>
           </a:xfrm>
           <a:prstGeom prst="rect">
@@ -17052,7 +17597,7 @@
         </p:nvSpPr>
         <p:spPr>
           <a:xfrm>
-            <a:off x="9006840" y="3703320"/>
+            <a:off x="9144000" y="3703320"/>
             <a:ext cx="822960" cy="822960"/>
           </a:xfrm>
           <a:prstGeom prst="rect">
@@ -17077,7 +17622,7 @@
         </p:nvSpPr>
         <p:spPr>
           <a:xfrm>
-            <a:off x="9875520" y="3703320"/>
+            <a:off x="10012680" y="3703320"/>
             <a:ext cx="822960" cy="822960"/>
           </a:xfrm>
           <a:prstGeom prst="rect">
@@ -17102,7 +17647,7 @@
         </p:nvSpPr>
         <p:spPr>
           <a:xfrm>
-            <a:off x="10744200" y="3703320"/>
+            <a:off x="10881360" y="3703320"/>
             <a:ext cx="822960" cy="822960"/>
           </a:xfrm>
           <a:prstGeom prst="rect">
@@ -17127,7 +17672,7 @@
         </p:nvSpPr>
         <p:spPr>
           <a:xfrm>
-            <a:off x="10744200" y="3977640"/>
+            <a:off x="10881360" y="3977640"/>
             <a:ext cx="822960" cy="274320"/>
           </a:xfrm>
           <a:prstGeom prst="rect">
@@ -17166,7 +17711,7 @@
         </p:nvSpPr>
         <p:spPr>
           <a:xfrm>
-            <a:off x="8321040" y="2267712"/>
+            <a:off x="8458200" y="2267712"/>
             <a:ext cx="640080" cy="228600"/>
           </a:xfrm>
           <a:prstGeom prst="rect">
@@ -17205,7 +17750,7 @@
         </p:nvSpPr>
         <p:spPr>
           <a:xfrm>
-            <a:off x="8321040" y="3136392"/>
+            <a:off x="8458200" y="3136392"/>
             <a:ext cx="640080" cy="228600"/>
           </a:xfrm>
           <a:prstGeom prst="rect">
@@ -17244,7 +17789,7 @@
         </p:nvSpPr>
         <p:spPr>
           <a:xfrm>
-            <a:off x="8321040" y="4005072"/>
+            <a:off x="8458200" y="4005072"/>
             <a:ext cx="640080" cy="228600"/>
           </a:xfrm>
           <a:prstGeom prst="rect">
@@ -17283,7 +17828,7 @@
         </p:nvSpPr>
         <p:spPr>
           <a:xfrm>
-            <a:off x="9006840" y="4599432"/>
+            <a:off x="9144000" y="4599432"/>
             <a:ext cx="822960" cy="228600"/>
           </a:xfrm>
           <a:prstGeom prst="rect">
@@ -17322,7 +17867,7 @@
         </p:nvSpPr>
         <p:spPr>
           <a:xfrm>
-            <a:off x="9875520" y="4599432"/>
+            <a:off x="10012680" y="4599432"/>
             <a:ext cx="822960" cy="228600"/>
           </a:xfrm>
           <a:prstGeom prst="rect">
@@ -17361,7 +17906,7 @@
         </p:nvSpPr>
         <p:spPr>
           <a:xfrm>
-            <a:off x="10744200" y="4599432"/>
+            <a:off x="10881360" y="4599432"/>
             <a:ext cx="822960" cy="228600"/>
           </a:xfrm>
           <a:prstGeom prst="rect">
@@ -17400,7 +17945,7 @@
         </p:nvSpPr>
         <p:spPr>
           <a:xfrm>
-            <a:off x="9006840" y="1645920"/>
+            <a:off x="9144000" y="1645920"/>
             <a:ext cx="2651760" cy="228600"/>
           </a:xfrm>
           <a:prstGeom prst="rect">
@@ -17491,7 +18036,7 @@
                 <a:ea typeface="Calibri" pitchFamily="34" charset="-122"/>
                 <a:cs typeface="Calibri" pitchFamily="34" charset="-120"/>
               </a:rPr>
-              <a:t>Responsáveis: R1 a R7 com um dono cada no docs/planejamento.md. Matriz revisada a cada sprint (pacote 7.3).</a:t>
+              <a:t>Cada um é dono dos riscos da sua frente: Gabriel (agências), Luca (modelo), Victor (negócio e rota), Davi (prazo). Revisão a cada sprint.</a:t>
             </a:r>
             <a:endParaRPr lang="en-US" sz="1200" dirty="0"/>
           </a:p>
@@ -17708,10 +18253,11 @@
             <a:tbl>
               <a:tblPr/>
               <a:tblGrid>
-                <a:gridCol w="3291840"/>
-                <a:gridCol w="822960"/>
-                <a:gridCol w="1554480"/>
-                <a:gridCol w="1280160"/>
+                <a:gridCol w="2902931"/>
+                <a:gridCol w="791708"/>
+                <a:gridCol w="1319514"/>
+                <a:gridCol w="879676"/>
+                <a:gridCol w="1055611"/>
               </a:tblGrid>
               <a:tr h="475488">
                 <a:tc>
@@ -17868,6 +18414,74 @@
                           <a:cs typeface="Calibri" pitchFamily="34" charset="-120"/>
                         </a:rPr>
                         <a:t>Pacotes da WBS</a:t>
+                      </a:r>
+                      <a:endParaRPr lang="en-US" sz="1150" dirty="0">
+                        <a:latin typeface="Calibri" charset="0"/>
+                        <a:ea typeface="Calibri" charset="0"/>
+                        <a:cs typeface="Calibri" charset="0"/>
+                      </a:endParaRPr>
+                    </a:p>
+                  </a:txBody>
+                  <a:tcPr marL="91440" marR="91440" marT="45720" marB="45720" anchor="ctr">
+                    <a:lnL w="9525" cap="flat" cmpd="sng" algn="ctr">
+                      <a:solidFill>
+                        <a:srgbClr val="D9E0E8"/>
+                      </a:solidFill>
+                      <a:prstDash val="solid"/>
+                      <a:round/>
+                      <a:headEnd type="none" w="med" len="med"/>
+                      <a:tailEnd type="none" w="med" len="med"/>
+                    </a:lnL>
+                    <a:lnR w="9525" cap="flat" cmpd="sng" algn="ctr">
+                      <a:solidFill>
+                        <a:srgbClr val="D9E0E8"/>
+                      </a:solidFill>
+                      <a:prstDash val="solid"/>
+                      <a:round/>
+                      <a:headEnd type="none" w="med" len="med"/>
+                      <a:tailEnd type="none" w="med" len="med"/>
+                    </a:lnR>
+                    <a:lnT w="9525" cap="flat" cmpd="sng" algn="ctr">
+                      <a:solidFill>
+                        <a:srgbClr val="D9E0E8"/>
+                      </a:solidFill>
+                      <a:prstDash val="solid"/>
+                      <a:round/>
+                      <a:headEnd type="none" w="med" len="med"/>
+                      <a:tailEnd type="none" w="med" len="med"/>
+                    </a:lnT>
+                    <a:lnB w="9525" cap="flat" cmpd="sng" algn="ctr">
+                      <a:solidFill>
+                        <a:srgbClr val="D9E0E8"/>
+                      </a:solidFill>
+                      <a:prstDash val="solid"/>
+                      <a:round/>
+                      <a:headEnd type="none" w="med" len="med"/>
+                      <a:tailEnd type="none" w="med" len="med"/>
+                    </a:lnB>
+                    <a:solidFill>
+                      <a:srgbClr val="12263A"/>
+                    </a:solidFill>
+                  </a:tcPr>
+                </a:tc>
+                <a:tc>
+                  <a:txBody>
+                    <a:bodyPr/>
+                    <a:lstStyle/>
+                    <a:p>
+                      <a:pPr indent="0" marL="0">
+                        <a:buNone/>
+                      </a:pPr>
+                      <a:r>
+                        <a:rPr lang="en-US" sz="1150" b="1" dirty="0">
+                          <a:solidFill>
+                            <a:srgbClr val="FFFFFF"/>
+                          </a:solidFill>
+                          <a:latin typeface="Calibri" pitchFamily="34" charset="0"/>
+                          <a:ea typeface="Calibri" pitchFamily="34" charset="-122"/>
+                          <a:cs typeface="Calibri" pitchFamily="34" charset="-120"/>
+                        </a:rPr>
+                        <a:t>Dono</a:t>
                       </a:r>
                       <a:endParaRPr lang="en-US" sz="1150" dirty="0">
                         <a:latin typeface="Calibri" charset="0"/>
@@ -18201,6 +18815,74 @@
                         <a:buNone/>
                       </a:pPr>
                       <a:r>
+                        <a:rPr lang="en-US" sz="1150" dirty="0">
+                          <a:solidFill>
+                            <a:srgbClr val="5A7185"/>
+                          </a:solidFill>
+                          <a:latin typeface="Calibri" pitchFamily="34" charset="0"/>
+                          <a:ea typeface="Calibri" pitchFamily="34" charset="-122"/>
+                          <a:cs typeface="Calibri" pitchFamily="34" charset="-120"/>
+                        </a:rPr>
+                        <a:t>Gabriel</a:t>
+                      </a:r>
+                      <a:endParaRPr lang="en-US" sz="1150" dirty="0">
+                        <a:latin typeface="Calibri" charset="0"/>
+                        <a:ea typeface="Calibri" charset="0"/>
+                        <a:cs typeface="Calibri" charset="0"/>
+                      </a:endParaRPr>
+                    </a:p>
+                  </a:txBody>
+                  <a:tcPr marL="91440" marR="91440" marT="45720" marB="45720" anchor="ctr">
+                    <a:lnL w="9525" cap="flat" cmpd="sng" algn="ctr">
+                      <a:solidFill>
+                        <a:srgbClr val="D9E0E8"/>
+                      </a:solidFill>
+                      <a:prstDash val="solid"/>
+                      <a:round/>
+                      <a:headEnd type="none" w="med" len="med"/>
+                      <a:tailEnd type="none" w="med" len="med"/>
+                    </a:lnL>
+                    <a:lnR w="9525" cap="flat" cmpd="sng" algn="ctr">
+                      <a:solidFill>
+                        <a:srgbClr val="D9E0E8"/>
+                      </a:solidFill>
+                      <a:prstDash val="solid"/>
+                      <a:round/>
+                      <a:headEnd type="none" w="med" len="med"/>
+                      <a:tailEnd type="none" w="med" len="med"/>
+                    </a:lnR>
+                    <a:lnT w="9525" cap="flat" cmpd="sng" algn="ctr">
+                      <a:solidFill>
+                        <a:srgbClr val="D9E0E8"/>
+                      </a:solidFill>
+                      <a:prstDash val="solid"/>
+                      <a:round/>
+                      <a:headEnd type="none" w="med" len="med"/>
+                      <a:tailEnd type="none" w="med" len="med"/>
+                    </a:lnT>
+                    <a:lnB w="9525" cap="flat" cmpd="sng" algn="ctr">
+                      <a:solidFill>
+                        <a:srgbClr val="D9E0E8"/>
+                      </a:solidFill>
+                      <a:prstDash val="solid"/>
+                      <a:round/>
+                      <a:headEnd type="none" w="med" len="med"/>
+                      <a:tailEnd type="none" w="med" len="med"/>
+                    </a:lnB>
+                    <a:solidFill>
+                      <a:srgbClr val="F4F7FA"/>
+                    </a:solidFill>
+                  </a:tcPr>
+                </a:tc>
+                <a:tc>
+                  <a:txBody>
+                    <a:bodyPr/>
+                    <a:lstStyle/>
+                    <a:p>
+                      <a:pPr indent="0" marL="0">
+                        <a:buNone/>
+                      </a:pPr>
+                      <a:r>
                         <a:rPr lang="en-US" sz="1150" b="1" dirty="0">
                           <a:solidFill>
                             <a:srgbClr val="0E7C66"/>
@@ -18475,6 +19157,74 @@
                         <a:buNone/>
                       </a:pPr>
                       <a:r>
+                        <a:rPr lang="en-US" sz="1150" dirty="0">
+                          <a:solidFill>
+                            <a:srgbClr val="5A7185"/>
+                          </a:solidFill>
+                          <a:latin typeface="Calibri" pitchFamily="34" charset="0"/>
+                          <a:ea typeface="Calibri" pitchFamily="34" charset="-122"/>
+                          <a:cs typeface="Calibri" pitchFamily="34" charset="-120"/>
+                        </a:rPr>
+                        <a:t>Luca</a:t>
+                      </a:r>
+                      <a:endParaRPr lang="en-US" sz="1150" dirty="0">
+                        <a:latin typeface="Calibri" charset="0"/>
+                        <a:ea typeface="Calibri" charset="0"/>
+                        <a:cs typeface="Calibri" charset="0"/>
+                      </a:endParaRPr>
+                    </a:p>
+                  </a:txBody>
+                  <a:tcPr marL="91440" marR="91440" marT="45720" marB="45720" anchor="ctr">
+                    <a:lnL w="9525" cap="flat" cmpd="sng" algn="ctr">
+                      <a:solidFill>
+                        <a:srgbClr val="D9E0E8"/>
+                      </a:solidFill>
+                      <a:prstDash val="solid"/>
+                      <a:round/>
+                      <a:headEnd type="none" w="med" len="med"/>
+                      <a:tailEnd type="none" w="med" len="med"/>
+                    </a:lnL>
+                    <a:lnR w="9525" cap="flat" cmpd="sng" algn="ctr">
+                      <a:solidFill>
+                        <a:srgbClr val="D9E0E8"/>
+                      </a:solidFill>
+                      <a:prstDash val="solid"/>
+                      <a:round/>
+                      <a:headEnd type="none" w="med" len="med"/>
+                      <a:tailEnd type="none" w="med" len="med"/>
+                    </a:lnR>
+                    <a:lnT w="9525" cap="flat" cmpd="sng" algn="ctr">
+                      <a:solidFill>
+                        <a:srgbClr val="D9E0E8"/>
+                      </a:solidFill>
+                      <a:prstDash val="solid"/>
+                      <a:round/>
+                      <a:headEnd type="none" w="med" len="med"/>
+                      <a:tailEnd type="none" w="med" len="med"/>
+                    </a:lnT>
+                    <a:lnB w="9525" cap="flat" cmpd="sng" algn="ctr">
+                      <a:solidFill>
+                        <a:srgbClr val="D9E0E8"/>
+                      </a:solidFill>
+                      <a:prstDash val="solid"/>
+                      <a:round/>
+                      <a:headEnd type="none" w="med" len="med"/>
+                      <a:tailEnd type="none" w="med" len="med"/>
+                    </a:lnB>
+                    <a:solidFill>
+                      <a:srgbClr val="FFFFFF"/>
+                    </a:solidFill>
+                  </a:tcPr>
+                </a:tc>
+                <a:tc>
+                  <a:txBody>
+                    <a:bodyPr/>
+                    <a:lstStyle/>
+                    <a:p>
+                      <a:pPr indent="0" marL="0">
+                        <a:buNone/>
+                      </a:pPr>
+                      <a:r>
                         <a:rPr lang="en-US" sz="1150" b="1" dirty="0">
                           <a:solidFill>
                             <a:srgbClr val="0E7C66"/>
@@ -18749,6 +19499,74 @@
                         <a:buNone/>
                       </a:pPr>
                       <a:r>
+                        <a:rPr lang="en-US" sz="1150" dirty="0">
+                          <a:solidFill>
+                            <a:srgbClr val="5A7185"/>
+                          </a:solidFill>
+                          <a:latin typeface="Calibri" pitchFamily="34" charset="0"/>
+                          <a:ea typeface="Calibri" pitchFamily="34" charset="-122"/>
+                          <a:cs typeface="Calibri" pitchFamily="34" charset="-120"/>
+                        </a:rPr>
+                        <a:t>Victor</a:t>
+                      </a:r>
+                      <a:endParaRPr lang="en-US" sz="1150" dirty="0">
+                        <a:latin typeface="Calibri" charset="0"/>
+                        <a:ea typeface="Calibri" charset="0"/>
+                        <a:cs typeface="Calibri" charset="0"/>
+                      </a:endParaRPr>
+                    </a:p>
+                  </a:txBody>
+                  <a:tcPr marL="91440" marR="91440" marT="45720" marB="45720" anchor="ctr">
+                    <a:lnL w="9525" cap="flat" cmpd="sng" algn="ctr">
+                      <a:solidFill>
+                        <a:srgbClr val="D9E0E8"/>
+                      </a:solidFill>
+                      <a:prstDash val="solid"/>
+                      <a:round/>
+                      <a:headEnd type="none" w="med" len="med"/>
+                      <a:tailEnd type="none" w="med" len="med"/>
+                    </a:lnL>
+                    <a:lnR w="9525" cap="flat" cmpd="sng" algn="ctr">
+                      <a:solidFill>
+                        <a:srgbClr val="D9E0E8"/>
+                      </a:solidFill>
+                      <a:prstDash val="solid"/>
+                      <a:round/>
+                      <a:headEnd type="none" w="med" len="med"/>
+                      <a:tailEnd type="none" w="med" len="med"/>
+                    </a:lnR>
+                    <a:lnT w="9525" cap="flat" cmpd="sng" algn="ctr">
+                      <a:solidFill>
+                        <a:srgbClr val="D9E0E8"/>
+                      </a:solidFill>
+                      <a:prstDash val="solid"/>
+                      <a:round/>
+                      <a:headEnd type="none" w="med" len="med"/>
+                      <a:tailEnd type="none" w="med" len="med"/>
+                    </a:lnT>
+                    <a:lnB w="9525" cap="flat" cmpd="sng" algn="ctr">
+                      <a:solidFill>
+                        <a:srgbClr val="D9E0E8"/>
+                      </a:solidFill>
+                      <a:prstDash val="solid"/>
+                      <a:round/>
+                      <a:headEnd type="none" w="med" len="med"/>
+                      <a:tailEnd type="none" w="med" len="med"/>
+                    </a:lnB>
+                    <a:solidFill>
+                      <a:srgbClr val="F4F7FA"/>
+                    </a:solidFill>
+                  </a:tcPr>
+                </a:tc>
+                <a:tc>
+                  <a:txBody>
+                    <a:bodyPr/>
+                    <a:lstStyle/>
+                    <a:p>
+                      <a:pPr indent="0" marL="0">
+                        <a:buNone/>
+                      </a:pPr>
+                      <a:r>
                         <a:rPr lang="en-US" sz="1150" b="1" dirty="0">
                           <a:solidFill>
                             <a:srgbClr val="0E7C66"/>
@@ -19023,6 +19841,74 @@
                         <a:buNone/>
                       </a:pPr>
                       <a:r>
+                        <a:rPr lang="en-US" sz="1150" dirty="0">
+                          <a:solidFill>
+                            <a:srgbClr val="5A7185"/>
+                          </a:solidFill>
+                          <a:latin typeface="Calibri" pitchFamily="34" charset="0"/>
+                          <a:ea typeface="Calibri" pitchFamily="34" charset="-122"/>
+                          <a:cs typeface="Calibri" pitchFamily="34" charset="-120"/>
+                        </a:rPr>
+                        <a:t>Davi</a:t>
+                      </a:r>
+                      <a:endParaRPr lang="en-US" sz="1150" dirty="0">
+                        <a:latin typeface="Calibri" charset="0"/>
+                        <a:ea typeface="Calibri" charset="0"/>
+                        <a:cs typeface="Calibri" charset="0"/>
+                      </a:endParaRPr>
+                    </a:p>
+                  </a:txBody>
+                  <a:tcPr marL="91440" marR="91440" marT="45720" marB="45720" anchor="ctr">
+                    <a:lnL w="9525" cap="flat" cmpd="sng" algn="ctr">
+                      <a:solidFill>
+                        <a:srgbClr val="D9E0E8"/>
+                      </a:solidFill>
+                      <a:prstDash val="solid"/>
+                      <a:round/>
+                      <a:headEnd type="none" w="med" len="med"/>
+                      <a:tailEnd type="none" w="med" len="med"/>
+                    </a:lnL>
+                    <a:lnR w="9525" cap="flat" cmpd="sng" algn="ctr">
+                      <a:solidFill>
+                        <a:srgbClr val="D9E0E8"/>
+                      </a:solidFill>
+                      <a:prstDash val="solid"/>
+                      <a:round/>
+                      <a:headEnd type="none" w="med" len="med"/>
+                      <a:tailEnd type="none" w="med" len="med"/>
+                    </a:lnR>
+                    <a:lnT w="9525" cap="flat" cmpd="sng" algn="ctr">
+                      <a:solidFill>
+                        <a:srgbClr val="D9E0E8"/>
+                      </a:solidFill>
+                      <a:prstDash val="solid"/>
+                      <a:round/>
+                      <a:headEnd type="none" w="med" len="med"/>
+                      <a:tailEnd type="none" w="med" len="med"/>
+                    </a:lnT>
+                    <a:lnB w="9525" cap="flat" cmpd="sng" algn="ctr">
+                      <a:solidFill>
+                        <a:srgbClr val="D9E0E8"/>
+                      </a:solidFill>
+                      <a:prstDash val="solid"/>
+                      <a:round/>
+                      <a:headEnd type="none" w="med" len="med"/>
+                      <a:tailEnd type="none" w="med" len="med"/>
+                    </a:lnB>
+                    <a:solidFill>
+                      <a:srgbClr val="FFFFFF"/>
+                    </a:solidFill>
+                  </a:tcPr>
+                </a:tc>
+                <a:tc>
+                  <a:txBody>
+                    <a:bodyPr/>
+                    <a:lstStyle/>
+                    <a:p>
+                      <a:pPr indent="0" marL="0">
+                        <a:buNone/>
+                      </a:pPr>
+                      <a:r>
                         <a:rPr lang="en-US" sz="1150" b="1" dirty="0">
                           <a:solidFill>
                             <a:srgbClr val="0E7C66"/>
@@ -19171,6 +20057,63 @@
                         </a:rPr>
                         <a:t>19 de 20</a:t>
                       </a:r>
+                      <a:endParaRPr lang="en-US" sz="1150" dirty="0">
+                        <a:latin typeface="Calibri" charset="0"/>
+                        <a:ea typeface="Calibri" charset="0"/>
+                        <a:cs typeface="Calibri" charset="0"/>
+                      </a:endParaRPr>
+                    </a:p>
+                  </a:txBody>
+                  <a:tcPr marL="91440" marR="91440" marT="45720" marB="45720" anchor="ctr">
+                    <a:lnL w="9525" cap="flat" cmpd="sng" algn="ctr">
+                      <a:solidFill>
+                        <a:srgbClr val="D9E0E8"/>
+                      </a:solidFill>
+                      <a:prstDash val="solid"/>
+                      <a:round/>
+                      <a:headEnd type="none" w="med" len="med"/>
+                      <a:tailEnd type="none" w="med" len="med"/>
+                    </a:lnL>
+                    <a:lnR w="9525" cap="flat" cmpd="sng" algn="ctr">
+                      <a:solidFill>
+                        <a:srgbClr val="D9E0E8"/>
+                      </a:solidFill>
+                      <a:prstDash val="solid"/>
+                      <a:round/>
+                      <a:headEnd type="none" w="med" len="med"/>
+                      <a:tailEnd type="none" w="med" len="med"/>
+                    </a:lnR>
+                    <a:lnT w="9525" cap="flat" cmpd="sng" algn="ctr">
+                      <a:solidFill>
+                        <a:srgbClr val="D9E0E8"/>
+                      </a:solidFill>
+                      <a:prstDash val="solid"/>
+                      <a:round/>
+                      <a:headEnd type="none" w="med" len="med"/>
+                      <a:tailEnd type="none" w="med" len="med"/>
+                    </a:lnT>
+                    <a:lnB w="9525" cap="flat" cmpd="sng" algn="ctr">
+                      <a:solidFill>
+                        <a:srgbClr val="D9E0E8"/>
+                      </a:solidFill>
+                      <a:prstDash val="solid"/>
+                      <a:round/>
+                      <a:headEnd type="none" w="med" len="med"/>
+                      <a:tailEnd type="none" w="med" len="med"/>
+                    </a:lnB>
+                    <a:solidFill>
+                      <a:srgbClr val="F4F7FA"/>
+                    </a:solidFill>
+                  </a:tcPr>
+                </a:tc>
+                <a:tc>
+                  <a:txBody>
+                    <a:bodyPr/>
+                    <a:lstStyle/>
+                    <a:p>
+                      <a:pPr indent="0" marL="0">
+                        <a:buNone/>
+                      </a:pPr>
                       <a:endParaRPr lang="en-US" sz="1150" dirty="0">
                         <a:latin typeface="Calibri" charset="0"/>
                         <a:ea typeface="Calibri" charset="0"/>

</xml_diff>

<commit_message>
Alinha a coluna de situação do backlog na apresentação ao quadro
Co-Authored-By: Claude Fable 5.1 <noreply@anthropic.com>
Claude-Session: https://claude.ai/code/session_01AxsLnikbU4P6aghAswDkjm
</commit_message>
<xml_diff>
--- a/docs/apresentacao-checkpoint-4-6.pptx
+++ b/docs/apresentacao-checkpoint-4-6.pptx
@@ -20714,7 +20714,7 @@
                 <a:ea typeface="Calibri" pitchFamily="34" charset="-122"/>
                 <a:cs typeface="Calibri" pitchFamily="34" charset="-120"/>
               </a:rPr>
-              <a:t>O que vai para avaliação e onde cada story da Onda 1 já está navegável</a:t>
+              <a:t>Stories de interface da Onda 1: navegáveis no protótipo, mas abertas no quadro até a validação com um gerente na Sprint 2</a:t>
             </a:r>
             <a:endParaRPr lang="en-US" sz="1350" dirty="0"/>
           </a:p>
@@ -24779,7 +24779,7 @@
                           <a:ea typeface="Calibri" pitchFamily="34" charset="-122"/>
                           <a:cs typeface="Calibri" pitchFamily="34" charset="-120"/>
                         </a:rPr>
-                        <a:t>Onda</a:t>
+                        <a:t>Quadro</a:t>
                       </a:r>
                       <a:endParaRPr lang="en-US" sz="900" dirty="0">
                         <a:latin typeface="Calibri" charset="0"/>
@@ -27161,15 +27161,15 @@
                         <a:buNone/>
                       </a:pPr>
                       <a:r>
-                        <a:rPr lang="en-US" sz="900" dirty="0">
+                        <a:rPr lang="en-US" sz="900" b="1" dirty="0">
                           <a:solidFill>
-                            <a:srgbClr val="5A7185"/>
+                            <a:srgbClr val="0E7C66"/>
                           </a:solidFill>
                           <a:latin typeface="Calibri" pitchFamily="34" charset="0"/>
                           <a:ea typeface="Calibri" pitchFamily="34" charset="-122"/>
                           <a:cs typeface="Calibri" pitchFamily="34" charset="-120"/>
                         </a:rPr>
-                        <a:t>Onda 1</a:t>
+                        <a:t>Concluído</a:t>
                       </a:r>
                       <a:endParaRPr lang="en-US" sz="900" dirty="0">
                         <a:latin typeface="Calibri" charset="0"/>
@@ -29073,15 +29073,15 @@
                         <a:buNone/>
                       </a:pPr>
                       <a:r>
-                        <a:rPr lang="en-US" sz="900" dirty="0">
+                        <a:rPr lang="en-US" sz="900" b="1" dirty="0">
                           <a:solidFill>
-                            <a:srgbClr val="5A7185"/>
+                            <a:srgbClr val="0E7C66"/>
                           </a:solidFill>
                           <a:latin typeface="Calibri" pitchFamily="34" charset="0"/>
                           <a:ea typeface="Calibri" pitchFamily="34" charset="-122"/>
                           <a:cs typeface="Calibri" pitchFamily="34" charset="-120"/>
                         </a:rPr>
-                        <a:t>Onda 1</a:t>
+                        <a:t>Concluído</a:t>
                       </a:r>
                       <a:endParaRPr lang="en-US" sz="900" dirty="0">
                         <a:latin typeface="Calibri" charset="0"/>
@@ -29551,15 +29551,15 @@
                         <a:buNone/>
                       </a:pPr>
                       <a:r>
-                        <a:rPr lang="en-US" sz="900" dirty="0">
+                        <a:rPr lang="en-US" sz="900" b="1" dirty="0">
                           <a:solidFill>
-                            <a:srgbClr val="5A7185"/>
+                            <a:srgbClr val="0E7C66"/>
                           </a:solidFill>
                           <a:latin typeface="Calibri" pitchFamily="34" charset="0"/>
                           <a:ea typeface="Calibri" pitchFamily="34" charset="-122"/>
                           <a:cs typeface="Calibri" pitchFamily="34" charset="-120"/>
                         </a:rPr>
-                        <a:t>Onda 1</a:t>
+                        <a:t>Concluído</a:t>
                       </a:r>
                       <a:endParaRPr lang="en-US" sz="900" dirty="0">
                         <a:latin typeface="Calibri" charset="0"/>
@@ -31628,7 +31628,7 @@
                 <a:ea typeface="Calibri" pitchFamily="34" charset="-122"/>
                 <a:cs typeface="Calibri" pitchFamily="34" charset="-120"/>
               </a:rPr>
-              <a:t>Prioridade pelo valor para a hipótese do MVP (slide anterior): jornada completa, depois confiança no resultado, depois uso recorrente. Pontos do Planning Poker: Onda 1 42 · Onda 2 16 · total 58.</a:t>
+              <a:t>Ordem = prioridade pelo valor para a hipótese do MVP (slide anterior). Coluna Quadro = coluna da Issue no GitHub Projects: Concluído (Sprint 1), Onda 1 e Onda 2. Pontos do Planning Poker: Onda 1 42 · Onda 2 16 · total 58.</a:t>
             </a:r>
             <a:endParaRPr lang="en-US" sz="1000" dirty="0"/>
           </a:p>

</xml_diff>

<commit_message>
Alinha a coluna de situação do backlog na apresentação ao quadro (#21)
Claude-Session: https://claude.ai/code/session_01AxsLnikbU4P6aghAswDkjm

Co-authored-by: Claude <noreply@anthropic.com>
</commit_message>
<xml_diff>
--- a/docs/apresentacao-checkpoint-4-6.pptx
+++ b/docs/apresentacao-checkpoint-4-6.pptx
@@ -20714,7 +20714,7 @@
                 <a:ea typeface="Calibri" pitchFamily="34" charset="-122"/>
                 <a:cs typeface="Calibri" pitchFamily="34" charset="-120"/>
               </a:rPr>
-              <a:t>O que vai para avaliação e onde cada story da Onda 1 já está navegável</a:t>
+              <a:t>Stories de interface da Onda 1: navegáveis no protótipo, mas abertas no quadro até a validação com um gerente na Sprint 2</a:t>
             </a:r>
             <a:endParaRPr lang="en-US" sz="1350" dirty="0"/>
           </a:p>
@@ -24779,7 +24779,7 @@
                           <a:ea typeface="Calibri" pitchFamily="34" charset="-122"/>
                           <a:cs typeface="Calibri" pitchFamily="34" charset="-120"/>
                         </a:rPr>
-                        <a:t>Onda</a:t>
+                        <a:t>Quadro</a:t>
                       </a:r>
                       <a:endParaRPr lang="en-US" sz="900" dirty="0">
                         <a:latin typeface="Calibri" charset="0"/>
@@ -27161,15 +27161,15 @@
                         <a:buNone/>
                       </a:pPr>
                       <a:r>
-                        <a:rPr lang="en-US" sz="900" dirty="0">
+                        <a:rPr lang="en-US" sz="900" b="1" dirty="0">
                           <a:solidFill>
-                            <a:srgbClr val="5A7185"/>
+                            <a:srgbClr val="0E7C66"/>
                           </a:solidFill>
                           <a:latin typeface="Calibri" pitchFamily="34" charset="0"/>
                           <a:ea typeface="Calibri" pitchFamily="34" charset="-122"/>
                           <a:cs typeface="Calibri" pitchFamily="34" charset="-120"/>
                         </a:rPr>
-                        <a:t>Onda 1</a:t>
+                        <a:t>Concluído</a:t>
                       </a:r>
                       <a:endParaRPr lang="en-US" sz="900" dirty="0">
                         <a:latin typeface="Calibri" charset="0"/>
@@ -29073,15 +29073,15 @@
                         <a:buNone/>
                       </a:pPr>
                       <a:r>
-                        <a:rPr lang="en-US" sz="900" dirty="0">
+                        <a:rPr lang="en-US" sz="900" b="1" dirty="0">
                           <a:solidFill>
-                            <a:srgbClr val="5A7185"/>
+                            <a:srgbClr val="0E7C66"/>
                           </a:solidFill>
                           <a:latin typeface="Calibri" pitchFamily="34" charset="0"/>
                           <a:ea typeface="Calibri" pitchFamily="34" charset="-122"/>
                           <a:cs typeface="Calibri" pitchFamily="34" charset="-120"/>
                         </a:rPr>
-                        <a:t>Onda 1</a:t>
+                        <a:t>Concluído</a:t>
                       </a:r>
                       <a:endParaRPr lang="en-US" sz="900" dirty="0">
                         <a:latin typeface="Calibri" charset="0"/>
@@ -29551,15 +29551,15 @@
                         <a:buNone/>
                       </a:pPr>
                       <a:r>
-                        <a:rPr lang="en-US" sz="900" dirty="0">
+                        <a:rPr lang="en-US" sz="900" b="1" dirty="0">
                           <a:solidFill>
-                            <a:srgbClr val="5A7185"/>
+                            <a:srgbClr val="0E7C66"/>
                           </a:solidFill>
                           <a:latin typeface="Calibri" pitchFamily="34" charset="0"/>
                           <a:ea typeface="Calibri" pitchFamily="34" charset="-122"/>
                           <a:cs typeface="Calibri" pitchFamily="34" charset="-120"/>
                         </a:rPr>
-                        <a:t>Onda 1</a:t>
+                        <a:t>Concluído</a:t>
                       </a:r>
                       <a:endParaRPr lang="en-US" sz="900" dirty="0">
                         <a:latin typeface="Calibri" charset="0"/>
@@ -31628,7 +31628,7 @@
                 <a:ea typeface="Calibri" pitchFamily="34" charset="-122"/>
                 <a:cs typeface="Calibri" pitchFamily="34" charset="-120"/>
               </a:rPr>
-              <a:t>Prioridade pelo valor para a hipótese do MVP (slide anterior): jornada completa, depois confiança no resultado, depois uso recorrente. Pontos do Planning Poker: Onda 1 42 · Onda 2 16 · total 58.</a:t>
+              <a:t>Ordem = prioridade pelo valor para a hipótese do MVP (slide anterior). Coluna Quadro = coluna da Issue no GitHub Projects: Concluído (Sprint 1), Onda 1 e Onda 2. Pontos do Planning Poker: Onda 1 42 · Onda 2 16 · total 58.</a:t>
             </a:r>
             <a:endParaRPr lang="en-US" sz="1000" dirty="0"/>
           </a:p>

</xml_diff>

<commit_message>
Corrige a contagem da revisão INVEST e atualiza as ressalvas pós-Poker
Co-Authored-By: Claude Fable 5.1 <noreply@anthropic.com>
Claude-Session: https://claude.ai/code/session_01AxsLnikbU4P6aghAswDkjm
</commit_message>
<xml_diff>
--- a/docs/apresentacao-checkpoint-4-6.pptx
+++ b/docs/apresentacao-checkpoint-4-6.pptx
@@ -32907,7 +32907,7 @@
                 <a:ea typeface="Calibri" pitchFamily="34" charset="-122"/>
                 <a:cs typeface="Calibri" pitchFamily="34" charset="-120"/>
               </a:rPr>
-              <a:t>10 das 14 stories passaram nas seis letras. As outras quatro têm a ressalva registrada, em vez de um checklist todo verde.</a:t>
+              <a:t>9 das 14 stories passaram nas seis letras. As outras cinco têm a ressalva registrada, em vez de um checklist todo verde.</a:t>
             </a:r>
             <a:endParaRPr lang="en-US" sz="1300" dirty="0"/>
           </a:p>
@@ -33712,7 +33712,7 @@
                           <a:ea typeface="Calibri" pitchFamily="34" charset="-122"/>
                           <a:cs typeface="Calibri" pitchFamily="34" charset="-120"/>
                         </a:rPr>
-                        <a:t>Modelo é experimento; o baseline medido antes de estimar reduziu a incerteza</a:t>
+                        <a:t>Modelo é experimento; o baseline medido antes de estimar reduziu a incerteza. Fechou em 8 pontos no Poker</a:t>
                       </a:r>
                       <a:endParaRPr lang="en-US" sz="1200" dirty="0">
                         <a:latin typeface="Calibri" charset="0"/>
@@ -33918,7 +33918,7 @@
                           <a:ea typeface="Calibri" pitchFamily="34" charset="-122"/>
                           <a:cs typeface="Calibri" pitchFamily="34" charset="-120"/>
                         </a:rPr>
-                        <a:t>Pode não caber numa sprint; se o Poker passar de 8 pontos, dividir em heurística e refinamento</a:t>
+                        <a:t>Podia não caber numa sprint; no Poker o escopo foi limitado a vizinho mais próximo + 2-opt, para caber em 8 pontos</a:t>
                       </a:r>
                       <a:endParaRPr lang="en-US" sz="1200" dirty="0">
                         <a:latin typeface="Calibri" charset="0"/>
@@ -34124,7 +34124,7 @@
                           <a:ea typeface="Calibri" pitchFamily="34" charset="-122"/>
                           <a:cs typeface="Calibri" pitchFamily="34" charset="-120"/>
                         </a:rPr>
-                        <a:t>Depende de fonte com publicação automatizada; avaliar a fonte antes de estimar</a:t>
+                        <a:t>Depende de fonte com publicação automatizada; os 5 pontos do Poker são ordem de grandeza, a rever depois de avaliar a fonte</a:t>
                       </a:r>
                       <a:endParaRPr lang="en-US" sz="1200" dirty="0">
                         <a:latin typeface="Calibri" charset="0"/>
@@ -34240,7 +34240,7 @@
                 <a:ea typeface="Calibri" pitchFamily="34" charset="-122"/>
                 <a:cs typeface="Calibri" pitchFamily="34" charset="-120"/>
               </a:rPr>
-              <a:t>Nenhuma story precisou ser reescrita. As ressalvas voltam na mesa no Planning Poker.</a:t>
+              <a:t>Nenhuma story precisou ser reescrita. As cinco ressalvas foram revistas no Planning Poker, com o registro em docs/planejamento.md.</a:t>
             </a:r>
             <a:endParaRPr lang="en-US" sz="1200" dirty="0"/>
           </a:p>

</xml_diff>

<commit_message>
Corrige a contagem da revisão INVEST e atualiza as ressalvas pós-Poker (#22)
Claude-Session: https://claude.ai/code/session_01AxsLnikbU4P6aghAswDkjm

Co-authored-by: Claude <noreply@anthropic.com>
</commit_message>
<xml_diff>
--- a/docs/apresentacao-checkpoint-4-6.pptx
+++ b/docs/apresentacao-checkpoint-4-6.pptx
@@ -32907,7 +32907,7 @@
                 <a:ea typeface="Calibri" pitchFamily="34" charset="-122"/>
                 <a:cs typeface="Calibri" pitchFamily="34" charset="-120"/>
               </a:rPr>
-              <a:t>10 das 14 stories passaram nas seis letras. As outras quatro têm a ressalva registrada, em vez de um checklist todo verde.</a:t>
+              <a:t>9 das 14 stories passaram nas seis letras. As outras cinco têm a ressalva registrada, em vez de um checklist todo verde.</a:t>
             </a:r>
             <a:endParaRPr lang="en-US" sz="1300" dirty="0"/>
           </a:p>
@@ -33712,7 +33712,7 @@
                           <a:ea typeface="Calibri" pitchFamily="34" charset="-122"/>
                           <a:cs typeface="Calibri" pitchFamily="34" charset="-120"/>
                         </a:rPr>
-                        <a:t>Modelo é experimento; o baseline medido antes de estimar reduziu a incerteza</a:t>
+                        <a:t>Modelo é experimento; o baseline medido antes de estimar reduziu a incerteza. Fechou em 8 pontos no Poker</a:t>
                       </a:r>
                       <a:endParaRPr lang="en-US" sz="1200" dirty="0">
                         <a:latin typeface="Calibri" charset="0"/>
@@ -33918,7 +33918,7 @@
                           <a:ea typeface="Calibri" pitchFamily="34" charset="-122"/>
                           <a:cs typeface="Calibri" pitchFamily="34" charset="-120"/>
                         </a:rPr>
-                        <a:t>Pode não caber numa sprint; se o Poker passar de 8 pontos, dividir em heurística e refinamento</a:t>
+                        <a:t>Podia não caber numa sprint; no Poker o escopo foi limitado a vizinho mais próximo + 2-opt, para caber em 8 pontos</a:t>
                       </a:r>
                       <a:endParaRPr lang="en-US" sz="1200" dirty="0">
                         <a:latin typeface="Calibri" charset="0"/>
@@ -34124,7 +34124,7 @@
                           <a:ea typeface="Calibri" pitchFamily="34" charset="-122"/>
                           <a:cs typeface="Calibri" pitchFamily="34" charset="-120"/>
                         </a:rPr>
-                        <a:t>Depende de fonte com publicação automatizada; avaliar a fonte antes de estimar</a:t>
+                        <a:t>Depende de fonte com publicação automatizada; os 5 pontos do Poker são ordem de grandeza, a rever depois de avaliar a fonte</a:t>
                       </a:r>
                       <a:endParaRPr lang="en-US" sz="1200" dirty="0">
                         <a:latin typeface="Calibri" charset="0"/>
@@ -34240,7 +34240,7 @@
                 <a:ea typeface="Calibri" pitchFamily="34" charset="-122"/>
                 <a:cs typeface="Calibri" pitchFamily="34" charset="-120"/>
               </a:rPr>
-              <a:t>Nenhuma story precisou ser reescrita. As ressalvas voltam na mesa no Planning Poker.</a:t>
+              <a:t>Nenhuma story precisou ser reescrita. As cinco ressalvas foram revistas no Planning Poker, com o registro em docs/planejamento.md.</a:t>
             </a:r>
             <a:endParaRPr lang="en-US" sz="1200" dirty="0"/>
           </a:p>

</xml_diff>

<commit_message>
Adiciona notas do apresentador em todos os slides
Co-Authored-By: Claude Fable 5.1 <noreply@anthropic.com>
Claude-Session: https://claude.ai/code/session_01AxsLnikbU4P6aghAswDkjm
</commit_message>
<xml_diff>
--- a/docs/apresentacao-checkpoint-4-6.pptx
+++ b/docs/apresentacao-checkpoint-4-6.pptx
@@ -816,7 +816,11 @@
           <a:p>
             <a:r>
               <a:rPr lang="en-US" dirty="0"/>
-              <a:t>Abertura. Este checkpoint não é um trabalho novo: é o mesmo produto do Canvas MVP ganhando backlog, arquitetura e plano.</a:t>
+              <a:t>QUEM: Gabriel · TEMPO: 30 s
+O QUE DIZER
+"Boa noite. Somos o grupo do Sistema de Roteirização de Visitas às Agências: Davi, Gabriel, Luca e Victor. Este é o checkpoint das Aulas 4, 5 e 6. Não é um trabalho novo: é o mesmo produto do Canvas MVP ganhando backlog, arquitetura e plano de sprint. Tudo o que vamos mostrar está no repositório, no pull request 15 e no quadro do GitHub, que estão nos links da capa."
+NÃO FAZER
+Não ler os links em voz alta. Não explicar o protótipo aqui.</a:t>
             </a:r>
             <a:endParaRPr lang="en-US" dirty="0"/>
           </a:p>
@@ -904,7 +908,13 @@
           <a:p>
             <a:r>
               <a:rPr lang="en-US" dirty="0"/>
-              <a:t>Se só der tempo de explicar um, explicar o D, que é o que a Aula 5 pede nominalmente. O próximo slide mostra o código.</a:t>
+              <a:t>QUEM: Luca · TEMPO: 1 min 30
+O QUE DIZER
+"Os cinco princípios, com o problema concreto que cada um resolveu no nosso código."
+"S, responsabilidade única: antes, cada script numerado misturava leitura, transformação e cálculo; mudar o Excel mexia no mesmo arquivo que formava as regionais. O, aberto/fechado: um meio de transporte novo, como trem, entra como classe nova e comparar_modais não muda; temos um teste que prova isso. L, Liskov: os três estimadores de preço são intercambiáveis, o treino avalia os três com a mesma função e escolhe o melhor, sem if por tipo. I, segregação de interface: as interfaces têm um ou dois métodos, então um teste cria uma implementação falsa em três linhas. D, inversão de dependência: a carga e o treino não sabem se o dado vem de Excel, API ou memória."
+"Se o tempo apertar, o importante é o D, que é o que a Aula 5 pede nominalmente. O próximo slide mostra o código."
+PERGUNTA PROVÁVEL
+"Vocês aplicaram os cinco de propósito ou encaixaram depois?" → S e D foram o objetivo da refatoração. O, L e I apareceram naturalmente quando os modais e os estimadores viraram classes com o mesmo contrato; registramos porque resolveram problemas reais.</a:t>
             </a:r>
             <a:endParaRPr lang="en-US" dirty="0"/>
           </a:p>
@@ -992,7 +1002,14 @@
           <a:p>
             <a:r>
               <a:rPr lang="en-US" dirty="0"/>
-              <a:t>O teste test_fonte_em_memoria_substitui_o_excel é a prova executável de que a inversão funciona.</a:t>
+              <a:t>QUEM: Luca · TEMPO: 1 min 30
+O QUE DIZER
+"Este é o exemplo de inversão de dependência que a Aula 5 pede. À esquerda, em ingest.py, a abstração: DataSource é uma classe abstrata com um único método, load, que devolve uma tabela. A função carregar_agencias recebe um DataSource, não um caminho de arquivo. Ela não sabe de onde o dado vem."
+"À direita, duas fontes usando a mesma função. Em produção, o pipeline.py passa um ExcelSource com a planilha consolidada. No teste, passamos um MemorySource com uma tabela montada na hora, sem arquivo nenhum em disco."
+Faixa: "Trocar a planilha por uma API do Banco Central é escrever uma classe ApiBacenSource e mudar uma linha do pipeline.py. Treino e serving não mudam."
+Analogia, se ajudar: "É como uma tomada: o aparelho não sabe se a energia vem da rede, de um gerador ou de uma bateria. Ele só conhece o formato da tomada."
+PERGUNTA PROVÁVEL
+"Onde está a prova de que funciona?" → No teste test_fonte_em_memoria_substitui_o_excel, em tests/test_ingest.py.</a:t>
             </a:r>
             <a:endParaRPr lang="en-US" dirty="0"/>
           </a:p>
@@ -1080,7 +1097,14 @@
           <a:p>
             <a:r>
               <a:rPr lang="en-US" dirty="0"/>
-              <a:t>A Aula 5 pede para comparar a saída com a versão anterior. Reativar os defeitos isolou o efeito da reorganização do efeito das correções.</a:t>
+              <a:t>QUEM: Luca · TEMPO: 1 min 30
+O QUE DIZER
+"A Etapa 4 da Aula 5 pede que o pipeline refatorado produza a mesma saída da versão anterior. Mas durante a refatoração encontramos dois defeitos no código antigo. Se corrigíssemos e comparássemos, os números não bateriam e não daria para saber se a diferença era da reorganização ou da correção."
+"Então fizemos em dois passos. Primeiro, rodamos o código novo com os dois defeitos antigos reativados: 2.040 agências, 106 regionais, mesma mediana, mesma cobertura de bairro. Idêntico. Isso prova que a reorganização não mudou o comportamento."
+"Depois corrigimos. Defeito 1: o filtro de instituição procurava o trecho 'ITA' e trazia 30 registros que não são agências, como corretoras com 'CAPITAL' no nome. Correção: nome exato, 2.010 agências. Defeito 2: a regra que expande 'S.' para 'SÃO' transformava 'SANTA CATARINA' em 'SAO ANTA CATARINA'. Correção: só expande palavra inteira."
+"Versão final: 2.010 agências, 105 regionais, 74,7% com coordenada de bairro."
+PERGUNTA PROVÁVEL
+"Como vocês acharam os defeitos?" → Validando o requisito de qualidade dos dados: ao escrever o teste de que toda agência é do Itaú, apareceram as corretoras.</a:t>
             </a:r>
             <a:endParaRPr lang="en-US" dirty="0"/>
           </a:p>
@@ -1168,7 +1192,15 @@
           <a:p>
             <a:r>
               <a:rPr lang="en-US" dirty="0"/>
-              <a:t>O baseline é o que o sistema fazia antes: o mesmo preço para o Brasil inteiro. Por isso a comparação é honesta.</a:t>
+              <a:t>QUEM: Luca · TEMPO: 2 min
+O QUE DIZER
+"Este slide é a verificação do critério de métrica do modelo, da US11. O baseline é o que o sistema fazia antes: o mesmo preço de gasolina para o Brasil inteiro. Erro de 20 centavos por litro. Um modelo intermediário, que soma a diferença média histórica de cada estado, cai para 11,5. A regressão Ridge, que usa o estado, a diferença das últimas 52 semanas e o mês, chega a 9,5 centavos. 52% menos erro que o baseline, e dentro do critério de 15."
+Gráfico: "Mês a mês no período de teste. A linha de cima é o baseline, a de baixo é o modelo; a linha tracejada é o critério de 15 centavos. O modelo fica abaixo do critério o tempo todo."
+Validação temporal: "Treino até dezembro de 2019, teste de janeiro de 2020 em diante. Não embaralhamos as semanas. Se embaralhássemos, o modelo veria semanas futuras no treino e o resultado ficaria inflado. Escolhemos 2020 de propósito: a pandemia inteira fica no teste, que é o cenário mais difícil."
+Drift: "O erro sobe no choque de preços da pandemia e tem o pico em outubro de 2020. É o princípio CACE da Aula 4 aparecendo nos dados: o modelo foi ajustado num regime de preços e avaliado em outro. Por isso o RNF06 manda reavaliar a cada atualização."
+Limitação: "A série acaba em 2021. O produto aplica a diferença de cada estado sobre o preço nacional atual, que é informado por parâmetro ao rodar o pipeline."
+PERGUNTA PROVÁVEL
+"Por que Ridge e não algo mais sofisticado?" → O problema é pequeno e linear: diferença de estado mais sazonalidade. Ridge é interpretável, treina em segundos e já bateu o critério com folga. Modelo mais complexo só se o drift piorar.</a:t>
             </a:r>
             <a:endParaRPr lang="en-US" dirty="0"/>
           </a:p>
@@ -1256,7 +1288,14 @@
           <a:p>
             <a:r>
               <a:rPr lang="en-US" dirty="0"/>
-              <a:t>Mostrar o PR aberto no navegador, na aba Files changed, com os comentários de revisão.</a:t>
+              <a:t>QUEM: Davi · TEMPO: 1 min 30
+O QUE DIZER
+"A definição de pronto da Aula 5: módulos com responsabilidade única, inversão de dependência, pipeline validado e pull request revisado. 23 testes com pytest, um arquivo por módulo, cada um ligado a um critério de aceite. 14 commits pequenos no PR 15: um por módulo reorganizado, depois documentação e revisão. O pipeline inteiro roda em 8 segundos."
+Tabela: "test_features garante que Mirandópolis, a 530 km, é descartado. test_train garante que nenhuma regional fura o teto de 40 nem o piso de 4, e que o MAE fica abaixo de 15 centavos. test_serve garante que avião não aparece abaixo de 150 km e que um modal novo entra sem alterar código existente."
+Revisão, em primeira pessoa: "Eu fiz a revisão do PR, com três comentários. Primeiro: o preço nacional da gasolina estava fixo no código; foi corrigido, agora é parâmetro do pipeline. Segundo: perguntei por que o corte temporal em 2020; o Luca testou 2019, 2020 e julho de 2020 e a conclusão é a mesma em todos. Terceiro: perguntei por que 30 km; o teste de sensibilidade mostrou que o limite único prejudica municípios muito grandes, como o Rio, e isso virou a Issue 16, para a Sprint 2."
+Se der tempo, abrir o PR no navegador na aba Files changed e mostrar os comentários resolvidos.
+PERGUNTA PROVÁVEL
+"A revisão mudou o projeto?" → Sim: um parâmetro novo, um teste novo e uma Issue nova. Está tudo no PR.</a:t>
             </a:r>
             <a:endParaRPr lang="en-US" dirty="0"/>
           </a:p>
@@ -1344,7 +1383,13 @@
           <a:p>
             <a:r>
               <a:rPr lang="en-US" dirty="0"/>
-              <a:t>Nível 3, os entregáveis, está no documento docs/planejamento.md. No slide ficou o nível 2 e o 4, que é onde mora a rastreabilidade.</a:t>
+              <a:t>QUEM: Davi · TEMPO: 1 min 30
+O QUE DIZER
+"WBS, a estrutura analítica do projeto, em quatro níveis como a Aula 6 pede. Nível 1 é o projeto. Nível 2 são as fases do CRISP-DM, mais uma de gestão, como no estudo de caso da aula. Nível 3, os entregáveis de cada fase, está no documento. No slide ficou o nível 4, os pacotes de trabalho, porque é neles que mora a rastreabilidade: cada pacote aponta para a story de origem."
+Apontar: "Preparação tem quatro pacotes, todos da US10 e da US11. Modelagem tem o k-means da US01, os modelos de preço da US11, os modais da US05. Entrega são as telas do protótipo. Gestão tem o Planning Poker, a revisão do PR e a revisão dos riscos."
+Regra dos 100%: "Conferimos que as 14 stories aparecem em algum pacote e que nenhum pacote existe sem story, com uma exceção declarada: 7.3, revisar riscos, é transversal. A tabela de conferência está no planejamento.md."
+PERGUNTA PROVÁVEL
+"Por que 'Entrega' em vez de 'Implantação', que é a fase do CRISP-DM?" → No MVP não há implantação; a entrega é o protótipo navegável. Seguimos o estudo de caso da Aula 6, que também usa 'Entrega'.</a:t>
             </a:r>
             <a:endParaRPr lang="en-US" dirty="0"/>
           </a:p>
@@ -1432,7 +1477,13 @@
           <a:p>
             <a:r>
               <a:rPr lang="en-US" dirty="0"/>
-              <a:t>US04: o 3 via só ordenar; o 8 lembrou de quebrar em dias com teto e janela → 5. US09: reabrir planejamento antigo com base alterada → 5, com aviso em vez de reconciliar. US11: 13 pela incerteza; baseline já medido fechou em 8. US12: empate 8/13; escopo limitado a vizinho mais próximo + 2-opt para caber em 8.</a:t>
+              <a:t>QUEM: Davi · TEMPO: 2 min
+O QUE DIZER
+"Planning Poker em Fibonacci: 1, 2, 3, 5, 8, 13. A US01, selecionar agências, foi a referência com 3 pontos; as outras foram comparadas com ela. Votação simultânea, para ninguém se ancorar no colega."
+Contar as divergências, que é onde o Poker rende: "Na US04, os votos foram de 3 a 8. Quem deu 3 pensava só em ordenar as agências; quem deu 8 lembrou que a sequência tem que ser quebrada em dias respeitando o teto de horas e a janela. Fechou em 5. Na US09, de 3 a 8: o 8 incluía reabrir um planejamento antigo depois que a base de agências mudou. Fechou em 5, com a decisão de mostrar um aviso em vez de tentar reconciliar. Na US11, de 5 a 13: o 13 era a incerteza de um modelo não testado; o argumento que fechou em 8 foi que o baseline já tinha sido medido, então a meta era conhecida. Na US12, empate entre 8 e 13: em vez de dividir, limitamos o escopo a vizinho mais próximo mais 2-opt."
+Capacidade: "4 pessoas, sprints de 2 semanas, velocidade assumida de 20 pontos. É hipótese: todos conciliam o projeto com outras disciplinas. Backlog de 58 pontos, previsão de 4 sprints. A velocidade real da Sprint 1 recalibra isso."
+PERGUNTA PROVÁVEL
+"Por que 20 pontos?" → Velocidade inicial é sempre hipótese; 20 é razoável para 4 pessoas em meio período, e a Sprint 1 entregou 19, o que confirma a ordem de grandeza.</a:t>
             </a:r>
             <a:endParaRPr lang="en-US" dirty="0"/>
           </a:p>
@@ -1520,7 +1571,14 @@
           <a:p>
             <a:r>
               <a:rPr lang="en-US" dirty="0"/>
-              <a:t>R3 é o único vermelho de nota 9. Ele se resolve com a área de negócio, por isso a resposta é transferir.</a:t>
+              <a:t>QUEM: Victor · TEMPO: 2 min
+O QUE DIZER
+"Sete riscos, com probabilidade e impacto de baixo a alto, exposição é o produto dos dois. Três de dados, dois de modelo, um de prazo e um de privacidade. Cada um tem resposta e dono."
+Os dois mais importantes: "R3 é o único de nota 9: prioridade e periodicidade de visita não existem em base pública. A resposta é transferir: no piloto, a área de negócio fornece o dado; até lá, os campos são simulados e declarados como tal na interface. R1, coordenada errada por colisão de nome de bairro, é mitigado pela regra dos 30 km e por um teste automático; a revisão do PR mostrou que a regra ainda tem um ponto cego nos municípios muito grandes, que virou a Issue 16."
+Resposta por tipo: "R5, rotas com ida e volta, aceitamos: está declarado na interface e a otimização é a US12. R7, agenda do gerente como dado pessoal, evitamos: o MVP não trata dado pessoal."
+Donos: "Cada integrante é dono dos riscos da frente que conduz: Gabriel na base de agências, Luca no modelo, eu no negócio e na rota, Davi no prazo e no repositório. A matriz é revisada a cada sprint, pacote 7.3."
+PERGUNTA PROVÁVEL
+"Por que R2, série antiga, é só médio de impacto?" → Porque o modelo usa a diferença entre estados, não o nível de preço, e a diferença é estável. Se fosse o nível, seria alto.</a:t>
             </a:r>
             <a:endParaRPr lang="en-US" dirty="0"/>
           </a:p>
@@ -1608,7 +1666,14 @@
           <a:p>
             <a:r>
               <a:rPr lang="en-US" dirty="0"/>
-              <a:t>Explicar a escolha honestamente: não faria sentido planejar construir de novo telas que já existem.</a:t>
+              <a:t>QUEM: Victor · TEMPO: 1 min 30
+O QUE DIZER
+"Meta da Sprint 1: transformar a base de agências e o custo de deslocamento num pipeline modular e testado, com o preço por estado validado contra o baseline. Capacidade de 20 pontos; selecionamos 19: US10 com 5, US11 com 8, US05 com 3, e testes com PR revisado com 3. Cada item tem um dono e os pacotes da WBS que cobre."
+Por que estas e não as do topo da prioridade, antecipar a pergunta: "A Aula 6 diz para puxar do topo do backlog. O topo é US01 a US08, que são as stories de interface, e elas já estavam navegáveis no protótipo do checkpoint anterior. Não faria sentido planejar uma sprint para construir telas que já existem. A Sprint 1 atacou o que sustenta os números que o protótipo mostra: localização, preço e modal. A Sprint 2 volta ao topo para validar as stories de interface com um gerente real."
+Definição de pronto: "Critério de aceite verificado, de preferência por teste; código no módulo certo; PR revisado por outro integrante; pipeline rodando de ponta a ponta. Os quatro itens foram entregues."
+Riscos monitorados: R1, R2, R4 e R6.
+PERGUNTA PROVÁVEL
+"A sprint já aconteceu? O checkpoint pedia o plano." → O plano foi feito na Aula 6 e a sprint rodou entre a Aula 6 e hoje. Mostramos o plano e o resultado porque o resultado é a prova de que a capacidade era realista.</a:t>
             </a:r>
             <a:endParaRPr lang="en-US" dirty="0"/>
           </a:p>
@@ -1696,7 +1761,15 @@
           <a:p>
             <a:r>
               <a:rPr lang="en-US" dirty="0"/>
-              <a:t>Se houver tempo, abrir o protótipo e mostrar uma jornada. Se não, este slide fecha.</a:t>
+              <a:t>QUEM: Victor · TEMPO: 1 min
+O QUE DIZER
+"Para fechar: as stories de interface da Onda 1 estão navegáveis no protótipo do checkpoint anterior, cada uma no lugar indicado aqui. Elas ficam abertas no quadro até a validação com um gerente real, que é a Sprint 2."
+Entregáveis: "Repositório, pull request 15 revisado e com merge, as 14 Issues com o quadro, e os três documentos: backlog, arquitetura e planejamento. Tudo público."
+Próximo passo: "Sprint 2 valida as stories de interface. A otimização da rota, US12, entra na Sprint 3."
+"Obrigado. Perguntas?"
+Se houver tempo e o professor pedir, abrir o protótipo e mostrar uma jornada: selecionar agências de uma regional, informar origem e período, gerar a rota e abrir o detalhe de um trecho. Dois minutos, no máximo.
+DIVISÃO DA APRESENTAÇÃO
+Gabriel: slides 1 a 8 (12 min) · Luca: 9 a 13 (8 min) · Davi: 14 a 16 (5 min) · Victor: 17 a 19 (4 min). Total ~20 min; se o professor der 10, cortar as leituras de story e as divergências do Poker para uma só.</a:t>
             </a:r>
             <a:endParaRPr lang="en-US" dirty="0"/>
           </a:p>
@@ -1784,7 +1857,13 @@
           <a:p>
             <a:r>
               <a:rPr lang="en-US" dirty="0"/>
-              <a:t>Mostrar que nada foi criado do zero: o backlog nasce do Canvas, a arquitetura implementa as stories e o plano organiza o trabalho sobre essa arquitetura.</a:t>
+              <a:t>QUEM: Gabriel · TEMPO: 1 min
+O QUE DIZER
+"O checkpoint tem uma regra de rastreabilidade: cada etapa recebe a saída da anterior. Na Aula 3 saiu o Canvas, com a persona Rafael e as 8 funcionalidades da Onda 1. Na Aula 4 essas funcionalidades viraram 4 épicos e 14 user stories. Na Aula 5 as stories viraram quatro módulos de código, com 23 testes e um pull request revisado. Na Aula 6 isso virou uma WBS, estimativas, 7 riscos e a Sprint 1."
+Apontar a linha de baixo: "Um exemplo de ponta a ponta: a funcionalidade 'recomendar modal por trecho' do Canvas virou a US05, que é a Issue 5; ela está implementada nas classes Carro, Ônibus e Avião do serve.py; é o pacote 4.3 da WBS, entrou na Sprint 1, e tem teste automático."
+Fechar com a faixa: "O protótipo de interface do checkpoint anterior aparece só como evidência. O centro desta entrega são os três documentos: backlog, arquitetura e plano."
+PERGUNTA PROVÁVEL
+"Por que falar de protótipo então?" → Porque as stories de interface da Onda 1 já existem nele; o plano de sprints parte disso.</a:t>
             </a:r>
             <a:endParaRPr lang="en-US" dirty="0"/>
           </a:p>
@@ -1872,7 +1951,12 @@
           <a:p>
             <a:r>
               <a:rPr lang="en-US" dirty="0"/>
-              <a:t>A pergunta provável é por que dados e modelo não estão no topo. Resposta: eles são pré-requisito técnico, mas sozinhos não entregam valor ao Rafael.</a:t>
+              <a:t>QUEM: Gabriel · TEMPO: 1 min 30
+O QUE DIZER
+"Agrupamos as funcionalidades da Onda 1 em quatro épicos. E1 é montar o planejamento: selecionar agências, informar origem, período, restrições e objetivo. E2 é a recomendação: sequência, modal por trecho, detalhe. E3 é a avaliação: totais, economia, comparação com o cenário de referência e registro. E4 é o que sustenta tudo: dados de localização e o preço do combustível."
+Critério de priorização: "Ordenamos pelo valor para a hipótese do Canvas, que é: uma recomendação automática ajuda o gerente a planejar com menos esforço, custo e tempo. Primeiro vem o que testa a hipótese de ponta a ponta, US01 a US08, porque sem a jornada completa não dá para medir economia. Depois o que dá confiança ao resultado, US10 e US11. Por último o uso recorrente, US09. A Onda 2 só depois de validar a hipótese. Facilidade técnica não foi critério, como a Aula 4 pede; dependência técnica só desempata."
+PERGUNTA PROVÁVEL
+"Por que dados e modelo não estão no topo, se tudo depende deles?" → Eles vêm antes na ordem de construção, mas sozinhos não entregam nada ao Rafael. Prioridade é valor, não dependência.</a:t>
             </a:r>
             <a:endParaRPr lang="en-US" dirty="0"/>
           </a:p>
@@ -1960,7 +2044,14 @@
           <a:p>
             <a:r>
               <a:rPr lang="en-US" dirty="0"/>
-              <a:t>Cada linha é uma Issue no GitHub, com o mesmo número: a US05 é a Issue #5.</a:t>
+              <a:t>QUEM: Gabriel · TEMPO: 1 min 30
+O QUE DIZER
+"São 14 stories, todas do ponto de vista do Rafael, gerente regional, no formato Como/Quero/Para. A tabela está em ordem de prioridade. Cada linha mostra a funcionalidade do Canvas de onde a story veio: nenhuma story foi inventada fora do Canvas. US10 e US11 não vêm de uma funcionalidade diretamente, elas sustentam outras stories, por isso estão no épico de dados e modelos."
+Ler duas em voz alta, não mais: "US01: como Rafael, quero selecionar as agências da minha regional, para montar a viagem só com quem precisa de visita. US11: quero que o custo de carro use o preço do combustível do estado, para a estimativa refletir a região."
+Coluna Quadro: "A coluna Quadro é a coluna da Issue no GitHub Projects. US05, US10 e US11 estão em Concluído porque foram entregues na Sprint 1. As outras oito da Onda 1 estão navegáveis no protótipo, mas ficam abertas até a validação com um gerente real, na Sprint 2."
+Pontos: "Os pontos vêm do Planning Poker, que o Davi apresenta na Parte 3."
+PERGUNTA PROVÁVEL
+"Por que 14 e não 8?" → 8 era o mínimo. Cada funcionalidade do Canvas virou uma story pequena o suficiente para caber numa sprint; mais três de Onda 2 e duas de dados e modelo.</a:t>
             </a:r>
             <a:endParaRPr lang="en-US" dirty="0"/>
           </a:p>
@@ -2048,7 +2139,14 @@
           <a:p>
             <a:r>
               <a:rPr lang="en-US" dirty="0"/>
-              <a:t>As duas viraram teste automático. Se alguém perguntar como validar, a resposta é: rode python -m pytest.</a:t>
+              <a:t>QUEM: Gabriel · TEMPO: 1 min 30
+O QUE DIZER
+"O checkpoint pede ao menos uma story com critério de métrica de dados ou de modelo. Temos uma de cada."
+US10: "A base do Banco Central não tem latitude nem longitude. O critério diz: dado as 2.010 agências, quando o pipeline roda, então 100% têm pelo menos coordenada de município, pelo menos 70% têm de bairro, e nenhuma fica a mais de 30 km do centro do município. Resultado: 74,7% com bairro, 290 coordenadas descartadas pela regra dos 30 km."
+US11: "Dado a série semanal da ANP, com treino até dezembro de 2019, quando o modelo é avaliado em 2020 e 2021, que ele nunca viu, então o erro médio é de no máximo 15 centavos por litro e 25% abaixo do baseline, que é usar o preço nacional para todos os estados, com erro de 20 centavos. Resultado: 9,5 centavos, 52% abaixo."
+"Os dois critérios viraram testes automáticos: quem quiser validar roda python -m pytest."
+PERGUNTA PROVÁVEL
+"Por que 70% e 30 km?" → 70% porque a base de bairros é pública e incompleta, a meta tinha que ser alcançável. 30 km porque é onde a curva achata: abaixo descarta bairros certos, acima deixa passar colisões. O Luca mostra o teste de sensibilidade na Parte 2 se pedirem.</a:t>
             </a:r>
             <a:endParaRPr lang="en-US" dirty="0"/>
           </a:p>
@@ -2136,7 +2234,13 @@
           <a:p>
             <a:r>
               <a:rPr lang="en-US" dirty="0"/>
-              <a:t>Um INVEST todo aprovado levanta suspeita de que ninguém revisou. Mostrar as ressalvas é mostrar que a revisão aconteceu.</a:t>
+              <a:t>QUEM: Gabriel · TEMPO: 1 min
+O QUE DIZER
+"INVEST é o checklist de qualidade de story: independente, negociável, valiosa, estimável, pequena e testável. Revisamos as 14. Nove passaram nas seis letras. Cinco têm ressalva, e preferimos registrar a ressalva a deixar tudo verde."
+Escolher duas: "US04 e US06 dependem de outra story como entrada, mas a dependência é de dado, não de entrega: dá para testar com uma lista fixa. US12 podia não caber numa sprint; no Planning Poker o grupo limitou o escopo, vizinho mais próximo mais 2-opt, para caber em 8 pontos. US14 depende de uma fonte com publicação automática; os 5 pontos são ordem de grandeza."
+"Nenhuma precisou ser reescrita."
+PERGUNTA PROVÁVEL
+"Uma story com ressalva em três letras não devia ser reescrita?" → A US14 é Onda 2. Reescrever agora seria gastar esforço numa story que só entra depois de validar a hipótese. A ressalva fica registrada para a hora certa.</a:t>
             </a:r>
             <a:endParaRPr lang="en-US" dirty="0"/>
           </a:p>
@@ -2224,7 +2328,12 @@
           <a:p>
             <a:r>
               <a:rPr lang="en-US" dirty="0"/>
-              <a:t>Os não funcionais de ML da Aula 4 estão aqui: desempenho do modelo, drift, explicabilidade e LGPD.</a:t>
+              <a:t>QUEM: Gabriel · TEMPO: 1 min
+O QUE DIZER
+"Dez requisitos funcionais, cada um ligado às stories que o realizam. E oito não funcionais. Os quatro primeiros são os clássicos: desempenho, disponibilidade, explicabilidade e transparência. Os quatro últimos são os específicos de ML que a Aula 4 traz: desempenho do modelo, que é o MAE de até 15 centavos; robustez a drift, que é reavaliar a cada atualização da série, com alerta acima de 25 centavos; reprodutibilidade, com sementes fixas; e privacidade, nenhum dado pessoal no MVP."
+Não ler a tabela inteira. Apontar RNF03: "Explicabilidade importa aqui porque o Rafael precisa justificar a escolha do transporte ao gestor dele; por isso todo modal mostra o motivo e as alternativas."
+PERGUNTA PROVÁVEL
+"Por que 2 segundos?" → É o tempo de uma tela carregar sem o usuário achar que travou; o produto roda no navegador, sem servidor.</a:t>
             </a:r>
             <a:endParaRPr lang="en-US" dirty="0"/>
           </a:p>
@@ -2312,7 +2421,13 @@
           <a:p>
             <a:r>
               <a:rPr lang="en-US" dirty="0"/>
-              <a:t>O requisito de qualidade foi o que mais rendeu: foi validando-o que encontramos os dois defeitos da Parte 2.</a:t>
+              <a:t>QUEM: Gabriel · TEMPO: 1 min 30
+O QUE DIZER
+"Requisito de dados é o terceiro tipo, que só existe em projeto de ML. Fontes: cadastro de agências do Banco Central, série semanal de preços da ANP, bases públicas de municípios e bairros, e a base consolidada do grupo. Volume: 16.552 agências no país, 2.010 no recorte Itaú; 23.570 registros de gasolina comum em 27 estados. Qualidade: coordenada para 100%, bairro validado contra o município, texto padronizado, preços fora de escala descartados."
+Atualização, com honestidade: "A série da ANP que temos para em maio de 2021. Isso é uma limitação declarada: o modelo aprende a diferença de cada estado em relação à média nacional, que é mais estável que o preço em si, e a automatização da atualização é a US14."
+LGPD: "As bases são públicas e de pessoa jurídica. Prioridade e prazo de visita são simulados porque não existem em base pública. Em produção, a agenda e o histórico do gerente seriam dados pessoais, e aí precisaria de base legal e acesso mínimo. Isso está no risco R7."
+PERGUNTA PROVÁVEL
+"Por que não usar uma série mais recente?" → A ANP publica, mas em formato que muda; integrar é exatamente a US14, de Onda 2. Para o MVP, a diferença entre estados é o que importa, e ela é estável.</a:t>
             </a:r>
             <a:endParaRPr lang="en-US" dirty="0"/>
           </a:p>
@@ -2400,7 +2515,13 @@
           <a:p>
             <a:r>
               <a:rPr lang="en-US" dirty="0"/>
-              <a:t>Os três estágios da Aula 5 têm ciclos de vida diferentes. A preparação ficou separada da ingestão porque muda por motivo diferente.</a:t>
+              <a:t>QUEM: Luca · TEMPO: 1 min 30
+O QUE DIZER
+"A arquitetura de referência da Aula 5 tem três estágios: ingestão, treino e serving. Nós separamos um quarto, a preparação, porque ela muda por motivo diferente da ingestão. Cada estágio é um módulo. ingest.py carrega e valida, através da abstração DataSource. features.py monta as coordenadas em três níveis e os atributos do modelo. train.py treina o k-means das regionais e a regressão do preço. serve.py calcula custo e modal por trecho, aplica o preço por estado e monta o pacote que o protótipo lê."
+"O pipeline.py orquestra os quatro e é o único lugar que conhece os arquivos concretos. Os módulos nunca abrem um Excel diretamente."
+Tabela de baixo: "Treino e serving têm ciclos de vida diferentes: o treino roda por sprint ou quando a série de preços muda; o serving roda a cada planejamento. É por isso que não podem viver no mesmo código."
+PERGUNTA PROVÁVEL
+"Por que a preparação ficou separada?" → Se o Bacen mudar o formato do Excel, só ingest.py muda. Se mudarmos a regra dos 30 km, só features.py muda. Um motivo de mudança por módulo é o princípio de responsabilidade única.</a:t>
             </a:r>
             <a:endParaRPr lang="en-US" dirty="0"/>
           </a:p>

</xml_diff>

<commit_message>
Adiciona notas do apresentador em todos os slides (#23)
Claude-Session: https://claude.ai/code/session_01AxsLnikbU4P6aghAswDkjm

Co-authored-by: Claude <noreply@anthropic.com>
</commit_message>
<xml_diff>
--- a/docs/apresentacao-checkpoint-4-6.pptx
+++ b/docs/apresentacao-checkpoint-4-6.pptx
@@ -816,7 +816,11 @@
           <a:p>
             <a:r>
               <a:rPr lang="en-US" dirty="0"/>
-              <a:t>Abertura. Este checkpoint não é um trabalho novo: é o mesmo produto do Canvas MVP ganhando backlog, arquitetura e plano.</a:t>
+              <a:t>QUEM: Gabriel · TEMPO: 30 s
+O QUE DIZER
+"Boa noite. Somos o grupo do Sistema de Roteirização de Visitas às Agências: Davi, Gabriel, Luca e Victor. Este é o checkpoint das Aulas 4, 5 e 6. Não é um trabalho novo: é o mesmo produto do Canvas MVP ganhando backlog, arquitetura e plano de sprint. Tudo o que vamos mostrar está no repositório, no pull request 15 e no quadro do GitHub, que estão nos links da capa."
+NÃO FAZER
+Não ler os links em voz alta. Não explicar o protótipo aqui.</a:t>
             </a:r>
             <a:endParaRPr lang="en-US" dirty="0"/>
           </a:p>
@@ -904,7 +908,13 @@
           <a:p>
             <a:r>
               <a:rPr lang="en-US" dirty="0"/>
-              <a:t>Se só der tempo de explicar um, explicar o D, que é o que a Aula 5 pede nominalmente. O próximo slide mostra o código.</a:t>
+              <a:t>QUEM: Luca · TEMPO: 1 min 30
+O QUE DIZER
+"Os cinco princípios, com o problema concreto que cada um resolveu no nosso código."
+"S, responsabilidade única: antes, cada script numerado misturava leitura, transformação e cálculo; mudar o Excel mexia no mesmo arquivo que formava as regionais. O, aberto/fechado: um meio de transporte novo, como trem, entra como classe nova e comparar_modais não muda; temos um teste que prova isso. L, Liskov: os três estimadores de preço são intercambiáveis, o treino avalia os três com a mesma função e escolhe o melhor, sem if por tipo. I, segregação de interface: as interfaces têm um ou dois métodos, então um teste cria uma implementação falsa em três linhas. D, inversão de dependência: a carga e o treino não sabem se o dado vem de Excel, API ou memória."
+"Se o tempo apertar, o importante é o D, que é o que a Aula 5 pede nominalmente. O próximo slide mostra o código."
+PERGUNTA PROVÁVEL
+"Vocês aplicaram os cinco de propósito ou encaixaram depois?" → S e D foram o objetivo da refatoração. O, L e I apareceram naturalmente quando os modais e os estimadores viraram classes com o mesmo contrato; registramos porque resolveram problemas reais.</a:t>
             </a:r>
             <a:endParaRPr lang="en-US" dirty="0"/>
           </a:p>
@@ -992,7 +1002,14 @@
           <a:p>
             <a:r>
               <a:rPr lang="en-US" dirty="0"/>
-              <a:t>O teste test_fonte_em_memoria_substitui_o_excel é a prova executável de que a inversão funciona.</a:t>
+              <a:t>QUEM: Luca · TEMPO: 1 min 30
+O QUE DIZER
+"Este é o exemplo de inversão de dependência que a Aula 5 pede. À esquerda, em ingest.py, a abstração: DataSource é uma classe abstrata com um único método, load, que devolve uma tabela. A função carregar_agencias recebe um DataSource, não um caminho de arquivo. Ela não sabe de onde o dado vem."
+"À direita, duas fontes usando a mesma função. Em produção, o pipeline.py passa um ExcelSource com a planilha consolidada. No teste, passamos um MemorySource com uma tabela montada na hora, sem arquivo nenhum em disco."
+Faixa: "Trocar a planilha por uma API do Banco Central é escrever uma classe ApiBacenSource e mudar uma linha do pipeline.py. Treino e serving não mudam."
+Analogia, se ajudar: "É como uma tomada: o aparelho não sabe se a energia vem da rede, de um gerador ou de uma bateria. Ele só conhece o formato da tomada."
+PERGUNTA PROVÁVEL
+"Onde está a prova de que funciona?" → No teste test_fonte_em_memoria_substitui_o_excel, em tests/test_ingest.py.</a:t>
             </a:r>
             <a:endParaRPr lang="en-US" dirty="0"/>
           </a:p>
@@ -1080,7 +1097,14 @@
           <a:p>
             <a:r>
               <a:rPr lang="en-US" dirty="0"/>
-              <a:t>A Aula 5 pede para comparar a saída com a versão anterior. Reativar os defeitos isolou o efeito da reorganização do efeito das correções.</a:t>
+              <a:t>QUEM: Luca · TEMPO: 1 min 30
+O QUE DIZER
+"A Etapa 4 da Aula 5 pede que o pipeline refatorado produza a mesma saída da versão anterior. Mas durante a refatoração encontramos dois defeitos no código antigo. Se corrigíssemos e comparássemos, os números não bateriam e não daria para saber se a diferença era da reorganização ou da correção."
+"Então fizemos em dois passos. Primeiro, rodamos o código novo com os dois defeitos antigos reativados: 2.040 agências, 106 regionais, mesma mediana, mesma cobertura de bairro. Idêntico. Isso prova que a reorganização não mudou o comportamento."
+"Depois corrigimos. Defeito 1: o filtro de instituição procurava o trecho 'ITA' e trazia 30 registros que não são agências, como corretoras com 'CAPITAL' no nome. Correção: nome exato, 2.010 agências. Defeito 2: a regra que expande 'S.' para 'SÃO' transformava 'SANTA CATARINA' em 'SAO ANTA CATARINA'. Correção: só expande palavra inteira."
+"Versão final: 2.010 agências, 105 regionais, 74,7% com coordenada de bairro."
+PERGUNTA PROVÁVEL
+"Como vocês acharam os defeitos?" → Validando o requisito de qualidade dos dados: ao escrever o teste de que toda agência é do Itaú, apareceram as corretoras.</a:t>
             </a:r>
             <a:endParaRPr lang="en-US" dirty="0"/>
           </a:p>
@@ -1168,7 +1192,15 @@
           <a:p>
             <a:r>
               <a:rPr lang="en-US" dirty="0"/>
-              <a:t>O baseline é o que o sistema fazia antes: o mesmo preço para o Brasil inteiro. Por isso a comparação é honesta.</a:t>
+              <a:t>QUEM: Luca · TEMPO: 2 min
+O QUE DIZER
+"Este slide é a verificação do critério de métrica do modelo, da US11. O baseline é o que o sistema fazia antes: o mesmo preço de gasolina para o Brasil inteiro. Erro de 20 centavos por litro. Um modelo intermediário, que soma a diferença média histórica de cada estado, cai para 11,5. A regressão Ridge, que usa o estado, a diferença das últimas 52 semanas e o mês, chega a 9,5 centavos. 52% menos erro que o baseline, e dentro do critério de 15."
+Gráfico: "Mês a mês no período de teste. A linha de cima é o baseline, a de baixo é o modelo; a linha tracejada é o critério de 15 centavos. O modelo fica abaixo do critério o tempo todo."
+Validação temporal: "Treino até dezembro de 2019, teste de janeiro de 2020 em diante. Não embaralhamos as semanas. Se embaralhássemos, o modelo veria semanas futuras no treino e o resultado ficaria inflado. Escolhemos 2020 de propósito: a pandemia inteira fica no teste, que é o cenário mais difícil."
+Drift: "O erro sobe no choque de preços da pandemia e tem o pico em outubro de 2020. É o princípio CACE da Aula 4 aparecendo nos dados: o modelo foi ajustado num regime de preços e avaliado em outro. Por isso o RNF06 manda reavaliar a cada atualização."
+Limitação: "A série acaba em 2021. O produto aplica a diferença de cada estado sobre o preço nacional atual, que é informado por parâmetro ao rodar o pipeline."
+PERGUNTA PROVÁVEL
+"Por que Ridge e não algo mais sofisticado?" → O problema é pequeno e linear: diferença de estado mais sazonalidade. Ridge é interpretável, treina em segundos e já bateu o critério com folga. Modelo mais complexo só se o drift piorar.</a:t>
             </a:r>
             <a:endParaRPr lang="en-US" dirty="0"/>
           </a:p>
@@ -1256,7 +1288,14 @@
           <a:p>
             <a:r>
               <a:rPr lang="en-US" dirty="0"/>
-              <a:t>Mostrar o PR aberto no navegador, na aba Files changed, com os comentários de revisão.</a:t>
+              <a:t>QUEM: Davi · TEMPO: 1 min 30
+O QUE DIZER
+"A definição de pronto da Aula 5: módulos com responsabilidade única, inversão de dependência, pipeline validado e pull request revisado. 23 testes com pytest, um arquivo por módulo, cada um ligado a um critério de aceite. 14 commits pequenos no PR 15: um por módulo reorganizado, depois documentação e revisão. O pipeline inteiro roda em 8 segundos."
+Tabela: "test_features garante que Mirandópolis, a 530 km, é descartado. test_train garante que nenhuma regional fura o teto de 40 nem o piso de 4, e que o MAE fica abaixo de 15 centavos. test_serve garante que avião não aparece abaixo de 150 km e que um modal novo entra sem alterar código existente."
+Revisão, em primeira pessoa: "Eu fiz a revisão do PR, com três comentários. Primeiro: o preço nacional da gasolina estava fixo no código; foi corrigido, agora é parâmetro do pipeline. Segundo: perguntei por que o corte temporal em 2020; o Luca testou 2019, 2020 e julho de 2020 e a conclusão é a mesma em todos. Terceiro: perguntei por que 30 km; o teste de sensibilidade mostrou que o limite único prejudica municípios muito grandes, como o Rio, e isso virou a Issue 16, para a Sprint 2."
+Se der tempo, abrir o PR no navegador na aba Files changed e mostrar os comentários resolvidos.
+PERGUNTA PROVÁVEL
+"A revisão mudou o projeto?" → Sim: um parâmetro novo, um teste novo e uma Issue nova. Está tudo no PR.</a:t>
             </a:r>
             <a:endParaRPr lang="en-US" dirty="0"/>
           </a:p>
@@ -1344,7 +1383,13 @@
           <a:p>
             <a:r>
               <a:rPr lang="en-US" dirty="0"/>
-              <a:t>Nível 3, os entregáveis, está no documento docs/planejamento.md. No slide ficou o nível 2 e o 4, que é onde mora a rastreabilidade.</a:t>
+              <a:t>QUEM: Davi · TEMPO: 1 min 30
+O QUE DIZER
+"WBS, a estrutura analítica do projeto, em quatro níveis como a Aula 6 pede. Nível 1 é o projeto. Nível 2 são as fases do CRISP-DM, mais uma de gestão, como no estudo de caso da aula. Nível 3, os entregáveis de cada fase, está no documento. No slide ficou o nível 4, os pacotes de trabalho, porque é neles que mora a rastreabilidade: cada pacote aponta para a story de origem."
+Apontar: "Preparação tem quatro pacotes, todos da US10 e da US11. Modelagem tem o k-means da US01, os modelos de preço da US11, os modais da US05. Entrega são as telas do protótipo. Gestão tem o Planning Poker, a revisão do PR e a revisão dos riscos."
+Regra dos 100%: "Conferimos que as 14 stories aparecem em algum pacote e que nenhum pacote existe sem story, com uma exceção declarada: 7.3, revisar riscos, é transversal. A tabela de conferência está no planejamento.md."
+PERGUNTA PROVÁVEL
+"Por que 'Entrega' em vez de 'Implantação', que é a fase do CRISP-DM?" → No MVP não há implantação; a entrega é o protótipo navegável. Seguimos o estudo de caso da Aula 6, que também usa 'Entrega'.</a:t>
             </a:r>
             <a:endParaRPr lang="en-US" dirty="0"/>
           </a:p>
@@ -1432,7 +1477,13 @@
           <a:p>
             <a:r>
               <a:rPr lang="en-US" dirty="0"/>
-              <a:t>US04: o 3 via só ordenar; o 8 lembrou de quebrar em dias com teto e janela → 5. US09: reabrir planejamento antigo com base alterada → 5, com aviso em vez de reconciliar. US11: 13 pela incerteza; baseline já medido fechou em 8. US12: empate 8/13; escopo limitado a vizinho mais próximo + 2-opt para caber em 8.</a:t>
+              <a:t>QUEM: Davi · TEMPO: 2 min
+O QUE DIZER
+"Planning Poker em Fibonacci: 1, 2, 3, 5, 8, 13. A US01, selecionar agências, foi a referência com 3 pontos; as outras foram comparadas com ela. Votação simultânea, para ninguém se ancorar no colega."
+Contar as divergências, que é onde o Poker rende: "Na US04, os votos foram de 3 a 8. Quem deu 3 pensava só em ordenar as agências; quem deu 8 lembrou que a sequência tem que ser quebrada em dias respeitando o teto de horas e a janela. Fechou em 5. Na US09, de 3 a 8: o 8 incluía reabrir um planejamento antigo depois que a base de agências mudou. Fechou em 5, com a decisão de mostrar um aviso em vez de tentar reconciliar. Na US11, de 5 a 13: o 13 era a incerteza de um modelo não testado; o argumento que fechou em 8 foi que o baseline já tinha sido medido, então a meta era conhecida. Na US12, empate entre 8 e 13: em vez de dividir, limitamos o escopo a vizinho mais próximo mais 2-opt."
+Capacidade: "4 pessoas, sprints de 2 semanas, velocidade assumida de 20 pontos. É hipótese: todos conciliam o projeto com outras disciplinas. Backlog de 58 pontos, previsão de 4 sprints. A velocidade real da Sprint 1 recalibra isso."
+PERGUNTA PROVÁVEL
+"Por que 20 pontos?" → Velocidade inicial é sempre hipótese; 20 é razoável para 4 pessoas em meio período, e a Sprint 1 entregou 19, o que confirma a ordem de grandeza.</a:t>
             </a:r>
             <a:endParaRPr lang="en-US" dirty="0"/>
           </a:p>
@@ -1520,7 +1571,14 @@
           <a:p>
             <a:r>
               <a:rPr lang="en-US" dirty="0"/>
-              <a:t>R3 é o único vermelho de nota 9. Ele se resolve com a área de negócio, por isso a resposta é transferir.</a:t>
+              <a:t>QUEM: Victor · TEMPO: 2 min
+O QUE DIZER
+"Sete riscos, com probabilidade e impacto de baixo a alto, exposição é o produto dos dois. Três de dados, dois de modelo, um de prazo e um de privacidade. Cada um tem resposta e dono."
+Os dois mais importantes: "R3 é o único de nota 9: prioridade e periodicidade de visita não existem em base pública. A resposta é transferir: no piloto, a área de negócio fornece o dado; até lá, os campos são simulados e declarados como tal na interface. R1, coordenada errada por colisão de nome de bairro, é mitigado pela regra dos 30 km e por um teste automático; a revisão do PR mostrou que a regra ainda tem um ponto cego nos municípios muito grandes, que virou a Issue 16."
+Resposta por tipo: "R5, rotas com ida e volta, aceitamos: está declarado na interface e a otimização é a US12. R7, agenda do gerente como dado pessoal, evitamos: o MVP não trata dado pessoal."
+Donos: "Cada integrante é dono dos riscos da frente que conduz: Gabriel na base de agências, Luca no modelo, eu no negócio e na rota, Davi no prazo e no repositório. A matriz é revisada a cada sprint, pacote 7.3."
+PERGUNTA PROVÁVEL
+"Por que R2, série antiga, é só médio de impacto?" → Porque o modelo usa a diferença entre estados, não o nível de preço, e a diferença é estável. Se fosse o nível, seria alto.</a:t>
             </a:r>
             <a:endParaRPr lang="en-US" dirty="0"/>
           </a:p>
@@ -1608,7 +1666,14 @@
           <a:p>
             <a:r>
               <a:rPr lang="en-US" dirty="0"/>
-              <a:t>Explicar a escolha honestamente: não faria sentido planejar construir de novo telas que já existem.</a:t>
+              <a:t>QUEM: Victor · TEMPO: 1 min 30
+O QUE DIZER
+"Meta da Sprint 1: transformar a base de agências e o custo de deslocamento num pipeline modular e testado, com o preço por estado validado contra o baseline. Capacidade de 20 pontos; selecionamos 19: US10 com 5, US11 com 8, US05 com 3, e testes com PR revisado com 3. Cada item tem um dono e os pacotes da WBS que cobre."
+Por que estas e não as do topo da prioridade, antecipar a pergunta: "A Aula 6 diz para puxar do topo do backlog. O topo é US01 a US08, que são as stories de interface, e elas já estavam navegáveis no protótipo do checkpoint anterior. Não faria sentido planejar uma sprint para construir telas que já existem. A Sprint 1 atacou o que sustenta os números que o protótipo mostra: localização, preço e modal. A Sprint 2 volta ao topo para validar as stories de interface com um gerente real."
+Definição de pronto: "Critério de aceite verificado, de preferência por teste; código no módulo certo; PR revisado por outro integrante; pipeline rodando de ponta a ponta. Os quatro itens foram entregues."
+Riscos monitorados: R1, R2, R4 e R6.
+PERGUNTA PROVÁVEL
+"A sprint já aconteceu? O checkpoint pedia o plano." → O plano foi feito na Aula 6 e a sprint rodou entre a Aula 6 e hoje. Mostramos o plano e o resultado porque o resultado é a prova de que a capacidade era realista.</a:t>
             </a:r>
             <a:endParaRPr lang="en-US" dirty="0"/>
           </a:p>
@@ -1696,7 +1761,15 @@
           <a:p>
             <a:r>
               <a:rPr lang="en-US" dirty="0"/>
-              <a:t>Se houver tempo, abrir o protótipo e mostrar uma jornada. Se não, este slide fecha.</a:t>
+              <a:t>QUEM: Victor · TEMPO: 1 min
+O QUE DIZER
+"Para fechar: as stories de interface da Onda 1 estão navegáveis no protótipo do checkpoint anterior, cada uma no lugar indicado aqui. Elas ficam abertas no quadro até a validação com um gerente real, que é a Sprint 2."
+Entregáveis: "Repositório, pull request 15 revisado e com merge, as 14 Issues com o quadro, e os três documentos: backlog, arquitetura e planejamento. Tudo público."
+Próximo passo: "Sprint 2 valida as stories de interface. A otimização da rota, US12, entra na Sprint 3."
+"Obrigado. Perguntas?"
+Se houver tempo e o professor pedir, abrir o protótipo e mostrar uma jornada: selecionar agências de uma regional, informar origem e período, gerar a rota e abrir o detalhe de um trecho. Dois minutos, no máximo.
+DIVISÃO DA APRESENTAÇÃO
+Gabriel: slides 1 a 8 (12 min) · Luca: 9 a 13 (8 min) · Davi: 14 a 16 (5 min) · Victor: 17 a 19 (4 min). Total ~20 min; se o professor der 10, cortar as leituras de story e as divergências do Poker para uma só.</a:t>
             </a:r>
             <a:endParaRPr lang="en-US" dirty="0"/>
           </a:p>
@@ -1784,7 +1857,13 @@
           <a:p>
             <a:r>
               <a:rPr lang="en-US" dirty="0"/>
-              <a:t>Mostrar que nada foi criado do zero: o backlog nasce do Canvas, a arquitetura implementa as stories e o plano organiza o trabalho sobre essa arquitetura.</a:t>
+              <a:t>QUEM: Gabriel · TEMPO: 1 min
+O QUE DIZER
+"O checkpoint tem uma regra de rastreabilidade: cada etapa recebe a saída da anterior. Na Aula 3 saiu o Canvas, com a persona Rafael e as 8 funcionalidades da Onda 1. Na Aula 4 essas funcionalidades viraram 4 épicos e 14 user stories. Na Aula 5 as stories viraram quatro módulos de código, com 23 testes e um pull request revisado. Na Aula 6 isso virou uma WBS, estimativas, 7 riscos e a Sprint 1."
+Apontar a linha de baixo: "Um exemplo de ponta a ponta: a funcionalidade 'recomendar modal por trecho' do Canvas virou a US05, que é a Issue 5; ela está implementada nas classes Carro, Ônibus e Avião do serve.py; é o pacote 4.3 da WBS, entrou na Sprint 1, e tem teste automático."
+Fechar com a faixa: "O protótipo de interface do checkpoint anterior aparece só como evidência. O centro desta entrega são os três documentos: backlog, arquitetura e plano."
+PERGUNTA PROVÁVEL
+"Por que falar de protótipo então?" → Porque as stories de interface da Onda 1 já existem nele; o plano de sprints parte disso.</a:t>
             </a:r>
             <a:endParaRPr lang="en-US" dirty="0"/>
           </a:p>
@@ -1872,7 +1951,12 @@
           <a:p>
             <a:r>
               <a:rPr lang="en-US" dirty="0"/>
-              <a:t>A pergunta provável é por que dados e modelo não estão no topo. Resposta: eles são pré-requisito técnico, mas sozinhos não entregam valor ao Rafael.</a:t>
+              <a:t>QUEM: Gabriel · TEMPO: 1 min 30
+O QUE DIZER
+"Agrupamos as funcionalidades da Onda 1 em quatro épicos. E1 é montar o planejamento: selecionar agências, informar origem, período, restrições e objetivo. E2 é a recomendação: sequência, modal por trecho, detalhe. E3 é a avaliação: totais, economia, comparação com o cenário de referência e registro. E4 é o que sustenta tudo: dados de localização e o preço do combustível."
+Critério de priorização: "Ordenamos pelo valor para a hipótese do Canvas, que é: uma recomendação automática ajuda o gerente a planejar com menos esforço, custo e tempo. Primeiro vem o que testa a hipótese de ponta a ponta, US01 a US08, porque sem a jornada completa não dá para medir economia. Depois o que dá confiança ao resultado, US10 e US11. Por último o uso recorrente, US09. A Onda 2 só depois de validar a hipótese. Facilidade técnica não foi critério, como a Aula 4 pede; dependência técnica só desempata."
+PERGUNTA PROVÁVEL
+"Por que dados e modelo não estão no topo, se tudo depende deles?" → Eles vêm antes na ordem de construção, mas sozinhos não entregam nada ao Rafael. Prioridade é valor, não dependência.</a:t>
             </a:r>
             <a:endParaRPr lang="en-US" dirty="0"/>
           </a:p>
@@ -1960,7 +2044,14 @@
           <a:p>
             <a:r>
               <a:rPr lang="en-US" dirty="0"/>
-              <a:t>Cada linha é uma Issue no GitHub, com o mesmo número: a US05 é a Issue #5.</a:t>
+              <a:t>QUEM: Gabriel · TEMPO: 1 min 30
+O QUE DIZER
+"São 14 stories, todas do ponto de vista do Rafael, gerente regional, no formato Como/Quero/Para. A tabela está em ordem de prioridade. Cada linha mostra a funcionalidade do Canvas de onde a story veio: nenhuma story foi inventada fora do Canvas. US10 e US11 não vêm de uma funcionalidade diretamente, elas sustentam outras stories, por isso estão no épico de dados e modelos."
+Ler duas em voz alta, não mais: "US01: como Rafael, quero selecionar as agências da minha regional, para montar a viagem só com quem precisa de visita. US11: quero que o custo de carro use o preço do combustível do estado, para a estimativa refletir a região."
+Coluna Quadro: "A coluna Quadro é a coluna da Issue no GitHub Projects. US05, US10 e US11 estão em Concluído porque foram entregues na Sprint 1. As outras oito da Onda 1 estão navegáveis no protótipo, mas ficam abertas até a validação com um gerente real, na Sprint 2."
+Pontos: "Os pontos vêm do Planning Poker, que o Davi apresenta na Parte 3."
+PERGUNTA PROVÁVEL
+"Por que 14 e não 8?" → 8 era o mínimo. Cada funcionalidade do Canvas virou uma story pequena o suficiente para caber numa sprint; mais três de Onda 2 e duas de dados e modelo.</a:t>
             </a:r>
             <a:endParaRPr lang="en-US" dirty="0"/>
           </a:p>
@@ -2048,7 +2139,14 @@
           <a:p>
             <a:r>
               <a:rPr lang="en-US" dirty="0"/>
-              <a:t>As duas viraram teste automático. Se alguém perguntar como validar, a resposta é: rode python -m pytest.</a:t>
+              <a:t>QUEM: Gabriel · TEMPO: 1 min 30
+O QUE DIZER
+"O checkpoint pede ao menos uma story com critério de métrica de dados ou de modelo. Temos uma de cada."
+US10: "A base do Banco Central não tem latitude nem longitude. O critério diz: dado as 2.010 agências, quando o pipeline roda, então 100% têm pelo menos coordenada de município, pelo menos 70% têm de bairro, e nenhuma fica a mais de 30 km do centro do município. Resultado: 74,7% com bairro, 290 coordenadas descartadas pela regra dos 30 km."
+US11: "Dado a série semanal da ANP, com treino até dezembro de 2019, quando o modelo é avaliado em 2020 e 2021, que ele nunca viu, então o erro médio é de no máximo 15 centavos por litro e 25% abaixo do baseline, que é usar o preço nacional para todos os estados, com erro de 20 centavos. Resultado: 9,5 centavos, 52% abaixo."
+"Os dois critérios viraram testes automáticos: quem quiser validar roda python -m pytest."
+PERGUNTA PROVÁVEL
+"Por que 70% e 30 km?" → 70% porque a base de bairros é pública e incompleta, a meta tinha que ser alcançável. 30 km porque é onde a curva achata: abaixo descarta bairros certos, acima deixa passar colisões. O Luca mostra o teste de sensibilidade na Parte 2 se pedirem.</a:t>
             </a:r>
             <a:endParaRPr lang="en-US" dirty="0"/>
           </a:p>
@@ -2136,7 +2234,13 @@
           <a:p>
             <a:r>
               <a:rPr lang="en-US" dirty="0"/>
-              <a:t>Um INVEST todo aprovado levanta suspeita de que ninguém revisou. Mostrar as ressalvas é mostrar que a revisão aconteceu.</a:t>
+              <a:t>QUEM: Gabriel · TEMPO: 1 min
+O QUE DIZER
+"INVEST é o checklist de qualidade de story: independente, negociável, valiosa, estimável, pequena e testável. Revisamos as 14. Nove passaram nas seis letras. Cinco têm ressalva, e preferimos registrar a ressalva a deixar tudo verde."
+Escolher duas: "US04 e US06 dependem de outra story como entrada, mas a dependência é de dado, não de entrega: dá para testar com uma lista fixa. US12 podia não caber numa sprint; no Planning Poker o grupo limitou o escopo, vizinho mais próximo mais 2-opt, para caber em 8 pontos. US14 depende de uma fonte com publicação automática; os 5 pontos são ordem de grandeza."
+"Nenhuma precisou ser reescrita."
+PERGUNTA PROVÁVEL
+"Uma story com ressalva em três letras não devia ser reescrita?" → A US14 é Onda 2. Reescrever agora seria gastar esforço numa story que só entra depois de validar a hipótese. A ressalva fica registrada para a hora certa.</a:t>
             </a:r>
             <a:endParaRPr lang="en-US" dirty="0"/>
           </a:p>
@@ -2224,7 +2328,12 @@
           <a:p>
             <a:r>
               <a:rPr lang="en-US" dirty="0"/>
-              <a:t>Os não funcionais de ML da Aula 4 estão aqui: desempenho do modelo, drift, explicabilidade e LGPD.</a:t>
+              <a:t>QUEM: Gabriel · TEMPO: 1 min
+O QUE DIZER
+"Dez requisitos funcionais, cada um ligado às stories que o realizam. E oito não funcionais. Os quatro primeiros são os clássicos: desempenho, disponibilidade, explicabilidade e transparência. Os quatro últimos são os específicos de ML que a Aula 4 traz: desempenho do modelo, que é o MAE de até 15 centavos; robustez a drift, que é reavaliar a cada atualização da série, com alerta acima de 25 centavos; reprodutibilidade, com sementes fixas; e privacidade, nenhum dado pessoal no MVP."
+Não ler a tabela inteira. Apontar RNF03: "Explicabilidade importa aqui porque o Rafael precisa justificar a escolha do transporte ao gestor dele; por isso todo modal mostra o motivo e as alternativas."
+PERGUNTA PROVÁVEL
+"Por que 2 segundos?" → É o tempo de uma tela carregar sem o usuário achar que travou; o produto roda no navegador, sem servidor.</a:t>
             </a:r>
             <a:endParaRPr lang="en-US" dirty="0"/>
           </a:p>
@@ -2312,7 +2421,13 @@
           <a:p>
             <a:r>
               <a:rPr lang="en-US" dirty="0"/>
-              <a:t>O requisito de qualidade foi o que mais rendeu: foi validando-o que encontramos os dois defeitos da Parte 2.</a:t>
+              <a:t>QUEM: Gabriel · TEMPO: 1 min 30
+O QUE DIZER
+"Requisito de dados é o terceiro tipo, que só existe em projeto de ML. Fontes: cadastro de agências do Banco Central, série semanal de preços da ANP, bases públicas de municípios e bairros, e a base consolidada do grupo. Volume: 16.552 agências no país, 2.010 no recorte Itaú; 23.570 registros de gasolina comum em 27 estados. Qualidade: coordenada para 100%, bairro validado contra o município, texto padronizado, preços fora de escala descartados."
+Atualização, com honestidade: "A série da ANP que temos para em maio de 2021. Isso é uma limitação declarada: o modelo aprende a diferença de cada estado em relação à média nacional, que é mais estável que o preço em si, e a automatização da atualização é a US14."
+LGPD: "As bases são públicas e de pessoa jurídica. Prioridade e prazo de visita são simulados porque não existem em base pública. Em produção, a agenda e o histórico do gerente seriam dados pessoais, e aí precisaria de base legal e acesso mínimo. Isso está no risco R7."
+PERGUNTA PROVÁVEL
+"Por que não usar uma série mais recente?" → A ANP publica, mas em formato que muda; integrar é exatamente a US14, de Onda 2. Para o MVP, a diferença entre estados é o que importa, e ela é estável.</a:t>
             </a:r>
             <a:endParaRPr lang="en-US" dirty="0"/>
           </a:p>
@@ -2400,7 +2515,13 @@
           <a:p>
             <a:r>
               <a:rPr lang="en-US" dirty="0"/>
-              <a:t>Os três estágios da Aula 5 têm ciclos de vida diferentes. A preparação ficou separada da ingestão porque muda por motivo diferente.</a:t>
+              <a:t>QUEM: Luca · TEMPO: 1 min 30
+O QUE DIZER
+"A arquitetura de referência da Aula 5 tem três estágios: ingestão, treino e serving. Nós separamos um quarto, a preparação, porque ela muda por motivo diferente da ingestão. Cada estágio é um módulo. ingest.py carrega e valida, através da abstração DataSource. features.py monta as coordenadas em três níveis e os atributos do modelo. train.py treina o k-means das regionais e a regressão do preço. serve.py calcula custo e modal por trecho, aplica o preço por estado e monta o pacote que o protótipo lê."
+"O pipeline.py orquestra os quatro e é o único lugar que conhece os arquivos concretos. Os módulos nunca abrem um Excel diretamente."
+Tabela de baixo: "Treino e serving têm ciclos de vida diferentes: o treino roda por sprint ou quando a série de preços muda; o serving roda a cada planejamento. É por isso que não podem viver no mesmo código."
+PERGUNTA PROVÁVEL
+"Por que a preparação ficou separada?" → Se o Bacen mudar o formato do Excel, só ingest.py muda. Se mudarmos a regra dos 30 km, só features.py muda. Um motivo de mudança por módulo é o princípio de responsabilidade única.</a:t>
             </a:r>
             <a:endParaRPr lang="en-US" dirty="0"/>
           </a:p>

</xml_diff>

<commit_message>
Adiciona notebook dos modelos executável no Google Colab
notebooks/modelos.ipynb reproduz o k-means das regionais (US01) e a
regressão Ridge do preço por estado (US11) com o mesmo código de src/,
a partir de dois recortes pequenos versionados em dados/colab/, e no fim
clona o repositório e roda os testes. O teste da US11 passa a usar esse
recorte quando a série bruta da ANP não está baixada. Link no README, no
docs/arquitetura.md e na apresentação.

Co-Authored-By: Claude Fable 5.1 <noreply@anthropic.com>
Claude-Session: https://claude.ai/code/session_01AxsLnikbU4P6aghAswDkjm
</commit_message>
<xml_diff>
--- a/docs/apresentacao-checkpoint-4-6.pptx
+++ b/docs/apresentacao-checkpoint-4-6.pptx
@@ -1764,7 +1764,7 @@
               <a:t>QUEM: Victor · TEMPO: 1 min
 O QUE DIZER
 "Para fechar: as stories de interface da Onda 1 estão navegáveis no protótipo do checkpoint anterior, cada uma no lugar indicado aqui. Elas ficam abertas no quadro até a validação com um gerente real, que é a Sprint 2."
-Entregáveis: "Repositório, pull request 15 revisado e com merge, as 14 Issues com o quadro, e os três documentos: backlog, arquitetura e planejamento. Tudo público."
+Entregáveis: "Repositório, pull request 15 revisado e com merge, as 14 Issues com o quadro, os três documentos: backlog, arquitetura e planejamento, e um notebook no Google Colab que reproduz os dois modelos e roda os testes. Tudo público."
 Próximo passo: "Sprint 2 valida as stories de interface. A otimização da rota, US12, entra na Sprint 3."
 "Obrigado. Perguntas?"
 Se houver tempo e o professor pedir, abrir o protótipo e mostrar uma jornada: selecionar agências de uma regional, informar origem e período, gerar a rota e abrir o detalhe de um trecho. Dois minutos, no máximo.
@@ -3120,8 +3120,8 @@
         </p:nvSpPr>
         <p:spPr>
           <a:xfrm>
-            <a:off x="548640" y="4754880"/>
-            <a:ext cx="10515600" cy="1005840"/>
+            <a:off x="548640" y="4663440"/>
+            <a:ext cx="10972800" cy="1280160"/>
           </a:xfrm>
           <a:prstGeom prst="rect">
             <a:avLst/>
@@ -3240,6 +3240,43 @@
                 <a:cs typeface="Calibri" pitchFamily="34" charset="-120"/>
               </a:rPr>
               <a:t>Issues #1 a #14 · quadro em github.com/users/davi-cassiano/projects/1</a:t>
+            </a:r>
+            <a:endParaRPr lang="en-US" sz="1200" dirty="0"/>
+          </a:p>
+          <a:p>
+            <a:pPr indent="0" marL="0">
+              <a:spcAft>
+                <a:spcPts val="400"/>
+              </a:spcAft>
+              <a:buNone/>
+            </a:pPr>
+            <a:r>
+              <a:rPr lang="en-US" sz="1200" b="1" dirty="0">
+                <a:solidFill>
+                  <a:srgbClr val="7FC4B4"/>
+                </a:solidFill>
+                <a:latin typeface="Calibri" pitchFamily="34" charset="0"/>
+                <a:ea typeface="Calibri" pitchFamily="34" charset="-122"/>
+                <a:cs typeface="Calibri" pitchFamily="34" charset="-120"/>
+              </a:rPr>
+              <a:t>Notebook  </a:t>
+            </a:r>
+            <a:pPr indent="0" marL="0">
+              <a:spcAft>
+                <a:spcPts val="400"/>
+              </a:spcAft>
+              <a:buNone/>
+            </a:pPr>
+            <a:r>
+              <a:rPr lang="en-US" sz="1200" dirty="0">
+                <a:solidFill>
+                  <a:srgbClr val="CFE0EC"/>
+                </a:solidFill>
+                <a:latin typeface="Calibri" pitchFamily="34" charset="0"/>
+                <a:ea typeface="Calibri" pitchFamily="34" charset="-122"/>
+                <a:cs typeface="Calibri" pitchFamily="34" charset="-120"/>
+              </a:rPr>
+              <a:t>colab.research.google.com/github/davi-cassiano/Projeto-Varela/blob/main/notebooks/modelos.ipynb</a:t>
             </a:r>
             <a:endParaRPr lang="en-US" sz="1200" dirty="0"/>
           </a:p>
@@ -8285,8 +8322,8 @@
         </p:nvSpPr>
         <p:spPr>
           <a:xfrm>
-            <a:off x="548640" y="5029200"/>
-            <a:ext cx="11064240" cy="1371600"/>
+            <a:off x="548640" y="4983480"/>
+            <a:ext cx="11064240" cy="1463040"/>
           </a:xfrm>
           <a:prstGeom prst="rect">
             <a:avLst/>
@@ -8300,12 +8337,12 @@
           <a:p>
             <a:pPr indent="0" marL="0">
               <a:spcAft>
-                <a:spcPts val="400"/>
+                <a:spcPts val="300"/>
               </a:spcAft>
               <a:buNone/>
             </a:pPr>
             <a:r>
-              <a:rPr lang="en-US" sz="1150" b="1" dirty="0">
+              <a:rPr lang="en-US" sz="1100" b="1" dirty="0">
                 <a:solidFill>
                   <a:srgbClr val="12263A"/>
                 </a:solidFill>
@@ -8317,12 +8354,12 @@
             </a:r>
             <a:pPr indent="0" marL="0">
               <a:spcAft>
-                <a:spcPts val="400"/>
+                <a:spcPts val="300"/>
               </a:spcAft>
               <a:buNone/>
             </a:pPr>
             <a:r>
-              <a:rPr lang="en-US" sz="1150" dirty="0">
+              <a:rPr lang="en-US" sz="1100" dirty="0">
                 <a:solidFill>
                   <a:srgbClr val="5A7185"/>
                 </a:solidFill>
@@ -8332,17 +8369,17 @@
               </a:rPr>
               <a:t>o treino vai até dez/2019 e o teste começa em jan/2020. Embaralhar deixaria o modelo ver semanas futuras e inflaria o resultado.</a:t>
             </a:r>
-            <a:endParaRPr lang="en-US" sz="1150" dirty="0"/>
+            <a:endParaRPr lang="en-US" sz="1100" dirty="0"/>
           </a:p>
           <a:p>
             <a:pPr indent="0" marL="0">
               <a:spcAft>
-                <a:spcPts val="400"/>
+                <a:spcPts val="300"/>
               </a:spcAft>
               <a:buNone/>
             </a:pPr>
             <a:r>
-              <a:rPr lang="en-US" sz="1150" b="1" dirty="0">
+              <a:rPr lang="en-US" sz="1100" b="1" dirty="0">
                 <a:solidFill>
                   <a:srgbClr val="12263A"/>
                 </a:solidFill>
@@ -8354,12 +8391,12 @@
             </a:r>
             <a:pPr indent="0" marL="0">
               <a:spcAft>
-                <a:spcPts val="400"/>
+                <a:spcPts val="300"/>
               </a:spcAft>
               <a:buNone/>
             </a:pPr>
             <a:r>
-              <a:rPr lang="en-US" sz="1150" dirty="0">
+              <a:rPr lang="en-US" sz="1100" dirty="0">
                 <a:solidFill>
                   <a:srgbClr val="5A7185"/>
                 </a:solidFill>
@@ -8369,17 +8406,17 @@
               </a:rPr>
               <a:t>o erro sobe no choque de preços da pandemia e chega ao pico em out/2020 — o princípio CACE da Aula 4 aparecendo nos dados.</a:t>
             </a:r>
-            <a:endParaRPr lang="en-US" sz="1150" dirty="0"/>
+            <a:endParaRPr lang="en-US" sz="1100" dirty="0"/>
           </a:p>
           <a:p>
             <a:pPr indent="0" marL="0">
               <a:spcAft>
-                <a:spcPts val="400"/>
+                <a:spcPts val="300"/>
               </a:spcAft>
               <a:buNone/>
             </a:pPr>
             <a:r>
-              <a:rPr lang="en-US" sz="1150" b="1" dirty="0">
+              <a:rPr lang="en-US" sz="1100" b="1" dirty="0">
                 <a:solidFill>
                   <a:srgbClr val="9A5B12"/>
                 </a:solidFill>
@@ -8391,12 +8428,12 @@
             </a:r>
             <a:pPr indent="0" marL="0">
               <a:spcAft>
-                <a:spcPts val="400"/>
+                <a:spcPts val="300"/>
               </a:spcAft>
               <a:buNone/>
             </a:pPr>
             <a:r>
-              <a:rPr lang="en-US" sz="1150" dirty="0">
+              <a:rPr lang="en-US" sz="1100" dirty="0">
                 <a:solidFill>
                   <a:srgbClr val="5A7185"/>
                 </a:solidFill>
@@ -8406,7 +8443,44 @@
               </a:rPr>
               <a:t>a série acaba em 2021; o produto aplica a diferença de cada estado sobre o preço nacional atual.</a:t>
             </a:r>
-            <a:endParaRPr lang="en-US" sz="1150" dirty="0"/>
+            <a:endParaRPr lang="en-US" sz="1100" dirty="0"/>
+          </a:p>
+          <a:p>
+            <a:pPr indent="0" marL="0">
+              <a:spcAft>
+                <a:spcPts val="300"/>
+              </a:spcAft>
+              <a:buNone/>
+            </a:pPr>
+            <a:r>
+              <a:rPr lang="en-US" sz="1100" b="1" dirty="0">
+                <a:solidFill>
+                  <a:srgbClr val="0E7C66"/>
+                </a:solidFill>
+                <a:latin typeface="Calibri" pitchFamily="34" charset="0"/>
+                <a:ea typeface="Calibri" pitchFamily="34" charset="-122"/>
+                <a:cs typeface="Calibri" pitchFamily="34" charset="-120"/>
+              </a:rPr>
+              <a:t>Reproduzir: </a:t>
+            </a:r>
+            <a:pPr indent="0" marL="0">
+              <a:spcAft>
+                <a:spcPts val="300"/>
+              </a:spcAft>
+              <a:buNone/>
+            </a:pPr>
+            <a:r>
+              <a:rPr lang="en-US" sz="1100" dirty="0">
+                <a:solidFill>
+                  <a:srgbClr val="5A7185"/>
+                </a:solidFill>
+                <a:latin typeface="Calibri" pitchFamily="34" charset="0"/>
+                <a:ea typeface="Calibri" pitchFamily="34" charset="-122"/>
+                <a:cs typeface="Calibri" pitchFamily="34" charset="-120"/>
+              </a:rPr>
+              <a:t>k-means e regressão rodam no Google Colab, com os mesmos dados e testes — colab.research.google.com/github/davi-cassiano/Projeto-Varela/blob/main/notebooks/modelos.ipynb</a:t>
+            </a:r>
+            <a:endParaRPr lang="en-US" sz="1100" dirty="0"/>
           </a:p>
         </p:txBody>
       </p:sp>
@@ -21479,8 +21553,8 @@
         </p:nvSpPr>
         <p:spPr>
           <a:xfrm>
-            <a:off x="7818120" y="2240280"/>
-            <a:ext cx="3657600" cy="2926080"/>
+            <a:off x="7818120" y="2194560"/>
+            <a:ext cx="3657600" cy="3017520"/>
           </a:xfrm>
           <a:prstGeom prst="rect">
             <a:avLst/>
@@ -21496,7 +21570,7 @@
               <a:buNone/>
             </a:pPr>
             <a:r>
-              <a:rPr lang="en-US" sz="1100" b="1" dirty="0">
+              <a:rPr lang="en-US" sz="1050" b="1" dirty="0">
                 <a:solidFill>
                   <a:srgbClr val="7FC4B4"/>
                 </a:solidFill>
@@ -21506,14 +21580,14 @@
               </a:rPr>
               <a:t>Repositório</a:t>
             </a:r>
-            <a:endParaRPr lang="en-US" sz="1100" dirty="0"/>
+            <a:endParaRPr lang="en-US" sz="1050" dirty="0"/>
           </a:p>
           <a:p>
             <a:pPr indent="0" marL="0">
               <a:buNone/>
             </a:pPr>
             <a:r>
-              <a:rPr lang="en-US" sz="1100" dirty="0">
+              <a:rPr lang="en-US" sz="1050" dirty="0">
                 <a:solidFill>
                   <a:srgbClr val="CFE0EC"/>
                 </a:solidFill>
@@ -21523,14 +21597,14 @@
               </a:rPr>
               <a:t>github.com/davi-cassiano/Projeto-Varela</a:t>
             </a:r>
-            <a:endParaRPr lang="en-US" sz="1100" dirty="0"/>
+            <a:endParaRPr lang="en-US" sz="1050" dirty="0"/>
           </a:p>
           <a:p>
             <a:pPr indent="0" marL="0">
               <a:buNone/>
             </a:pPr>
             <a:r>
-              <a:rPr lang="en-US" sz="1100" dirty="0">
+              <a:rPr lang="en-US" sz="1050" dirty="0">
                 <a:solidFill>
                   <a:srgbClr val="CFE0EC"/>
                 </a:solidFill>
@@ -21540,14 +21614,14 @@
               </a:rPr>
               <a:t> </a:t>
             </a:r>
-            <a:endParaRPr lang="en-US" sz="1100" dirty="0"/>
+            <a:endParaRPr lang="en-US" sz="1050" dirty="0"/>
           </a:p>
           <a:p>
             <a:pPr indent="0" marL="0">
               <a:buNone/>
             </a:pPr>
             <a:r>
-              <a:rPr lang="en-US" sz="1100" b="1" dirty="0">
+              <a:rPr lang="en-US" sz="1050" b="1" dirty="0">
                 <a:solidFill>
                   <a:srgbClr val="7FC4B4"/>
                 </a:solidFill>
@@ -21557,14 +21631,14 @@
               </a:rPr>
               <a:t>Pull request revisado</a:t>
             </a:r>
-            <a:endParaRPr lang="en-US" sz="1100" dirty="0"/>
+            <a:endParaRPr lang="en-US" sz="1050" dirty="0"/>
           </a:p>
           <a:p>
             <a:pPr indent="0" marL="0">
               <a:buNone/>
             </a:pPr>
             <a:r>
-              <a:rPr lang="en-US" sz="1100" dirty="0">
+              <a:rPr lang="en-US" sz="1050" dirty="0">
                 <a:solidFill>
                   <a:srgbClr val="CFE0EC"/>
                 </a:solidFill>
@@ -21574,14 +21648,14 @@
               </a:rPr>
               <a:t>github.com/davi-cassiano/Projeto-Varela/pull/15</a:t>
             </a:r>
-            <a:endParaRPr lang="en-US" sz="1100" dirty="0"/>
+            <a:endParaRPr lang="en-US" sz="1050" dirty="0"/>
           </a:p>
           <a:p>
             <a:pPr indent="0" marL="0">
               <a:buNone/>
             </a:pPr>
             <a:r>
-              <a:rPr lang="en-US" sz="1100" dirty="0">
+              <a:rPr lang="en-US" sz="1050" dirty="0">
                 <a:solidFill>
                   <a:srgbClr val="CFE0EC"/>
                 </a:solidFill>
@@ -21591,14 +21665,14 @@
               </a:rPr>
               <a:t> </a:t>
             </a:r>
-            <a:endParaRPr lang="en-US" sz="1100" dirty="0"/>
+            <a:endParaRPr lang="en-US" sz="1050" dirty="0"/>
           </a:p>
           <a:p>
             <a:pPr indent="0" marL="0">
               <a:buNone/>
             </a:pPr>
             <a:r>
-              <a:rPr lang="en-US" sz="1100" b="1" dirty="0">
+              <a:rPr lang="en-US" sz="1050" b="1" dirty="0">
                 <a:solidFill>
                   <a:srgbClr val="7FC4B4"/>
                 </a:solidFill>
@@ -21608,14 +21682,14 @@
               </a:rPr>
               <a:t>Backlog</a:t>
             </a:r>
-            <a:endParaRPr lang="en-US" sz="1100" dirty="0"/>
+            <a:endParaRPr lang="en-US" sz="1050" dirty="0"/>
           </a:p>
           <a:p>
             <a:pPr indent="0" marL="0">
               <a:buNone/>
             </a:pPr>
             <a:r>
-              <a:rPr lang="en-US" sz="1100" dirty="0">
+              <a:rPr lang="en-US" sz="1050" dirty="0">
                 <a:solidFill>
                   <a:srgbClr val="CFE0EC"/>
                 </a:solidFill>
@@ -21625,14 +21699,14 @@
               </a:rPr>
               <a:t>Issues #1 a #14 · quadro em</a:t>
             </a:r>
-            <a:endParaRPr lang="en-US" sz="1100" dirty="0"/>
+            <a:endParaRPr lang="en-US" sz="1050" dirty="0"/>
           </a:p>
           <a:p>
             <a:pPr indent="0" marL="0">
               <a:buNone/>
             </a:pPr>
             <a:r>
-              <a:rPr lang="en-US" sz="1100" dirty="0">
+              <a:rPr lang="en-US" sz="1050" dirty="0">
                 <a:solidFill>
                   <a:srgbClr val="CFE0EC"/>
                 </a:solidFill>
@@ -21642,14 +21716,14 @@
               </a:rPr>
               <a:t>github.com/users/davi-cassiano/projects/1</a:t>
             </a:r>
-            <a:endParaRPr lang="en-US" sz="1100" dirty="0"/>
+            <a:endParaRPr lang="en-US" sz="1050" dirty="0"/>
           </a:p>
           <a:p>
             <a:pPr indent="0" marL="0">
               <a:buNone/>
             </a:pPr>
             <a:r>
-              <a:rPr lang="en-US" sz="1100" dirty="0">
+              <a:rPr lang="en-US" sz="1050" dirty="0">
                 <a:solidFill>
                   <a:srgbClr val="CFE0EC"/>
                 </a:solidFill>
@@ -21659,14 +21733,14 @@
               </a:rPr>
               <a:t> </a:t>
             </a:r>
-            <a:endParaRPr lang="en-US" sz="1100" dirty="0"/>
+            <a:endParaRPr lang="en-US" sz="1050" dirty="0"/>
           </a:p>
           <a:p>
             <a:pPr indent="0" marL="0">
               <a:buNone/>
             </a:pPr>
             <a:r>
-              <a:rPr lang="en-US" sz="1100" b="1" dirty="0">
+              <a:rPr lang="en-US" sz="1050" b="1" dirty="0">
                 <a:solidFill>
                   <a:srgbClr val="7FC4B4"/>
                 </a:solidFill>
@@ -21676,14 +21750,14 @@
               </a:rPr>
               <a:t>Documentos</a:t>
             </a:r>
-            <a:endParaRPr lang="en-US" sz="1100" dirty="0"/>
+            <a:endParaRPr lang="en-US" sz="1050" dirty="0"/>
           </a:p>
           <a:p>
             <a:pPr indent="0" marL="0">
               <a:buNone/>
             </a:pPr>
             <a:r>
-              <a:rPr lang="en-US" sz="1100" dirty="0">
+              <a:rPr lang="en-US" sz="1050" dirty="0">
                 <a:solidFill>
                   <a:srgbClr val="CFE0EC"/>
                 </a:solidFill>
@@ -21693,7 +21767,58 @@
               </a:rPr>
               <a:t>docs/backlog.md · arquitetura.md · planejamento.md</a:t>
             </a:r>
-            <a:endParaRPr lang="en-US" sz="1100" dirty="0"/>
+            <a:endParaRPr lang="en-US" sz="1050" dirty="0"/>
+          </a:p>
+          <a:p>
+            <a:pPr indent="0" marL="0">
+              <a:buNone/>
+            </a:pPr>
+            <a:r>
+              <a:rPr lang="en-US" sz="1050" dirty="0">
+                <a:solidFill>
+                  <a:srgbClr val="CFE0EC"/>
+                </a:solidFill>
+                <a:latin typeface="Calibri" pitchFamily="34" charset="0"/>
+                <a:ea typeface="Calibri" pitchFamily="34" charset="-122"/>
+                <a:cs typeface="Calibri" pitchFamily="34" charset="-120"/>
+              </a:rPr>
+              <a:t> </a:t>
+            </a:r>
+            <a:endParaRPr lang="en-US" sz="1050" dirty="0"/>
+          </a:p>
+          <a:p>
+            <a:pPr indent="0" marL="0">
+              <a:buNone/>
+            </a:pPr>
+            <a:r>
+              <a:rPr lang="en-US" sz="1050" b="1" dirty="0">
+                <a:solidFill>
+                  <a:srgbClr val="7FC4B4"/>
+                </a:solidFill>
+                <a:latin typeface="Calibri" pitchFamily="34" charset="0"/>
+                <a:ea typeface="Calibri" pitchFamily="34" charset="-122"/>
+                <a:cs typeface="Calibri" pitchFamily="34" charset="-120"/>
+              </a:rPr>
+              <a:t>Notebook dos modelos (Google Colab)</a:t>
+            </a:r>
+            <a:endParaRPr lang="en-US" sz="1050" dirty="0"/>
+          </a:p>
+          <a:p>
+            <a:pPr indent="0" marL="0">
+              <a:buNone/>
+            </a:pPr>
+            <a:r>
+              <a:rPr lang="en-US" sz="1050" dirty="0">
+                <a:solidFill>
+                  <a:srgbClr val="CFE0EC"/>
+                </a:solidFill>
+                <a:latin typeface="Calibri" pitchFamily="34" charset="0"/>
+                <a:ea typeface="Calibri" pitchFamily="34" charset="-122"/>
+                <a:cs typeface="Calibri" pitchFamily="34" charset="-120"/>
+              </a:rPr>
+              <a:t>colab.research.google.com/github/davi-cassiano/Projeto-Varela/blob/main/notebooks/modelos.ipynb</a:t>
+            </a:r>
+            <a:endParaRPr lang="en-US" sz="1050" dirty="0"/>
           </a:p>
         </p:txBody>
       </p:sp>

</xml_diff>

<commit_message>
Adiciona notebook dos modelos executável no Google Colab (#24)
notebooks/modelos.ipynb reproduz o k-means das regionais (US01) e a
regressão Ridge do preço por estado (US11) com o mesmo código de src/,
a partir de dois recortes pequenos versionados em dados/colab/, e no fim
clona o repositório e roda os testes. O teste da US11 passa a usar esse
recorte quando a série bruta da ANP não está baixada. Link no README, no
docs/arquitetura.md e na apresentação.


Claude-Session: https://claude.ai/code/session_01AxsLnikbU4P6aghAswDkjm

Co-authored-by: Claude <noreply@anthropic.com>
</commit_message>
<xml_diff>
--- a/docs/apresentacao-checkpoint-4-6.pptx
+++ b/docs/apresentacao-checkpoint-4-6.pptx
@@ -1764,7 +1764,7 @@
               <a:t>QUEM: Victor · TEMPO: 1 min
 O QUE DIZER
 "Para fechar: as stories de interface da Onda 1 estão navegáveis no protótipo do checkpoint anterior, cada uma no lugar indicado aqui. Elas ficam abertas no quadro até a validação com um gerente real, que é a Sprint 2."
-Entregáveis: "Repositório, pull request 15 revisado e com merge, as 14 Issues com o quadro, e os três documentos: backlog, arquitetura e planejamento. Tudo público."
+Entregáveis: "Repositório, pull request 15 revisado e com merge, as 14 Issues com o quadro, os três documentos: backlog, arquitetura e planejamento, e um notebook no Google Colab que reproduz os dois modelos e roda os testes. Tudo público."
 Próximo passo: "Sprint 2 valida as stories de interface. A otimização da rota, US12, entra na Sprint 3."
 "Obrigado. Perguntas?"
 Se houver tempo e o professor pedir, abrir o protótipo e mostrar uma jornada: selecionar agências de uma regional, informar origem e período, gerar a rota e abrir o detalhe de um trecho. Dois minutos, no máximo.
@@ -3120,8 +3120,8 @@
         </p:nvSpPr>
         <p:spPr>
           <a:xfrm>
-            <a:off x="548640" y="4754880"/>
-            <a:ext cx="10515600" cy="1005840"/>
+            <a:off x="548640" y="4663440"/>
+            <a:ext cx="10972800" cy="1280160"/>
           </a:xfrm>
           <a:prstGeom prst="rect">
             <a:avLst/>
@@ -3240,6 +3240,43 @@
                 <a:cs typeface="Calibri" pitchFamily="34" charset="-120"/>
               </a:rPr>
               <a:t>Issues #1 a #14 · quadro em github.com/users/davi-cassiano/projects/1</a:t>
+            </a:r>
+            <a:endParaRPr lang="en-US" sz="1200" dirty="0"/>
+          </a:p>
+          <a:p>
+            <a:pPr indent="0" marL="0">
+              <a:spcAft>
+                <a:spcPts val="400"/>
+              </a:spcAft>
+              <a:buNone/>
+            </a:pPr>
+            <a:r>
+              <a:rPr lang="en-US" sz="1200" b="1" dirty="0">
+                <a:solidFill>
+                  <a:srgbClr val="7FC4B4"/>
+                </a:solidFill>
+                <a:latin typeface="Calibri" pitchFamily="34" charset="0"/>
+                <a:ea typeface="Calibri" pitchFamily="34" charset="-122"/>
+                <a:cs typeface="Calibri" pitchFamily="34" charset="-120"/>
+              </a:rPr>
+              <a:t>Notebook  </a:t>
+            </a:r>
+            <a:pPr indent="0" marL="0">
+              <a:spcAft>
+                <a:spcPts val="400"/>
+              </a:spcAft>
+              <a:buNone/>
+            </a:pPr>
+            <a:r>
+              <a:rPr lang="en-US" sz="1200" dirty="0">
+                <a:solidFill>
+                  <a:srgbClr val="CFE0EC"/>
+                </a:solidFill>
+                <a:latin typeface="Calibri" pitchFamily="34" charset="0"/>
+                <a:ea typeface="Calibri" pitchFamily="34" charset="-122"/>
+                <a:cs typeface="Calibri" pitchFamily="34" charset="-120"/>
+              </a:rPr>
+              <a:t>colab.research.google.com/github/davi-cassiano/Projeto-Varela/blob/main/notebooks/modelos.ipynb</a:t>
             </a:r>
             <a:endParaRPr lang="en-US" sz="1200" dirty="0"/>
           </a:p>
@@ -8285,8 +8322,8 @@
         </p:nvSpPr>
         <p:spPr>
           <a:xfrm>
-            <a:off x="548640" y="5029200"/>
-            <a:ext cx="11064240" cy="1371600"/>
+            <a:off x="548640" y="4983480"/>
+            <a:ext cx="11064240" cy="1463040"/>
           </a:xfrm>
           <a:prstGeom prst="rect">
             <a:avLst/>
@@ -8300,12 +8337,12 @@
           <a:p>
             <a:pPr indent="0" marL="0">
               <a:spcAft>
-                <a:spcPts val="400"/>
+                <a:spcPts val="300"/>
               </a:spcAft>
               <a:buNone/>
             </a:pPr>
             <a:r>
-              <a:rPr lang="en-US" sz="1150" b="1" dirty="0">
+              <a:rPr lang="en-US" sz="1100" b="1" dirty="0">
                 <a:solidFill>
                   <a:srgbClr val="12263A"/>
                 </a:solidFill>
@@ -8317,12 +8354,12 @@
             </a:r>
             <a:pPr indent="0" marL="0">
               <a:spcAft>
-                <a:spcPts val="400"/>
+                <a:spcPts val="300"/>
               </a:spcAft>
               <a:buNone/>
             </a:pPr>
             <a:r>
-              <a:rPr lang="en-US" sz="1150" dirty="0">
+              <a:rPr lang="en-US" sz="1100" dirty="0">
                 <a:solidFill>
                   <a:srgbClr val="5A7185"/>
                 </a:solidFill>
@@ -8332,17 +8369,17 @@
               </a:rPr>
               <a:t>o treino vai até dez/2019 e o teste começa em jan/2020. Embaralhar deixaria o modelo ver semanas futuras e inflaria o resultado.</a:t>
             </a:r>
-            <a:endParaRPr lang="en-US" sz="1150" dirty="0"/>
+            <a:endParaRPr lang="en-US" sz="1100" dirty="0"/>
           </a:p>
           <a:p>
             <a:pPr indent="0" marL="0">
               <a:spcAft>
-                <a:spcPts val="400"/>
+                <a:spcPts val="300"/>
               </a:spcAft>
               <a:buNone/>
             </a:pPr>
             <a:r>
-              <a:rPr lang="en-US" sz="1150" b="1" dirty="0">
+              <a:rPr lang="en-US" sz="1100" b="1" dirty="0">
                 <a:solidFill>
                   <a:srgbClr val="12263A"/>
                 </a:solidFill>
@@ -8354,12 +8391,12 @@
             </a:r>
             <a:pPr indent="0" marL="0">
               <a:spcAft>
-                <a:spcPts val="400"/>
+                <a:spcPts val="300"/>
               </a:spcAft>
               <a:buNone/>
             </a:pPr>
             <a:r>
-              <a:rPr lang="en-US" sz="1150" dirty="0">
+              <a:rPr lang="en-US" sz="1100" dirty="0">
                 <a:solidFill>
                   <a:srgbClr val="5A7185"/>
                 </a:solidFill>
@@ -8369,17 +8406,17 @@
               </a:rPr>
               <a:t>o erro sobe no choque de preços da pandemia e chega ao pico em out/2020 — o princípio CACE da Aula 4 aparecendo nos dados.</a:t>
             </a:r>
-            <a:endParaRPr lang="en-US" sz="1150" dirty="0"/>
+            <a:endParaRPr lang="en-US" sz="1100" dirty="0"/>
           </a:p>
           <a:p>
             <a:pPr indent="0" marL="0">
               <a:spcAft>
-                <a:spcPts val="400"/>
+                <a:spcPts val="300"/>
               </a:spcAft>
               <a:buNone/>
             </a:pPr>
             <a:r>
-              <a:rPr lang="en-US" sz="1150" b="1" dirty="0">
+              <a:rPr lang="en-US" sz="1100" b="1" dirty="0">
                 <a:solidFill>
                   <a:srgbClr val="9A5B12"/>
                 </a:solidFill>
@@ -8391,12 +8428,12 @@
             </a:r>
             <a:pPr indent="0" marL="0">
               <a:spcAft>
-                <a:spcPts val="400"/>
+                <a:spcPts val="300"/>
               </a:spcAft>
               <a:buNone/>
             </a:pPr>
             <a:r>
-              <a:rPr lang="en-US" sz="1150" dirty="0">
+              <a:rPr lang="en-US" sz="1100" dirty="0">
                 <a:solidFill>
                   <a:srgbClr val="5A7185"/>
                 </a:solidFill>
@@ -8406,7 +8443,44 @@
               </a:rPr>
               <a:t>a série acaba em 2021; o produto aplica a diferença de cada estado sobre o preço nacional atual.</a:t>
             </a:r>
-            <a:endParaRPr lang="en-US" sz="1150" dirty="0"/>
+            <a:endParaRPr lang="en-US" sz="1100" dirty="0"/>
+          </a:p>
+          <a:p>
+            <a:pPr indent="0" marL="0">
+              <a:spcAft>
+                <a:spcPts val="300"/>
+              </a:spcAft>
+              <a:buNone/>
+            </a:pPr>
+            <a:r>
+              <a:rPr lang="en-US" sz="1100" b="1" dirty="0">
+                <a:solidFill>
+                  <a:srgbClr val="0E7C66"/>
+                </a:solidFill>
+                <a:latin typeface="Calibri" pitchFamily="34" charset="0"/>
+                <a:ea typeface="Calibri" pitchFamily="34" charset="-122"/>
+                <a:cs typeface="Calibri" pitchFamily="34" charset="-120"/>
+              </a:rPr>
+              <a:t>Reproduzir: </a:t>
+            </a:r>
+            <a:pPr indent="0" marL="0">
+              <a:spcAft>
+                <a:spcPts val="300"/>
+              </a:spcAft>
+              <a:buNone/>
+            </a:pPr>
+            <a:r>
+              <a:rPr lang="en-US" sz="1100" dirty="0">
+                <a:solidFill>
+                  <a:srgbClr val="5A7185"/>
+                </a:solidFill>
+                <a:latin typeface="Calibri" pitchFamily="34" charset="0"/>
+                <a:ea typeface="Calibri" pitchFamily="34" charset="-122"/>
+                <a:cs typeface="Calibri" pitchFamily="34" charset="-120"/>
+              </a:rPr>
+              <a:t>k-means e regressão rodam no Google Colab, com os mesmos dados e testes — colab.research.google.com/github/davi-cassiano/Projeto-Varela/blob/main/notebooks/modelos.ipynb</a:t>
+            </a:r>
+            <a:endParaRPr lang="en-US" sz="1100" dirty="0"/>
           </a:p>
         </p:txBody>
       </p:sp>
@@ -21479,8 +21553,8 @@
         </p:nvSpPr>
         <p:spPr>
           <a:xfrm>
-            <a:off x="7818120" y="2240280"/>
-            <a:ext cx="3657600" cy="2926080"/>
+            <a:off x="7818120" y="2194560"/>
+            <a:ext cx="3657600" cy="3017520"/>
           </a:xfrm>
           <a:prstGeom prst="rect">
             <a:avLst/>
@@ -21496,7 +21570,7 @@
               <a:buNone/>
             </a:pPr>
             <a:r>
-              <a:rPr lang="en-US" sz="1100" b="1" dirty="0">
+              <a:rPr lang="en-US" sz="1050" b="1" dirty="0">
                 <a:solidFill>
                   <a:srgbClr val="7FC4B4"/>
                 </a:solidFill>
@@ -21506,14 +21580,14 @@
               </a:rPr>
               <a:t>Repositório</a:t>
             </a:r>
-            <a:endParaRPr lang="en-US" sz="1100" dirty="0"/>
+            <a:endParaRPr lang="en-US" sz="1050" dirty="0"/>
           </a:p>
           <a:p>
             <a:pPr indent="0" marL="0">
               <a:buNone/>
             </a:pPr>
             <a:r>
-              <a:rPr lang="en-US" sz="1100" dirty="0">
+              <a:rPr lang="en-US" sz="1050" dirty="0">
                 <a:solidFill>
                   <a:srgbClr val="CFE0EC"/>
                 </a:solidFill>
@@ -21523,14 +21597,14 @@
               </a:rPr>
               <a:t>github.com/davi-cassiano/Projeto-Varela</a:t>
             </a:r>
-            <a:endParaRPr lang="en-US" sz="1100" dirty="0"/>
+            <a:endParaRPr lang="en-US" sz="1050" dirty="0"/>
           </a:p>
           <a:p>
             <a:pPr indent="0" marL="0">
               <a:buNone/>
             </a:pPr>
             <a:r>
-              <a:rPr lang="en-US" sz="1100" dirty="0">
+              <a:rPr lang="en-US" sz="1050" dirty="0">
                 <a:solidFill>
                   <a:srgbClr val="CFE0EC"/>
                 </a:solidFill>
@@ -21540,14 +21614,14 @@
               </a:rPr>
               <a:t> </a:t>
             </a:r>
-            <a:endParaRPr lang="en-US" sz="1100" dirty="0"/>
+            <a:endParaRPr lang="en-US" sz="1050" dirty="0"/>
           </a:p>
           <a:p>
             <a:pPr indent="0" marL="0">
               <a:buNone/>
             </a:pPr>
             <a:r>
-              <a:rPr lang="en-US" sz="1100" b="1" dirty="0">
+              <a:rPr lang="en-US" sz="1050" b="1" dirty="0">
                 <a:solidFill>
                   <a:srgbClr val="7FC4B4"/>
                 </a:solidFill>
@@ -21557,14 +21631,14 @@
               </a:rPr>
               <a:t>Pull request revisado</a:t>
             </a:r>
-            <a:endParaRPr lang="en-US" sz="1100" dirty="0"/>
+            <a:endParaRPr lang="en-US" sz="1050" dirty="0"/>
           </a:p>
           <a:p>
             <a:pPr indent="0" marL="0">
               <a:buNone/>
             </a:pPr>
             <a:r>
-              <a:rPr lang="en-US" sz="1100" dirty="0">
+              <a:rPr lang="en-US" sz="1050" dirty="0">
                 <a:solidFill>
                   <a:srgbClr val="CFE0EC"/>
                 </a:solidFill>
@@ -21574,14 +21648,14 @@
               </a:rPr>
               <a:t>github.com/davi-cassiano/Projeto-Varela/pull/15</a:t>
             </a:r>
-            <a:endParaRPr lang="en-US" sz="1100" dirty="0"/>
+            <a:endParaRPr lang="en-US" sz="1050" dirty="0"/>
           </a:p>
           <a:p>
             <a:pPr indent="0" marL="0">
               <a:buNone/>
             </a:pPr>
             <a:r>
-              <a:rPr lang="en-US" sz="1100" dirty="0">
+              <a:rPr lang="en-US" sz="1050" dirty="0">
                 <a:solidFill>
                   <a:srgbClr val="CFE0EC"/>
                 </a:solidFill>
@@ -21591,14 +21665,14 @@
               </a:rPr>
               <a:t> </a:t>
             </a:r>
-            <a:endParaRPr lang="en-US" sz="1100" dirty="0"/>
+            <a:endParaRPr lang="en-US" sz="1050" dirty="0"/>
           </a:p>
           <a:p>
             <a:pPr indent="0" marL="0">
               <a:buNone/>
             </a:pPr>
             <a:r>
-              <a:rPr lang="en-US" sz="1100" b="1" dirty="0">
+              <a:rPr lang="en-US" sz="1050" b="1" dirty="0">
                 <a:solidFill>
                   <a:srgbClr val="7FC4B4"/>
                 </a:solidFill>
@@ -21608,14 +21682,14 @@
               </a:rPr>
               <a:t>Backlog</a:t>
             </a:r>
-            <a:endParaRPr lang="en-US" sz="1100" dirty="0"/>
+            <a:endParaRPr lang="en-US" sz="1050" dirty="0"/>
           </a:p>
           <a:p>
             <a:pPr indent="0" marL="0">
               <a:buNone/>
             </a:pPr>
             <a:r>
-              <a:rPr lang="en-US" sz="1100" dirty="0">
+              <a:rPr lang="en-US" sz="1050" dirty="0">
                 <a:solidFill>
                   <a:srgbClr val="CFE0EC"/>
                 </a:solidFill>
@@ -21625,14 +21699,14 @@
               </a:rPr>
               <a:t>Issues #1 a #14 · quadro em</a:t>
             </a:r>
-            <a:endParaRPr lang="en-US" sz="1100" dirty="0"/>
+            <a:endParaRPr lang="en-US" sz="1050" dirty="0"/>
           </a:p>
           <a:p>
             <a:pPr indent="0" marL="0">
               <a:buNone/>
             </a:pPr>
             <a:r>
-              <a:rPr lang="en-US" sz="1100" dirty="0">
+              <a:rPr lang="en-US" sz="1050" dirty="0">
                 <a:solidFill>
                   <a:srgbClr val="CFE0EC"/>
                 </a:solidFill>
@@ -21642,14 +21716,14 @@
               </a:rPr>
               <a:t>github.com/users/davi-cassiano/projects/1</a:t>
             </a:r>
-            <a:endParaRPr lang="en-US" sz="1100" dirty="0"/>
+            <a:endParaRPr lang="en-US" sz="1050" dirty="0"/>
           </a:p>
           <a:p>
             <a:pPr indent="0" marL="0">
               <a:buNone/>
             </a:pPr>
             <a:r>
-              <a:rPr lang="en-US" sz="1100" dirty="0">
+              <a:rPr lang="en-US" sz="1050" dirty="0">
                 <a:solidFill>
                   <a:srgbClr val="CFE0EC"/>
                 </a:solidFill>
@@ -21659,14 +21733,14 @@
               </a:rPr>
               <a:t> </a:t>
             </a:r>
-            <a:endParaRPr lang="en-US" sz="1100" dirty="0"/>
+            <a:endParaRPr lang="en-US" sz="1050" dirty="0"/>
           </a:p>
           <a:p>
             <a:pPr indent="0" marL="0">
               <a:buNone/>
             </a:pPr>
             <a:r>
-              <a:rPr lang="en-US" sz="1100" b="1" dirty="0">
+              <a:rPr lang="en-US" sz="1050" b="1" dirty="0">
                 <a:solidFill>
                   <a:srgbClr val="7FC4B4"/>
                 </a:solidFill>
@@ -21676,14 +21750,14 @@
               </a:rPr>
               <a:t>Documentos</a:t>
             </a:r>
-            <a:endParaRPr lang="en-US" sz="1100" dirty="0"/>
+            <a:endParaRPr lang="en-US" sz="1050" dirty="0"/>
           </a:p>
           <a:p>
             <a:pPr indent="0" marL="0">
               <a:buNone/>
             </a:pPr>
             <a:r>
-              <a:rPr lang="en-US" sz="1100" dirty="0">
+              <a:rPr lang="en-US" sz="1050" dirty="0">
                 <a:solidFill>
                   <a:srgbClr val="CFE0EC"/>
                 </a:solidFill>
@@ -21693,7 +21767,58 @@
               </a:rPr>
               <a:t>docs/backlog.md · arquitetura.md · planejamento.md</a:t>
             </a:r>
-            <a:endParaRPr lang="en-US" sz="1100" dirty="0"/>
+            <a:endParaRPr lang="en-US" sz="1050" dirty="0"/>
+          </a:p>
+          <a:p>
+            <a:pPr indent="0" marL="0">
+              <a:buNone/>
+            </a:pPr>
+            <a:r>
+              <a:rPr lang="en-US" sz="1050" dirty="0">
+                <a:solidFill>
+                  <a:srgbClr val="CFE0EC"/>
+                </a:solidFill>
+                <a:latin typeface="Calibri" pitchFamily="34" charset="0"/>
+                <a:ea typeface="Calibri" pitchFamily="34" charset="-122"/>
+                <a:cs typeface="Calibri" pitchFamily="34" charset="-120"/>
+              </a:rPr>
+              <a:t> </a:t>
+            </a:r>
+            <a:endParaRPr lang="en-US" sz="1050" dirty="0"/>
+          </a:p>
+          <a:p>
+            <a:pPr indent="0" marL="0">
+              <a:buNone/>
+            </a:pPr>
+            <a:r>
+              <a:rPr lang="en-US" sz="1050" b="1" dirty="0">
+                <a:solidFill>
+                  <a:srgbClr val="7FC4B4"/>
+                </a:solidFill>
+                <a:latin typeface="Calibri" pitchFamily="34" charset="0"/>
+                <a:ea typeface="Calibri" pitchFamily="34" charset="-122"/>
+                <a:cs typeface="Calibri" pitchFamily="34" charset="-120"/>
+              </a:rPr>
+              <a:t>Notebook dos modelos (Google Colab)</a:t>
+            </a:r>
+            <a:endParaRPr lang="en-US" sz="1050" dirty="0"/>
+          </a:p>
+          <a:p>
+            <a:pPr indent="0" marL="0">
+              <a:buNone/>
+            </a:pPr>
+            <a:r>
+              <a:rPr lang="en-US" sz="1050" dirty="0">
+                <a:solidFill>
+                  <a:srgbClr val="CFE0EC"/>
+                </a:solidFill>
+                <a:latin typeface="Calibri" pitchFamily="34" charset="0"/>
+                <a:ea typeface="Calibri" pitchFamily="34" charset="-122"/>
+                <a:cs typeface="Calibri" pitchFamily="34" charset="-120"/>
+              </a:rPr>
+              <a:t>colab.research.google.com/github/davi-cassiano/Projeto-Varela/blob/main/notebooks/modelos.ipynb</a:t>
+            </a:r>
+            <a:endParaRPr lang="en-US" sz="1050" dirty="0"/>
           </a:p>
         </p:txBody>
       </p:sp>

</xml_diff>